<commit_message>
Remove anomaly health and inner voice systems
</commit_message>
<xml_diff>
--- a/PROJECT_LIMEN_GAME_DESIGN.pptx
+++ b/PROJECT_LIMEN_GAME_DESIGN.pptx
@@ -2,30 +2,30 @@
 <file path=ppt/presentation.xml><?xml version="1.0" encoding="utf-8"?>
 <p:presentation xmlns:p="http://schemas.openxmlformats.org/presentationml/2006/main">
   <p:sldMasterIdLst>
-    <p:sldMasterId xmlns:r="http://schemas.openxmlformats.org/officeDocument/2006/relationships" id="2147483648" r:id="Rcd3010f36bab41e2"/>
+    <p:sldMasterId xmlns:r="http://schemas.openxmlformats.org/officeDocument/2006/relationships" id="2147483648" r:id="Re8acb68211344b78"/>
   </p:sldMasterIdLst>
   <p:notesMasterIdLst>
-    <p:notesMasterId xmlns:r="http://schemas.openxmlformats.org/officeDocument/2006/relationships" r:id="Rbb7f17ca2b3b4e6d"/>
+    <p:notesMasterId xmlns:r="http://schemas.openxmlformats.org/officeDocument/2006/relationships" r:id="R26d439045ff14086"/>
   </p:notesMasterIdLst>
   <p:sldIdLst>
-    <p:sldId xmlns:r="http://schemas.openxmlformats.org/officeDocument/2006/relationships" id="256" r:id="R4a2929ee55ee48ff"/>
-    <p:sldId xmlns:r="http://schemas.openxmlformats.org/officeDocument/2006/relationships" id="257" r:id="Rf79ebfa140b94915"/>
-    <p:sldId xmlns:r="http://schemas.openxmlformats.org/officeDocument/2006/relationships" id="258" r:id="R29ffa02d2d124c3e"/>
-    <p:sldId xmlns:r="http://schemas.openxmlformats.org/officeDocument/2006/relationships" id="259" r:id="R4956e7b9e9a1475f"/>
-    <p:sldId xmlns:r="http://schemas.openxmlformats.org/officeDocument/2006/relationships" id="260" r:id="R18ae4eabdd5840e2"/>
-    <p:sldId xmlns:r="http://schemas.openxmlformats.org/officeDocument/2006/relationships" id="261" r:id="Rc6e9a72bc3644fb8"/>
-    <p:sldId xmlns:r="http://schemas.openxmlformats.org/officeDocument/2006/relationships" id="262" r:id="R4d72d4c814564453"/>
-    <p:sldId xmlns:r="http://schemas.openxmlformats.org/officeDocument/2006/relationships" id="263" r:id="R964e428122bd4736"/>
-    <p:sldId xmlns:r="http://schemas.openxmlformats.org/officeDocument/2006/relationships" id="264" r:id="R8390d6f6e67846b0"/>
-    <p:sldId xmlns:r="http://schemas.openxmlformats.org/officeDocument/2006/relationships" id="265" r:id="R8df0dadfe1dc49b5"/>
-    <p:sldId xmlns:r="http://schemas.openxmlformats.org/officeDocument/2006/relationships" id="266" r:id="Rbf57512a986644f5"/>
-    <p:sldId xmlns:r="http://schemas.openxmlformats.org/officeDocument/2006/relationships" id="267" r:id="R2c5a89f90b984883"/>
-    <p:sldId xmlns:r="http://schemas.openxmlformats.org/officeDocument/2006/relationships" id="268" r:id="R8d92f5c475454086"/>
-    <p:sldId xmlns:r="http://schemas.openxmlformats.org/officeDocument/2006/relationships" id="269" r:id="R050f5a66c5194c0a"/>
-    <p:sldId xmlns:r="http://schemas.openxmlformats.org/officeDocument/2006/relationships" id="270" r:id="Rf41767f1e2d04d2e"/>
-    <p:sldId xmlns:r="http://schemas.openxmlformats.org/officeDocument/2006/relationships" id="271" r:id="R6331300e5e3a46e9"/>
-    <p:sldId xmlns:r="http://schemas.openxmlformats.org/officeDocument/2006/relationships" id="272" r:id="R3c582f6968d047cf"/>
-    <p:sldId xmlns:r="http://schemas.openxmlformats.org/officeDocument/2006/relationships" id="273" r:id="R4fe6bf3bd6de4a96"/>
+    <p:sldId xmlns:r="http://schemas.openxmlformats.org/officeDocument/2006/relationships" id="256" r:id="Ree87dbd0fb584fb2"/>
+    <p:sldId xmlns:r="http://schemas.openxmlformats.org/officeDocument/2006/relationships" id="257" r:id="R58b683d3b2d244be"/>
+    <p:sldId xmlns:r="http://schemas.openxmlformats.org/officeDocument/2006/relationships" id="258" r:id="R9e52eeef6506403e"/>
+    <p:sldId xmlns:r="http://schemas.openxmlformats.org/officeDocument/2006/relationships" id="259" r:id="Rd1fa7124490b48b6"/>
+    <p:sldId xmlns:r="http://schemas.openxmlformats.org/officeDocument/2006/relationships" id="260" r:id="R3810b75ac5ce4283"/>
+    <p:sldId xmlns:r="http://schemas.openxmlformats.org/officeDocument/2006/relationships" id="261" r:id="R7f66998cacb8491f"/>
+    <p:sldId xmlns:r="http://schemas.openxmlformats.org/officeDocument/2006/relationships" id="262" r:id="R715c9fd1f11b4d33"/>
+    <p:sldId xmlns:r="http://schemas.openxmlformats.org/officeDocument/2006/relationships" id="263" r:id="R90263a305979416a"/>
+    <p:sldId xmlns:r="http://schemas.openxmlformats.org/officeDocument/2006/relationships" id="264" r:id="R5becf8b0df234362"/>
+    <p:sldId xmlns:r="http://schemas.openxmlformats.org/officeDocument/2006/relationships" id="265" r:id="R1aa4e942720a4d2a"/>
+    <p:sldId xmlns:r="http://schemas.openxmlformats.org/officeDocument/2006/relationships" id="266" r:id="R3c18d44aabb7484c"/>
+    <p:sldId xmlns:r="http://schemas.openxmlformats.org/officeDocument/2006/relationships" id="267" r:id="R87daff43d47a4766"/>
+    <p:sldId xmlns:r="http://schemas.openxmlformats.org/officeDocument/2006/relationships" id="268" r:id="R380a4e870dfe4b9e"/>
+    <p:sldId xmlns:r="http://schemas.openxmlformats.org/officeDocument/2006/relationships" id="269" r:id="R5df8ec93944a452d"/>
+    <p:sldId xmlns:r="http://schemas.openxmlformats.org/officeDocument/2006/relationships" id="270" r:id="R133109a80a0a4cd9"/>
+    <p:sldId xmlns:r="http://schemas.openxmlformats.org/officeDocument/2006/relationships" id="271" r:id="R11faae5e0c574399"/>
+    <p:sldId xmlns:r="http://schemas.openxmlformats.org/officeDocument/2006/relationships" id="272" r:id="Rd523875f9bb24085"/>
+    <p:sldId xmlns:r="http://schemas.openxmlformats.org/officeDocument/2006/relationships" id="273" r:id="R1b98732ccf4e4bdd"/>
   </p:sldIdLst>
   <p:sldSz cx="12192000" cy="6858000"/>
   <p:notesSz cx="6858000" cy="9144000"/>
@@ -1624,7 +1624,7 @@
           <p:cNvPr id="3" name="Title">
             <a:extLst xmlns:a="http://schemas.openxmlformats.org/drawingml/2006/main">
               <a:ext uri="{FF2B5EF4-FFF2-40B4-BE49-F238E27FC236}">
-                <a16:creationId xmlns:a16="http://schemas.microsoft.com/office/drawing/2014/main" id="{5586CE22-D581-477B-A743-8CEBEF2C5FB0}"/>
+                <a16:creationId xmlns:a16="http://schemas.microsoft.com/office/drawing/2014/main" id="{89B32B43-8C39-4716-91BB-F3AB6E43BCF2}"/>
               </a:ext>
             </a:extLst>
           </p:cNvPr>
@@ -1853,7 +1853,7 @@
           <p:cNvPr id="2" name="Subtitle">
             <a:extLst xmlns:a="http://schemas.openxmlformats.org/drawingml/2006/main">
               <a:ext uri="{FF2B5EF4-FFF2-40B4-BE49-F238E27FC236}">
-                <a16:creationId xmlns:a16="http://schemas.microsoft.com/office/drawing/2014/main" id="{BFB4528C-C1B7-487B-AFBE-068521F0FAD2}"/>
+                <a16:creationId xmlns:a16="http://schemas.microsoft.com/office/drawing/2014/main" id="{DC27BF40-BFE0-4BE5-843C-7ABD27662461}"/>
               </a:ext>
             </a:extLst>
           </p:cNvPr>
@@ -2099,7 +2099,7 @@
           <p:cNvPr id="2" name="Section title">
             <a:extLst xmlns:a="http://schemas.openxmlformats.org/drawingml/2006/main">
               <a:ext uri="{FF2B5EF4-FFF2-40B4-BE49-F238E27FC236}">
-                <a16:creationId xmlns:a16="http://schemas.microsoft.com/office/drawing/2014/main" id="{BDF78D1E-F71E-46B4-A25D-FBF7ECB3F791}"/>
+                <a16:creationId xmlns:a16="http://schemas.microsoft.com/office/drawing/2014/main" id="{07C9A05B-7EF0-4109-888F-A921DD8EDBEB}"/>
               </a:ext>
             </a:extLst>
           </p:cNvPr>
@@ -2345,7 +2345,7 @@
           <p:cNvPr id="3" name="Title">
             <a:extLst xmlns:a="http://schemas.openxmlformats.org/drawingml/2006/main">
               <a:ext uri="{FF2B5EF4-FFF2-40B4-BE49-F238E27FC236}">
-                <a16:creationId xmlns:a16="http://schemas.microsoft.com/office/drawing/2014/main" id="{32A4CFF5-010A-4C06-88F4-DE7C60FB3B64}"/>
+                <a16:creationId xmlns:a16="http://schemas.microsoft.com/office/drawing/2014/main" id="{4EA6059B-0F6E-40E8-AA7E-3D0991765FEF}"/>
               </a:ext>
             </a:extLst>
           </p:cNvPr>
@@ -2574,7 +2574,7 @@
           <p:cNvPr id="2" name="Body">
             <a:extLst xmlns:a="http://schemas.openxmlformats.org/drawingml/2006/main">
               <a:ext uri="{FF2B5EF4-FFF2-40B4-BE49-F238E27FC236}">
-                <a16:creationId xmlns:a16="http://schemas.microsoft.com/office/drawing/2014/main" id="{42342A11-EA30-4E70-AF96-421B00C3C025}"/>
+                <a16:creationId xmlns:a16="http://schemas.microsoft.com/office/drawing/2014/main" id="{7A0149BD-190A-42E2-BF22-4999D29DD3CE}"/>
               </a:ext>
             </a:extLst>
           </p:cNvPr>
@@ -2820,7 +2820,7 @@
           <p:cNvPr id="4" name="Title">
             <a:extLst xmlns:a="http://schemas.openxmlformats.org/drawingml/2006/main">
               <a:ext uri="{FF2B5EF4-FFF2-40B4-BE49-F238E27FC236}">
-                <a16:creationId xmlns:a16="http://schemas.microsoft.com/office/drawing/2014/main" id="{73D2EB36-7679-4C52-AF52-1BEDDE6FFB8B}"/>
+                <a16:creationId xmlns:a16="http://schemas.microsoft.com/office/drawing/2014/main" id="{9DB971D9-27F0-4DA0-A2C2-6915BFA53EB1}"/>
               </a:ext>
             </a:extLst>
           </p:cNvPr>
@@ -3049,7 +3049,7 @@
           <p:cNvPr id="2" name="Left column">
             <a:extLst xmlns:a="http://schemas.openxmlformats.org/drawingml/2006/main">
               <a:ext uri="{FF2B5EF4-FFF2-40B4-BE49-F238E27FC236}">
-                <a16:creationId xmlns:a16="http://schemas.microsoft.com/office/drawing/2014/main" id="{0FD065DF-19B0-4BDA-BDC6-FC96E39B13FF}"/>
+                <a16:creationId xmlns:a16="http://schemas.microsoft.com/office/drawing/2014/main" id="{3F15A6ED-C805-4CDC-9FE9-8C8092067014}"/>
               </a:ext>
             </a:extLst>
           </p:cNvPr>
@@ -3278,7 +3278,7 @@
           <p:cNvPr id="3" name="Right column">
             <a:extLst xmlns:a="http://schemas.openxmlformats.org/drawingml/2006/main">
               <a:ext uri="{FF2B5EF4-FFF2-40B4-BE49-F238E27FC236}">
-                <a16:creationId xmlns:a16="http://schemas.microsoft.com/office/drawing/2014/main" id="{0A34A990-5690-4E38-9D9F-D5CB9E791E47}"/>
+                <a16:creationId xmlns:a16="http://schemas.microsoft.com/office/drawing/2014/main" id="{F2CDF0D0-FB21-44E4-A8F2-B0E4EC568BEE}"/>
               </a:ext>
             </a:extLst>
           </p:cNvPr>
@@ -3524,7 +3524,7 @@
           <p:cNvPr id="3" name="Title">
             <a:extLst xmlns:a="http://schemas.openxmlformats.org/drawingml/2006/main">
               <a:ext uri="{FF2B5EF4-FFF2-40B4-BE49-F238E27FC236}">
-                <a16:creationId xmlns:a16="http://schemas.microsoft.com/office/drawing/2014/main" id="{DA265943-465B-48A9-B5D9-CFEB3DDA4499}"/>
+                <a16:creationId xmlns:a16="http://schemas.microsoft.com/office/drawing/2014/main" id="{FA11E864-2DEF-4519-BA00-F592BCB40DAF}"/>
               </a:ext>
             </a:extLst>
           </p:cNvPr>
@@ -3753,7 +3753,7 @@
           <p:cNvPr id="2" name="Left column">
             <a:extLst xmlns:a="http://schemas.openxmlformats.org/drawingml/2006/main">
               <a:ext uri="{FF2B5EF4-FFF2-40B4-BE49-F238E27FC236}">
-                <a16:creationId xmlns:a16="http://schemas.microsoft.com/office/drawing/2014/main" id="{17EC1275-B8E5-40B4-AA65-770C3868EF4D}"/>
+                <a16:creationId xmlns:a16="http://schemas.microsoft.com/office/drawing/2014/main" id="{053F6293-2E98-4FA3-8038-E8584F957A9A}"/>
               </a:ext>
             </a:extLst>
           </p:cNvPr>
@@ -4020,12 +4020,12 @@
   </p:cSld>
   <p:clrMap bg1="lt1" tx1="dk1" bg2="lt2" tx2="dk2" accent1="accent1" accent2="accent2" accent3="accent3" accent4="accent4" accent5="accent5" accent6="accent6" hlink="hlink" folHlink="folHlink"/>
   <p:sldLayoutIdLst>
-    <p:sldLayoutId xmlns:r="http://schemas.openxmlformats.org/officeDocument/2006/relationships" id="2147483649" r:id="R04d4083405ce46b6"/>
-    <p:sldLayoutId xmlns:r="http://schemas.openxmlformats.org/officeDocument/2006/relationships" id="2147483650" r:id="Re1f40e23dfb84463"/>
-    <p:sldLayoutId xmlns:r="http://schemas.openxmlformats.org/officeDocument/2006/relationships" id="2147483651" r:id="R06e9da071bfa4f65"/>
-    <p:sldLayoutId xmlns:r="http://schemas.openxmlformats.org/officeDocument/2006/relationships" id="2147483652" r:id="Rbba0a28d9bd54e64"/>
-    <p:sldLayoutId xmlns:r="http://schemas.openxmlformats.org/officeDocument/2006/relationships" id="2147483653" r:id="R07e0d642e27d438a"/>
-    <p:sldLayoutId xmlns:r="http://schemas.openxmlformats.org/officeDocument/2006/relationships" id="2147483654" r:id="R5d096a1279974b53"/>
+    <p:sldLayoutId xmlns:r="http://schemas.openxmlformats.org/officeDocument/2006/relationships" id="2147483649" r:id="Rdecfb848e58d426c"/>
+    <p:sldLayoutId xmlns:r="http://schemas.openxmlformats.org/officeDocument/2006/relationships" id="2147483650" r:id="R565dd447102b470d"/>
+    <p:sldLayoutId xmlns:r="http://schemas.openxmlformats.org/officeDocument/2006/relationships" id="2147483651" r:id="R85618a0c8b484680"/>
+    <p:sldLayoutId xmlns:r="http://schemas.openxmlformats.org/officeDocument/2006/relationships" id="2147483652" r:id="R1c2155958ba64fa2"/>
+    <p:sldLayoutId xmlns:r="http://schemas.openxmlformats.org/officeDocument/2006/relationships" id="2147483653" r:id="R47db83498214485b"/>
+    <p:sldLayoutId xmlns:r="http://schemas.openxmlformats.org/officeDocument/2006/relationships" id="2147483654" r:id="Rba8e04ab427c447d"/>
   </p:sldLayoutIdLst>
   <p:txStyles>
     <p:titleStyle>
@@ -4576,7 +4576,7 @@
           <p:cNvPr id="8" name="">
             <a:extLst xmlns:a="http://schemas.openxmlformats.org/drawingml/2006/main">
               <a:ext uri="{FF2B5EF4-FFF2-40B4-BE49-F238E27FC236}">
-                <a16:creationId xmlns:a16="http://schemas.microsoft.com/office/drawing/2014/main" id="{7926109E-C3B0-4BDE-8EFE-E65A7A230DD2}"/>
+                <a16:creationId xmlns:a16="http://schemas.microsoft.com/office/drawing/2014/main" id="{24E0700E-120B-4975-B063-F33CF13D733F}"/>
               </a:ext>
             </a:extLst>
           </p:cNvPr>
@@ -4607,7 +4607,7 @@
           <p:cNvPr id="2" name="">
             <a:extLst xmlns:a="http://schemas.openxmlformats.org/drawingml/2006/main">
               <a:ext uri="{FF2B5EF4-FFF2-40B4-BE49-F238E27FC236}">
-                <a16:creationId xmlns:a16="http://schemas.microsoft.com/office/drawing/2014/main" id="{E53908EF-CB96-4117-BA39-856F81F31BDE}"/>
+                <a16:creationId xmlns:a16="http://schemas.microsoft.com/office/drawing/2014/main" id="{FD2FA4F9-89D1-474B-ABDC-E6D453FB3B64}"/>
               </a:ext>
             </a:extLst>
           </p:cNvPr>
@@ -4728,7 +4728,7 @@
           <p:cNvPr id="3" name="">
             <a:extLst xmlns:a="http://schemas.openxmlformats.org/drawingml/2006/main">
               <a:ext uri="{FF2B5EF4-FFF2-40B4-BE49-F238E27FC236}">
-                <a16:creationId xmlns:a16="http://schemas.microsoft.com/office/drawing/2014/main" id="{8134E58F-7261-4350-BA28-37303F5C08C5}"/>
+                <a16:creationId xmlns:a16="http://schemas.microsoft.com/office/drawing/2014/main" id="{C29C1A1F-5FF1-4E4D-BA66-A39DC7B8CA79}"/>
               </a:ext>
             </a:extLst>
           </p:cNvPr>
@@ -4849,7 +4849,7 @@
           <p:cNvPr id="4" name="">
             <a:extLst xmlns:a="http://schemas.openxmlformats.org/drawingml/2006/main">
               <a:ext uri="{FF2B5EF4-FFF2-40B4-BE49-F238E27FC236}">
-                <a16:creationId xmlns:a16="http://schemas.microsoft.com/office/drawing/2014/main" id="{99EF5119-AB17-4013-9A1E-0D130956408B}"/>
+                <a16:creationId xmlns:a16="http://schemas.microsoft.com/office/drawing/2014/main" id="{4E066090-8805-43BD-9F53-67DEC9FBCF46}"/>
               </a:ext>
             </a:extLst>
           </p:cNvPr>
@@ -4970,7 +4970,7 @@
           <p:cNvPr id="5" name="">
             <a:extLst xmlns:a="http://schemas.openxmlformats.org/drawingml/2006/main">
               <a:ext uri="{FF2B5EF4-FFF2-40B4-BE49-F238E27FC236}">
-                <a16:creationId xmlns:a16="http://schemas.microsoft.com/office/drawing/2014/main" id="{D603F16F-E112-4CB7-9F98-48B3A455288F}"/>
+                <a16:creationId xmlns:a16="http://schemas.microsoft.com/office/drawing/2014/main" id="{D6C4AD34-4D59-49E0-A46A-4933FCA45BCF}"/>
               </a:ext>
             </a:extLst>
           </p:cNvPr>
@@ -5001,7 +5001,7 @@
           <p:cNvPr id="6" name="">
             <a:extLst xmlns:a="http://schemas.openxmlformats.org/drawingml/2006/main">
               <a:ext uri="{FF2B5EF4-FFF2-40B4-BE49-F238E27FC236}">
-                <a16:creationId xmlns:a16="http://schemas.microsoft.com/office/drawing/2014/main" id="{B1C65C9A-AD36-4679-8474-9EBBBFFC8349}"/>
+                <a16:creationId xmlns:a16="http://schemas.microsoft.com/office/drawing/2014/main" id="{0A76534A-D669-454A-B750-AE2B3B78B26F}"/>
               </a:ext>
             </a:extLst>
           </p:cNvPr>
@@ -5139,7 +5139,7 @@
           <p:cNvPr id="7" name="">
             <a:extLst xmlns:a="http://schemas.openxmlformats.org/drawingml/2006/main">
               <a:ext uri="{FF2B5EF4-FFF2-40B4-BE49-F238E27FC236}">
-                <a16:creationId xmlns:a16="http://schemas.microsoft.com/office/drawing/2014/main" id="{82112EEC-4547-47CF-8934-BAD95CD50BD9}"/>
+                <a16:creationId xmlns:a16="http://schemas.microsoft.com/office/drawing/2014/main" id="{2E5D091D-58B9-4CF8-99D2-B72EE396FA30}"/>
               </a:ext>
             </a:extLst>
           </p:cNvPr>
@@ -5250,7 +5250,7 @@
                   <a:srgbClr val="A2AFAC"/>
                 </a:solidFill>
               </a:rPr>
-              <a:t>기획 기준 2026.10.23</a:t>
+              <a:t>기획 기준 2026.10.24</a:t>
             </a:r>
           </a:p>
         </p:txBody>
@@ -5258,7 +5258,7 @@
     </p:spTree>
     <p:extLst>
       <p:ext uri="{BB962C8B-B14F-4D97-AF65-F5344CB8AC3E}">
-        <p14:creationId xmlns:p14="http://schemas.microsoft.com/office/powerpoint/2010/main" val="235581305"/>
+        <p14:creationId xmlns:p14="http://schemas.microsoft.com/office/powerpoint/2010/main" val="120892249"/>
       </p:ext>
     </p:extLst>
   </p:cSld>
@@ -5289,7 +5289,7 @@
           <p:cNvPr id="49" name="">
             <a:extLst xmlns:a="http://schemas.openxmlformats.org/drawingml/2006/main">
               <a:ext uri="{FF2B5EF4-FFF2-40B4-BE49-F238E27FC236}">
-                <a16:creationId xmlns:a16="http://schemas.microsoft.com/office/drawing/2014/main" id="{50A68960-F0F0-47D5-B8CF-664A2515D72D}"/>
+                <a16:creationId xmlns:a16="http://schemas.microsoft.com/office/drawing/2014/main" id="{503F8E64-3EA9-4168-BA9A-80B87DEEB67C}"/>
               </a:ext>
             </a:extLst>
           </p:cNvPr>
@@ -5320,7 +5320,7 @@
           <p:cNvPr id="2" name="">
             <a:extLst xmlns:a="http://schemas.openxmlformats.org/drawingml/2006/main">
               <a:ext uri="{FF2B5EF4-FFF2-40B4-BE49-F238E27FC236}">
-                <a16:creationId xmlns:a16="http://schemas.microsoft.com/office/drawing/2014/main" id="{8E54A438-1567-4DBB-AC7E-618332BA2B90}"/>
+                <a16:creationId xmlns:a16="http://schemas.microsoft.com/office/drawing/2014/main" id="{BE6955B2-FD51-4F28-A1A5-BB338F563A1E}"/>
               </a:ext>
             </a:extLst>
           </p:cNvPr>
@@ -5441,7 +5441,7 @@
           <p:cNvPr id="3" name="">
             <a:extLst xmlns:a="http://schemas.openxmlformats.org/drawingml/2006/main">
               <a:ext uri="{FF2B5EF4-FFF2-40B4-BE49-F238E27FC236}">
-                <a16:creationId xmlns:a16="http://schemas.microsoft.com/office/drawing/2014/main" id="{79EEEAEE-3018-4619-9871-CEEE9C99CEF3}"/>
+                <a16:creationId xmlns:a16="http://schemas.microsoft.com/office/drawing/2014/main" id="{750E24A1-0FDE-4181-886B-919193741C97}"/>
               </a:ext>
             </a:extLst>
           </p:cNvPr>
@@ -5562,7 +5562,7 @@
           <p:cNvPr id="4" name="">
             <a:extLst xmlns:a="http://schemas.openxmlformats.org/drawingml/2006/main">
               <a:ext uri="{FF2B5EF4-FFF2-40B4-BE49-F238E27FC236}">
-                <a16:creationId xmlns:a16="http://schemas.microsoft.com/office/drawing/2014/main" id="{E568A0BD-282F-40A2-B057-F1F7D3636159}"/>
+                <a16:creationId xmlns:a16="http://schemas.microsoft.com/office/drawing/2014/main" id="{931F74AE-E13C-4724-8CBE-2AB6A2F33192}"/>
               </a:ext>
             </a:extLst>
           </p:cNvPr>
@@ -5593,7 +5593,7 @@
           <p:cNvPr id="5" name="">
             <a:extLst xmlns:a="http://schemas.openxmlformats.org/drawingml/2006/main">
               <a:ext uri="{FF2B5EF4-FFF2-40B4-BE49-F238E27FC236}">
-                <a16:creationId xmlns:a16="http://schemas.microsoft.com/office/drawing/2014/main" id="{7CD71CFF-7042-4FEC-BD59-071B8E42F734}"/>
+                <a16:creationId xmlns:a16="http://schemas.microsoft.com/office/drawing/2014/main" id="{EAB42858-EAB0-4B55-9894-B0BE7E36528E}"/>
               </a:ext>
             </a:extLst>
           </p:cNvPr>
@@ -5714,7 +5714,7 @@
           <p:cNvPr id="6" name="">
             <a:extLst xmlns:a="http://schemas.openxmlformats.org/drawingml/2006/main">
               <a:ext uri="{FF2B5EF4-FFF2-40B4-BE49-F238E27FC236}">
-                <a16:creationId xmlns:a16="http://schemas.microsoft.com/office/drawing/2014/main" id="{61185518-4E37-4036-8A38-44776C162877}"/>
+                <a16:creationId xmlns:a16="http://schemas.microsoft.com/office/drawing/2014/main" id="{50D39C8A-CA60-487F-B253-824F070353E3}"/>
               </a:ext>
             </a:extLst>
           </p:cNvPr>
@@ -5835,7 +5835,7 @@
           <p:cNvPr id="7" name="">
             <a:extLst xmlns:a="http://schemas.openxmlformats.org/drawingml/2006/main">
               <a:ext uri="{FF2B5EF4-FFF2-40B4-BE49-F238E27FC236}">
-                <a16:creationId xmlns:a16="http://schemas.microsoft.com/office/drawing/2014/main" id="{78C98F3E-55A5-44FF-89EB-5E71DF9CF7CA}"/>
+                <a16:creationId xmlns:a16="http://schemas.microsoft.com/office/drawing/2014/main" id="{FFEC860B-E164-4FB5-8D27-331F2E24AD71}"/>
               </a:ext>
             </a:extLst>
           </p:cNvPr>
@@ -5956,7 +5956,7 @@
           <p:cNvPr id="8" name="">
             <a:extLst xmlns:a="http://schemas.openxmlformats.org/drawingml/2006/main">
               <a:ext uri="{FF2B5EF4-FFF2-40B4-BE49-F238E27FC236}">
-                <a16:creationId xmlns:a16="http://schemas.microsoft.com/office/drawing/2014/main" id="{C4304817-26DD-4414-9A29-E948C5E6E209}"/>
+                <a16:creationId xmlns:a16="http://schemas.microsoft.com/office/drawing/2014/main" id="{2B277CAF-DA01-4260-A9CD-ABFC41C7579A}"/>
               </a:ext>
             </a:extLst>
           </p:cNvPr>
@@ -6077,7 +6077,7 @@
           <p:cNvPr id="9" name="">
             <a:extLst xmlns:a="http://schemas.openxmlformats.org/drawingml/2006/main">
               <a:ext uri="{FF2B5EF4-FFF2-40B4-BE49-F238E27FC236}">
-                <a16:creationId xmlns:a16="http://schemas.microsoft.com/office/drawing/2014/main" id="{64EF1DD9-0434-4F03-B75F-D890A1D177B9}"/>
+                <a16:creationId xmlns:a16="http://schemas.microsoft.com/office/drawing/2014/main" id="{C144CE39-3593-4BFE-818C-CC9B622A9A72}"/>
               </a:ext>
             </a:extLst>
           </p:cNvPr>
@@ -6108,7 +6108,7 @@
           <p:cNvPr id="10" name="">
             <a:extLst xmlns:a="http://schemas.openxmlformats.org/drawingml/2006/main">
               <a:ext uri="{FF2B5EF4-FFF2-40B4-BE49-F238E27FC236}">
-                <a16:creationId xmlns:a16="http://schemas.microsoft.com/office/drawing/2014/main" id="{16684A29-E1D6-4EF6-A113-F1783F5187F6}"/>
+                <a16:creationId xmlns:a16="http://schemas.microsoft.com/office/drawing/2014/main" id="{79AB1C6C-94A0-408D-8C57-DBB9CA7FB8FD}"/>
               </a:ext>
             </a:extLst>
           </p:cNvPr>
@@ -6229,7 +6229,7 @@
           <p:cNvPr id="11" name="">
             <a:extLst xmlns:a="http://schemas.openxmlformats.org/drawingml/2006/main">
               <a:ext uri="{FF2B5EF4-FFF2-40B4-BE49-F238E27FC236}">
-                <a16:creationId xmlns:a16="http://schemas.microsoft.com/office/drawing/2014/main" id="{9111A838-4EFD-4CCB-A311-4F94AE01517A}"/>
+                <a16:creationId xmlns:a16="http://schemas.microsoft.com/office/drawing/2014/main" id="{913802CA-21DC-4A3A-BD82-F86A76CA206A}"/>
               </a:ext>
             </a:extLst>
           </p:cNvPr>
@@ -6350,7 +6350,7 @@
           <p:cNvPr id="12" name="">
             <a:extLst xmlns:a="http://schemas.openxmlformats.org/drawingml/2006/main">
               <a:ext uri="{FF2B5EF4-FFF2-40B4-BE49-F238E27FC236}">
-                <a16:creationId xmlns:a16="http://schemas.microsoft.com/office/drawing/2014/main" id="{EF535103-18DE-41D0-96AF-7A0EBAC7084A}"/>
+                <a16:creationId xmlns:a16="http://schemas.microsoft.com/office/drawing/2014/main" id="{E168A893-11E3-4006-8B69-BA7DAA42E3ED}"/>
               </a:ext>
             </a:extLst>
           </p:cNvPr>
@@ -6471,7 +6471,7 @@
           <p:cNvPr id="13" name="">
             <a:extLst xmlns:a="http://schemas.openxmlformats.org/drawingml/2006/main">
               <a:ext uri="{FF2B5EF4-FFF2-40B4-BE49-F238E27FC236}">
-                <a16:creationId xmlns:a16="http://schemas.microsoft.com/office/drawing/2014/main" id="{39898888-F4BB-4C00-B489-D11A42F453EB}"/>
+                <a16:creationId xmlns:a16="http://schemas.microsoft.com/office/drawing/2014/main" id="{BA1A9308-97EF-47C7-9121-1D2A2EEE3227}"/>
               </a:ext>
             </a:extLst>
           </p:cNvPr>
@@ -6502,7 +6502,7 @@
           <p:cNvPr id="14" name="">
             <a:extLst xmlns:a="http://schemas.openxmlformats.org/drawingml/2006/main">
               <a:ext uri="{FF2B5EF4-FFF2-40B4-BE49-F238E27FC236}">
-                <a16:creationId xmlns:a16="http://schemas.microsoft.com/office/drawing/2014/main" id="{792E9C12-9B5A-4179-9D9E-5C3824CE1EC5}"/>
+                <a16:creationId xmlns:a16="http://schemas.microsoft.com/office/drawing/2014/main" id="{C1F210D3-F9BF-49BA-A379-A5CBA1DF17AC}"/>
               </a:ext>
             </a:extLst>
           </p:cNvPr>
@@ -6623,7 +6623,7 @@
           <p:cNvPr id="15" name="">
             <a:extLst xmlns:a="http://schemas.openxmlformats.org/drawingml/2006/main">
               <a:ext uri="{FF2B5EF4-FFF2-40B4-BE49-F238E27FC236}">
-                <a16:creationId xmlns:a16="http://schemas.microsoft.com/office/drawing/2014/main" id="{39531833-9B31-475B-8CD8-95570A911CD7}"/>
+                <a16:creationId xmlns:a16="http://schemas.microsoft.com/office/drawing/2014/main" id="{172A477F-F31A-4563-B0BA-F18D6AD6DDAF}"/>
               </a:ext>
             </a:extLst>
           </p:cNvPr>
@@ -6744,7 +6744,7 @@
           <p:cNvPr id="16" name="">
             <a:extLst xmlns:a="http://schemas.openxmlformats.org/drawingml/2006/main">
               <a:ext uri="{FF2B5EF4-FFF2-40B4-BE49-F238E27FC236}">
-                <a16:creationId xmlns:a16="http://schemas.microsoft.com/office/drawing/2014/main" id="{F3A4F41F-365C-4BED-86D9-4A4889C91D2B}"/>
+                <a16:creationId xmlns:a16="http://schemas.microsoft.com/office/drawing/2014/main" id="{10952BA5-21DE-47FB-819C-5E391C9F317A}"/>
               </a:ext>
             </a:extLst>
           </p:cNvPr>
@@ -6865,7 +6865,7 @@
           <p:cNvPr id="17" name="">
             <a:extLst xmlns:a="http://schemas.openxmlformats.org/drawingml/2006/main">
               <a:ext uri="{FF2B5EF4-FFF2-40B4-BE49-F238E27FC236}">
-                <a16:creationId xmlns:a16="http://schemas.microsoft.com/office/drawing/2014/main" id="{EA96D486-4DCF-4049-A4E7-D533AB367C9E}"/>
+                <a16:creationId xmlns:a16="http://schemas.microsoft.com/office/drawing/2014/main" id="{23E53C6A-A001-471C-8837-B1965CE46102}"/>
               </a:ext>
             </a:extLst>
           </p:cNvPr>
@@ -6896,7 +6896,7 @@
           <p:cNvPr id="18" name="">
             <a:extLst xmlns:a="http://schemas.openxmlformats.org/drawingml/2006/main">
               <a:ext uri="{FF2B5EF4-FFF2-40B4-BE49-F238E27FC236}">
-                <a16:creationId xmlns:a16="http://schemas.microsoft.com/office/drawing/2014/main" id="{21DC98E6-15E6-4220-9DB4-A9F38FCCCB1A}"/>
+                <a16:creationId xmlns:a16="http://schemas.microsoft.com/office/drawing/2014/main" id="{EEF73176-C3CF-43B3-A906-27EDEEE091FE}"/>
               </a:ext>
             </a:extLst>
           </p:cNvPr>
@@ -7017,7 +7017,7 @@
           <p:cNvPr id="19" name="">
             <a:extLst xmlns:a="http://schemas.openxmlformats.org/drawingml/2006/main">
               <a:ext uri="{FF2B5EF4-FFF2-40B4-BE49-F238E27FC236}">
-                <a16:creationId xmlns:a16="http://schemas.microsoft.com/office/drawing/2014/main" id="{6724ADFC-C9DE-4ED3-BA36-AF7946BF19A9}"/>
+                <a16:creationId xmlns:a16="http://schemas.microsoft.com/office/drawing/2014/main" id="{58BDB04E-FB8E-4A97-9ECF-D1C3DC6CD047}"/>
               </a:ext>
             </a:extLst>
           </p:cNvPr>
@@ -7138,7 +7138,7 @@
           <p:cNvPr id="20" name="">
             <a:extLst xmlns:a="http://schemas.openxmlformats.org/drawingml/2006/main">
               <a:ext uri="{FF2B5EF4-FFF2-40B4-BE49-F238E27FC236}">
-                <a16:creationId xmlns:a16="http://schemas.microsoft.com/office/drawing/2014/main" id="{445D205E-26ED-4C66-BCE9-2A4364B1342B}"/>
+                <a16:creationId xmlns:a16="http://schemas.microsoft.com/office/drawing/2014/main" id="{C1B671CB-EBA1-465C-AB69-B9DA2F0C5ECE}"/>
               </a:ext>
             </a:extLst>
           </p:cNvPr>
@@ -7259,7 +7259,7 @@
           <p:cNvPr id="21" name="">
             <a:extLst xmlns:a="http://schemas.openxmlformats.org/drawingml/2006/main">
               <a:ext uri="{FF2B5EF4-FFF2-40B4-BE49-F238E27FC236}">
-                <a16:creationId xmlns:a16="http://schemas.microsoft.com/office/drawing/2014/main" id="{3185E520-73F6-4F0E-863A-3D82172C6313}"/>
+                <a16:creationId xmlns:a16="http://schemas.microsoft.com/office/drawing/2014/main" id="{56B75B7A-FC98-4429-805C-6FC026E671FD}"/>
               </a:ext>
             </a:extLst>
           </p:cNvPr>
@@ -7290,7 +7290,7 @@
           <p:cNvPr id="22" name="">
             <a:extLst xmlns:a="http://schemas.openxmlformats.org/drawingml/2006/main">
               <a:ext uri="{FF2B5EF4-FFF2-40B4-BE49-F238E27FC236}">
-                <a16:creationId xmlns:a16="http://schemas.microsoft.com/office/drawing/2014/main" id="{37824F63-3368-412C-B5ED-6970ED3862E1}"/>
+                <a16:creationId xmlns:a16="http://schemas.microsoft.com/office/drawing/2014/main" id="{F05DFF28-2728-44EE-BD24-090D66EF1C89}"/>
               </a:ext>
             </a:extLst>
           </p:cNvPr>
@@ -7411,7 +7411,7 @@
           <p:cNvPr id="23" name="">
             <a:extLst xmlns:a="http://schemas.openxmlformats.org/drawingml/2006/main">
               <a:ext uri="{FF2B5EF4-FFF2-40B4-BE49-F238E27FC236}">
-                <a16:creationId xmlns:a16="http://schemas.microsoft.com/office/drawing/2014/main" id="{2E18C11B-4C12-439E-AF46-3AB431DF1803}"/>
+                <a16:creationId xmlns:a16="http://schemas.microsoft.com/office/drawing/2014/main" id="{9154BD7F-18D2-4E84-974E-A162B25F610A}"/>
               </a:ext>
             </a:extLst>
           </p:cNvPr>
@@ -7532,7 +7532,7 @@
           <p:cNvPr id="24" name="">
             <a:extLst xmlns:a="http://schemas.openxmlformats.org/drawingml/2006/main">
               <a:ext uri="{FF2B5EF4-FFF2-40B4-BE49-F238E27FC236}">
-                <a16:creationId xmlns:a16="http://schemas.microsoft.com/office/drawing/2014/main" id="{CED1FF17-F174-4C71-802A-BCDE09C68135}"/>
+                <a16:creationId xmlns:a16="http://schemas.microsoft.com/office/drawing/2014/main" id="{35428324-ED60-49BE-A0A4-283779E8CBC1}"/>
               </a:ext>
             </a:extLst>
           </p:cNvPr>
@@ -7653,7 +7653,7 @@
           <p:cNvPr id="25" name="">
             <a:extLst xmlns:a="http://schemas.openxmlformats.org/drawingml/2006/main">
               <a:ext uri="{FF2B5EF4-FFF2-40B4-BE49-F238E27FC236}">
-                <a16:creationId xmlns:a16="http://schemas.microsoft.com/office/drawing/2014/main" id="{D8A243CA-5219-41B2-A9C3-1BAA41F95775}"/>
+                <a16:creationId xmlns:a16="http://schemas.microsoft.com/office/drawing/2014/main" id="{246A29CF-A7A5-4368-BEB9-15CB45A15D60}"/>
               </a:ext>
             </a:extLst>
           </p:cNvPr>
@@ -7684,7 +7684,7 @@
           <p:cNvPr id="26" name="">
             <a:extLst xmlns:a="http://schemas.openxmlformats.org/drawingml/2006/main">
               <a:ext uri="{FF2B5EF4-FFF2-40B4-BE49-F238E27FC236}">
-                <a16:creationId xmlns:a16="http://schemas.microsoft.com/office/drawing/2014/main" id="{F59FC507-AF1A-4C1E-ACA7-4BA09E31567B}"/>
+                <a16:creationId xmlns:a16="http://schemas.microsoft.com/office/drawing/2014/main" id="{34EDBCD7-0D05-4A83-988A-1F39B38DEABB}"/>
               </a:ext>
             </a:extLst>
           </p:cNvPr>
@@ -7805,7 +7805,7 @@
           <p:cNvPr id="27" name="">
             <a:extLst xmlns:a="http://schemas.openxmlformats.org/drawingml/2006/main">
               <a:ext uri="{FF2B5EF4-FFF2-40B4-BE49-F238E27FC236}">
-                <a16:creationId xmlns:a16="http://schemas.microsoft.com/office/drawing/2014/main" id="{8BA9D0A3-5E01-4FA9-93BF-10034AC57726}"/>
+                <a16:creationId xmlns:a16="http://schemas.microsoft.com/office/drawing/2014/main" id="{A42B0A9F-A115-4245-8DA4-B44FD16606BA}"/>
               </a:ext>
             </a:extLst>
           </p:cNvPr>
@@ -7926,7 +7926,7 @@
           <p:cNvPr id="28" name="">
             <a:extLst xmlns:a="http://schemas.openxmlformats.org/drawingml/2006/main">
               <a:ext uri="{FF2B5EF4-FFF2-40B4-BE49-F238E27FC236}">
-                <a16:creationId xmlns:a16="http://schemas.microsoft.com/office/drawing/2014/main" id="{86F0A3A5-E465-4594-9093-8FF4EE90D05F}"/>
+                <a16:creationId xmlns:a16="http://schemas.microsoft.com/office/drawing/2014/main" id="{7F02F82A-5534-488A-8100-8DFDDF6E92C7}"/>
               </a:ext>
             </a:extLst>
           </p:cNvPr>
@@ -8047,7 +8047,7 @@
           <p:cNvPr id="29" name="">
             <a:extLst xmlns:a="http://schemas.openxmlformats.org/drawingml/2006/main">
               <a:ext uri="{FF2B5EF4-FFF2-40B4-BE49-F238E27FC236}">
-                <a16:creationId xmlns:a16="http://schemas.microsoft.com/office/drawing/2014/main" id="{0DF8669B-3259-49F5-B915-B59B5E4E59B9}"/>
+                <a16:creationId xmlns:a16="http://schemas.microsoft.com/office/drawing/2014/main" id="{6ABD04A6-0817-43F9-8EBC-AA4C1D3CC949}"/>
               </a:ext>
             </a:extLst>
           </p:cNvPr>
@@ -8078,7 +8078,7 @@
           <p:cNvPr id="30" name="">
             <a:extLst xmlns:a="http://schemas.openxmlformats.org/drawingml/2006/main">
               <a:ext uri="{FF2B5EF4-FFF2-40B4-BE49-F238E27FC236}">
-                <a16:creationId xmlns:a16="http://schemas.microsoft.com/office/drawing/2014/main" id="{0930F332-761F-46CE-BEE2-7FF357496406}"/>
+                <a16:creationId xmlns:a16="http://schemas.microsoft.com/office/drawing/2014/main" id="{48387612-3146-47F5-A83C-558CCF8921E0}"/>
               </a:ext>
             </a:extLst>
           </p:cNvPr>
@@ -8199,7 +8199,7 @@
           <p:cNvPr id="31" name="">
             <a:extLst xmlns:a="http://schemas.openxmlformats.org/drawingml/2006/main">
               <a:ext uri="{FF2B5EF4-FFF2-40B4-BE49-F238E27FC236}">
-                <a16:creationId xmlns:a16="http://schemas.microsoft.com/office/drawing/2014/main" id="{839BE70F-884C-4E23-B3F6-89C11CE8B915}"/>
+                <a16:creationId xmlns:a16="http://schemas.microsoft.com/office/drawing/2014/main" id="{324D2F2D-AB8C-4E39-8BF4-3D718440AE10}"/>
               </a:ext>
             </a:extLst>
           </p:cNvPr>
@@ -8320,7 +8320,7 @@
           <p:cNvPr id="32" name="">
             <a:extLst xmlns:a="http://schemas.openxmlformats.org/drawingml/2006/main">
               <a:ext uri="{FF2B5EF4-FFF2-40B4-BE49-F238E27FC236}">
-                <a16:creationId xmlns:a16="http://schemas.microsoft.com/office/drawing/2014/main" id="{656DB98F-AA8B-425C-BB07-7249C5912B00}"/>
+                <a16:creationId xmlns:a16="http://schemas.microsoft.com/office/drawing/2014/main" id="{1EC67BC2-7221-40D2-AD5B-653E6881EAC7}"/>
               </a:ext>
             </a:extLst>
           </p:cNvPr>
@@ -8441,7 +8441,7 @@
           <p:cNvPr id="33" name="">
             <a:extLst xmlns:a="http://schemas.openxmlformats.org/drawingml/2006/main">
               <a:ext uri="{FF2B5EF4-FFF2-40B4-BE49-F238E27FC236}">
-                <a16:creationId xmlns:a16="http://schemas.microsoft.com/office/drawing/2014/main" id="{A0AD2A04-4877-43B7-8F57-4052562228D5}"/>
+                <a16:creationId xmlns:a16="http://schemas.microsoft.com/office/drawing/2014/main" id="{984769FD-9D55-4B45-AA3D-6C9BD29EC20A}"/>
               </a:ext>
             </a:extLst>
           </p:cNvPr>
@@ -8472,7 +8472,7 @@
           <p:cNvPr id="34" name="">
             <a:extLst xmlns:a="http://schemas.openxmlformats.org/drawingml/2006/main">
               <a:ext uri="{FF2B5EF4-FFF2-40B4-BE49-F238E27FC236}">
-                <a16:creationId xmlns:a16="http://schemas.microsoft.com/office/drawing/2014/main" id="{34E621A7-7BDD-48E1-A2F0-FE7940CC9A56}"/>
+                <a16:creationId xmlns:a16="http://schemas.microsoft.com/office/drawing/2014/main" id="{6C5538DE-7C1F-4B1F-B199-2E0376FCF96F}"/>
               </a:ext>
             </a:extLst>
           </p:cNvPr>
@@ -8593,7 +8593,7 @@
           <p:cNvPr id="35" name="">
             <a:extLst xmlns:a="http://schemas.openxmlformats.org/drawingml/2006/main">
               <a:ext uri="{FF2B5EF4-FFF2-40B4-BE49-F238E27FC236}">
-                <a16:creationId xmlns:a16="http://schemas.microsoft.com/office/drawing/2014/main" id="{35E0E971-8881-40A3-AC2F-14A2E5BB5D64}"/>
+                <a16:creationId xmlns:a16="http://schemas.microsoft.com/office/drawing/2014/main" id="{0E4F7D44-85B5-4522-81AD-3053FBC3A503}"/>
               </a:ext>
             </a:extLst>
           </p:cNvPr>
@@ -8714,7 +8714,7 @@
           <p:cNvPr id="36" name="">
             <a:extLst xmlns:a="http://schemas.openxmlformats.org/drawingml/2006/main">
               <a:ext uri="{FF2B5EF4-FFF2-40B4-BE49-F238E27FC236}">
-                <a16:creationId xmlns:a16="http://schemas.microsoft.com/office/drawing/2014/main" id="{4EF68240-5079-434D-9C5F-EF556C27216B}"/>
+                <a16:creationId xmlns:a16="http://schemas.microsoft.com/office/drawing/2014/main" id="{2D494020-BC1A-42A3-AE12-F1B9137D328F}"/>
               </a:ext>
             </a:extLst>
           </p:cNvPr>
@@ -8835,7 +8835,7 @@
           <p:cNvPr id="37" name="">
             <a:extLst xmlns:a="http://schemas.openxmlformats.org/drawingml/2006/main">
               <a:ext uri="{FF2B5EF4-FFF2-40B4-BE49-F238E27FC236}">
-                <a16:creationId xmlns:a16="http://schemas.microsoft.com/office/drawing/2014/main" id="{95662880-ECB6-4A43-83DB-2A8D893B4175}"/>
+                <a16:creationId xmlns:a16="http://schemas.microsoft.com/office/drawing/2014/main" id="{330DAC3B-B6D1-4EEC-A3C6-57B5C4322C83}"/>
               </a:ext>
             </a:extLst>
           </p:cNvPr>
@@ -8866,7 +8866,7 @@
           <p:cNvPr id="38" name="">
             <a:extLst xmlns:a="http://schemas.openxmlformats.org/drawingml/2006/main">
               <a:ext uri="{FF2B5EF4-FFF2-40B4-BE49-F238E27FC236}">
-                <a16:creationId xmlns:a16="http://schemas.microsoft.com/office/drawing/2014/main" id="{FE5E33F8-E6E1-4EB0-A76F-4FACDBC9E6F8}"/>
+                <a16:creationId xmlns:a16="http://schemas.microsoft.com/office/drawing/2014/main" id="{7FF4F93D-F41F-4920-BE9A-65CC7306ECB9}"/>
               </a:ext>
             </a:extLst>
           </p:cNvPr>
@@ -8987,7 +8987,7 @@
           <p:cNvPr id="39" name="">
             <a:extLst xmlns:a="http://schemas.openxmlformats.org/drawingml/2006/main">
               <a:ext uri="{FF2B5EF4-FFF2-40B4-BE49-F238E27FC236}">
-                <a16:creationId xmlns:a16="http://schemas.microsoft.com/office/drawing/2014/main" id="{EE27E073-E1DD-4C67-8830-F381DF863053}"/>
+                <a16:creationId xmlns:a16="http://schemas.microsoft.com/office/drawing/2014/main" id="{F4F8D586-0B4A-4646-A7DA-D7D0C9AA890C}"/>
               </a:ext>
             </a:extLst>
           </p:cNvPr>
@@ -9108,7 +9108,7 @@
           <p:cNvPr id="40" name="">
             <a:extLst xmlns:a="http://schemas.openxmlformats.org/drawingml/2006/main">
               <a:ext uri="{FF2B5EF4-FFF2-40B4-BE49-F238E27FC236}">
-                <a16:creationId xmlns:a16="http://schemas.microsoft.com/office/drawing/2014/main" id="{C636DA5B-7893-4F69-94F0-328562812D02}"/>
+                <a16:creationId xmlns:a16="http://schemas.microsoft.com/office/drawing/2014/main" id="{13C860FE-90FA-47E1-BFA7-9C735F72E0EC}"/>
               </a:ext>
             </a:extLst>
           </p:cNvPr>
@@ -9229,7 +9229,7 @@
           <p:cNvPr id="41" name="">
             <a:extLst xmlns:a="http://schemas.openxmlformats.org/drawingml/2006/main">
               <a:ext uri="{FF2B5EF4-FFF2-40B4-BE49-F238E27FC236}">
-                <a16:creationId xmlns:a16="http://schemas.microsoft.com/office/drawing/2014/main" id="{50EC7D05-EE2B-463D-B229-B6C260F4EFEC}"/>
+                <a16:creationId xmlns:a16="http://schemas.microsoft.com/office/drawing/2014/main" id="{2242178D-DC1A-4432-9A93-2EB712805C59}"/>
               </a:ext>
             </a:extLst>
           </p:cNvPr>
@@ -9260,7 +9260,7 @@
           <p:cNvPr id="42" name="">
             <a:extLst xmlns:a="http://schemas.openxmlformats.org/drawingml/2006/main">
               <a:ext uri="{FF2B5EF4-FFF2-40B4-BE49-F238E27FC236}">
-                <a16:creationId xmlns:a16="http://schemas.microsoft.com/office/drawing/2014/main" id="{D71C7777-9ED9-467B-AEE3-AFAFB0BAB9CF}"/>
+                <a16:creationId xmlns:a16="http://schemas.microsoft.com/office/drawing/2014/main" id="{B93F4C05-9363-4E27-8F64-8CCEB9CC4F31}"/>
               </a:ext>
             </a:extLst>
           </p:cNvPr>
@@ -9381,7 +9381,7 @@
           <p:cNvPr id="43" name="">
             <a:extLst xmlns:a="http://schemas.openxmlformats.org/drawingml/2006/main">
               <a:ext uri="{FF2B5EF4-FFF2-40B4-BE49-F238E27FC236}">
-                <a16:creationId xmlns:a16="http://schemas.microsoft.com/office/drawing/2014/main" id="{D06B8866-57FB-463B-9524-9202FF6C0C0B}"/>
+                <a16:creationId xmlns:a16="http://schemas.microsoft.com/office/drawing/2014/main" id="{964706C6-E50A-4851-837C-295B71D3FFDC}"/>
               </a:ext>
             </a:extLst>
           </p:cNvPr>
@@ -9502,7 +9502,7 @@
           <p:cNvPr id="44" name="">
             <a:extLst xmlns:a="http://schemas.openxmlformats.org/drawingml/2006/main">
               <a:ext uri="{FF2B5EF4-FFF2-40B4-BE49-F238E27FC236}">
-                <a16:creationId xmlns:a16="http://schemas.microsoft.com/office/drawing/2014/main" id="{EF33695B-6B86-4B4F-AE63-7DF21D50BFF9}"/>
+                <a16:creationId xmlns:a16="http://schemas.microsoft.com/office/drawing/2014/main" id="{8E931396-9999-4BCC-9E0A-123A047022E6}"/>
               </a:ext>
             </a:extLst>
           </p:cNvPr>
@@ -9623,7 +9623,7 @@
           <p:cNvPr id="45" name="">
             <a:extLst xmlns:a="http://schemas.openxmlformats.org/drawingml/2006/main">
               <a:ext uri="{FF2B5EF4-FFF2-40B4-BE49-F238E27FC236}">
-                <a16:creationId xmlns:a16="http://schemas.microsoft.com/office/drawing/2014/main" id="{3EABF31B-D0B0-43A8-AC75-234162006F13}"/>
+                <a16:creationId xmlns:a16="http://schemas.microsoft.com/office/drawing/2014/main" id="{13460DB4-A205-431E-965E-CB38A0BF4D49}"/>
               </a:ext>
             </a:extLst>
           </p:cNvPr>
@@ -9654,7 +9654,7 @@
           <p:cNvPr id="46" name="">
             <a:extLst xmlns:a="http://schemas.openxmlformats.org/drawingml/2006/main">
               <a:ext uri="{FF2B5EF4-FFF2-40B4-BE49-F238E27FC236}">
-                <a16:creationId xmlns:a16="http://schemas.microsoft.com/office/drawing/2014/main" id="{FDF06419-1D23-4DEA-A430-EF360C774D85}"/>
+                <a16:creationId xmlns:a16="http://schemas.microsoft.com/office/drawing/2014/main" id="{50D0B98F-7DBC-409C-992C-D2C87E01966D}"/>
               </a:ext>
             </a:extLst>
           </p:cNvPr>
@@ -9775,7 +9775,7 @@
           <p:cNvPr id="47" name="">
             <a:extLst xmlns:a="http://schemas.openxmlformats.org/drawingml/2006/main">
               <a:ext uri="{FF2B5EF4-FFF2-40B4-BE49-F238E27FC236}">
-                <a16:creationId xmlns:a16="http://schemas.microsoft.com/office/drawing/2014/main" id="{A6EC9D12-E709-4F62-88C3-CD0D348404E8}"/>
+                <a16:creationId xmlns:a16="http://schemas.microsoft.com/office/drawing/2014/main" id="{A041948C-9BC9-4C17-88C1-67367A31BB0E}"/>
               </a:ext>
             </a:extLst>
           </p:cNvPr>
@@ -9896,7 +9896,7 @@
           <p:cNvPr id="48" name="">
             <a:extLst xmlns:a="http://schemas.openxmlformats.org/drawingml/2006/main">
               <a:ext uri="{FF2B5EF4-FFF2-40B4-BE49-F238E27FC236}">
-                <a16:creationId xmlns:a16="http://schemas.microsoft.com/office/drawing/2014/main" id="{477BAC5A-9A29-4AB6-A2D3-4BD424D3AAD8}"/>
+                <a16:creationId xmlns:a16="http://schemas.microsoft.com/office/drawing/2014/main" id="{45B342E8-7040-47DF-B486-34552A77B277}"/>
               </a:ext>
             </a:extLst>
           </p:cNvPr>
@@ -10015,7 +10015,7 @@
     </p:spTree>
     <p:extLst>
       <p:ext uri="{BB962C8B-B14F-4D97-AF65-F5344CB8AC3E}">
-        <p14:creationId xmlns:p14="http://schemas.microsoft.com/office/powerpoint/2010/main" val="386245623"/>
+        <p14:creationId xmlns:p14="http://schemas.microsoft.com/office/powerpoint/2010/main" val="1788727883"/>
       </p:ext>
     </p:extLst>
   </p:cSld>
@@ -10046,7 +10046,7 @@
           <p:cNvPr id="53" name="">
             <a:extLst xmlns:a="http://schemas.openxmlformats.org/drawingml/2006/main">
               <a:ext uri="{FF2B5EF4-FFF2-40B4-BE49-F238E27FC236}">
-                <a16:creationId xmlns:a16="http://schemas.microsoft.com/office/drawing/2014/main" id="{FE119FB2-B5C0-48CC-9DA1-8CC5A626E5E9}"/>
+                <a16:creationId xmlns:a16="http://schemas.microsoft.com/office/drawing/2014/main" id="{09622D43-7873-492A-B5CF-8248A98075C2}"/>
               </a:ext>
             </a:extLst>
           </p:cNvPr>
@@ -10077,7 +10077,7 @@
           <p:cNvPr id="2" name="">
             <a:extLst xmlns:a="http://schemas.openxmlformats.org/drawingml/2006/main">
               <a:ext uri="{FF2B5EF4-FFF2-40B4-BE49-F238E27FC236}">
-                <a16:creationId xmlns:a16="http://schemas.microsoft.com/office/drawing/2014/main" id="{C0391F8F-4505-4E9D-92BE-304E4594C3EB}"/>
+                <a16:creationId xmlns:a16="http://schemas.microsoft.com/office/drawing/2014/main" id="{146D7E52-7FF3-426E-8927-B60797D0E1DB}"/>
               </a:ext>
             </a:extLst>
           </p:cNvPr>
@@ -10198,7 +10198,7 @@
           <p:cNvPr id="3" name="">
             <a:extLst xmlns:a="http://schemas.openxmlformats.org/drawingml/2006/main">
               <a:ext uri="{FF2B5EF4-FFF2-40B4-BE49-F238E27FC236}">
-                <a16:creationId xmlns:a16="http://schemas.microsoft.com/office/drawing/2014/main" id="{AB08FADA-CC69-45C1-97F1-D40FEB1296CB}"/>
+                <a16:creationId xmlns:a16="http://schemas.microsoft.com/office/drawing/2014/main" id="{7A04AAB1-4302-4557-89CA-D8ECAD461F3D}"/>
               </a:ext>
             </a:extLst>
           </p:cNvPr>
@@ -10319,7 +10319,7 @@
           <p:cNvPr id="4" name="">
             <a:extLst xmlns:a="http://schemas.openxmlformats.org/drawingml/2006/main">
               <a:ext uri="{FF2B5EF4-FFF2-40B4-BE49-F238E27FC236}">
-                <a16:creationId xmlns:a16="http://schemas.microsoft.com/office/drawing/2014/main" id="{9885ED98-5E76-414C-A954-57D9C5429C36}"/>
+                <a16:creationId xmlns:a16="http://schemas.microsoft.com/office/drawing/2014/main" id="{CB36A4C2-C135-4AE5-B7A2-69DE9BAC5BD5}"/>
               </a:ext>
             </a:extLst>
           </p:cNvPr>
@@ -10350,7 +10350,7 @@
           <p:cNvPr id="5" name="">
             <a:extLst xmlns:a="http://schemas.openxmlformats.org/drawingml/2006/main">
               <a:ext uri="{FF2B5EF4-FFF2-40B4-BE49-F238E27FC236}">
-                <a16:creationId xmlns:a16="http://schemas.microsoft.com/office/drawing/2014/main" id="{7E1035CC-12F6-40D8-A1B9-7EFF37BFACF6}"/>
+                <a16:creationId xmlns:a16="http://schemas.microsoft.com/office/drawing/2014/main" id="{93762E7E-EA6D-4911-A939-5831341D00C9}"/>
               </a:ext>
             </a:extLst>
           </p:cNvPr>
@@ -10471,7 +10471,7 @@
           <p:cNvPr id="6" name="">
             <a:extLst xmlns:a="http://schemas.openxmlformats.org/drawingml/2006/main">
               <a:ext uri="{FF2B5EF4-FFF2-40B4-BE49-F238E27FC236}">
-                <a16:creationId xmlns:a16="http://schemas.microsoft.com/office/drawing/2014/main" id="{08B69BEE-DBAF-4D50-BC42-20736D20F885}"/>
+                <a16:creationId xmlns:a16="http://schemas.microsoft.com/office/drawing/2014/main" id="{24A95761-0B20-461E-8E99-1DA870683687}"/>
               </a:ext>
             </a:extLst>
           </p:cNvPr>
@@ -10592,7 +10592,7 @@
           <p:cNvPr id="7" name="">
             <a:extLst xmlns:a="http://schemas.openxmlformats.org/drawingml/2006/main">
               <a:ext uri="{FF2B5EF4-FFF2-40B4-BE49-F238E27FC236}">
-                <a16:creationId xmlns:a16="http://schemas.microsoft.com/office/drawing/2014/main" id="{33A8AB59-11B9-4301-AC10-2140AB7AE8C7}"/>
+                <a16:creationId xmlns:a16="http://schemas.microsoft.com/office/drawing/2014/main" id="{55F0BA40-8FAE-4132-932C-238EF4073AAE}"/>
               </a:ext>
             </a:extLst>
           </p:cNvPr>
@@ -10713,7 +10713,7 @@
           <p:cNvPr id="8" name="">
             <a:extLst xmlns:a="http://schemas.openxmlformats.org/drawingml/2006/main">
               <a:ext uri="{FF2B5EF4-FFF2-40B4-BE49-F238E27FC236}">
-                <a16:creationId xmlns:a16="http://schemas.microsoft.com/office/drawing/2014/main" id="{7C1CD029-1539-4909-9189-156D54DCBEE2}"/>
+                <a16:creationId xmlns:a16="http://schemas.microsoft.com/office/drawing/2014/main" id="{AED15C06-18BB-4266-AE91-B2AE6651ADA1}"/>
               </a:ext>
             </a:extLst>
           </p:cNvPr>
@@ -10834,7 +10834,7 @@
           <p:cNvPr id="9" name="">
             <a:extLst xmlns:a="http://schemas.openxmlformats.org/drawingml/2006/main">
               <a:ext uri="{FF2B5EF4-FFF2-40B4-BE49-F238E27FC236}">
-                <a16:creationId xmlns:a16="http://schemas.microsoft.com/office/drawing/2014/main" id="{DCDA59CD-3F50-4967-AF14-D807C1FC9477}"/>
+                <a16:creationId xmlns:a16="http://schemas.microsoft.com/office/drawing/2014/main" id="{7AA0FCBE-AC0C-44A8-A538-4878224B9192}"/>
               </a:ext>
             </a:extLst>
           </p:cNvPr>
@@ -10865,7 +10865,7 @@
           <p:cNvPr id="10" name="">
             <a:extLst xmlns:a="http://schemas.openxmlformats.org/drawingml/2006/main">
               <a:ext uri="{FF2B5EF4-FFF2-40B4-BE49-F238E27FC236}">
-                <a16:creationId xmlns:a16="http://schemas.microsoft.com/office/drawing/2014/main" id="{3E022DA0-6419-4358-B111-F0681FC7F37E}"/>
+                <a16:creationId xmlns:a16="http://schemas.microsoft.com/office/drawing/2014/main" id="{A3E0ECCC-1093-4884-AE7A-0251A789A36C}"/>
               </a:ext>
             </a:extLst>
           </p:cNvPr>
@@ -10986,7 +10986,7 @@
           <p:cNvPr id="11" name="">
             <a:extLst xmlns:a="http://schemas.openxmlformats.org/drawingml/2006/main">
               <a:ext uri="{FF2B5EF4-FFF2-40B4-BE49-F238E27FC236}">
-                <a16:creationId xmlns:a16="http://schemas.microsoft.com/office/drawing/2014/main" id="{2C0990FB-4C9E-489E-8FE5-1507FC416D4B}"/>
+                <a16:creationId xmlns:a16="http://schemas.microsoft.com/office/drawing/2014/main" id="{9EB00206-F895-4274-9DE3-5B37A09F13B9}"/>
               </a:ext>
             </a:extLst>
           </p:cNvPr>
@@ -11107,7 +11107,7 @@
           <p:cNvPr id="12" name="">
             <a:extLst xmlns:a="http://schemas.openxmlformats.org/drawingml/2006/main">
               <a:ext uri="{FF2B5EF4-FFF2-40B4-BE49-F238E27FC236}">
-                <a16:creationId xmlns:a16="http://schemas.microsoft.com/office/drawing/2014/main" id="{A91E529D-AA82-45E8-A462-0FA81C154166}"/>
+                <a16:creationId xmlns:a16="http://schemas.microsoft.com/office/drawing/2014/main" id="{3C130B03-7230-4319-806F-56DBDF26F108}"/>
               </a:ext>
             </a:extLst>
           </p:cNvPr>
@@ -11228,7 +11228,7 @@
           <p:cNvPr id="13" name="">
             <a:extLst xmlns:a="http://schemas.openxmlformats.org/drawingml/2006/main">
               <a:ext uri="{FF2B5EF4-FFF2-40B4-BE49-F238E27FC236}">
-                <a16:creationId xmlns:a16="http://schemas.microsoft.com/office/drawing/2014/main" id="{16E24EC5-06F9-4E05-AC2D-89ED44A045B5}"/>
+                <a16:creationId xmlns:a16="http://schemas.microsoft.com/office/drawing/2014/main" id="{78B77E4A-E89B-4B05-A02F-51DE8010EA88}"/>
               </a:ext>
             </a:extLst>
           </p:cNvPr>
@@ -11259,7 +11259,7 @@
           <p:cNvPr id="14" name="">
             <a:extLst xmlns:a="http://schemas.openxmlformats.org/drawingml/2006/main">
               <a:ext uri="{FF2B5EF4-FFF2-40B4-BE49-F238E27FC236}">
-                <a16:creationId xmlns:a16="http://schemas.microsoft.com/office/drawing/2014/main" id="{98077BB0-A8ED-4A12-BD45-5765DD1313DA}"/>
+                <a16:creationId xmlns:a16="http://schemas.microsoft.com/office/drawing/2014/main" id="{027B4F13-42F3-4FAB-9C9B-8BDEB9CED59B}"/>
               </a:ext>
             </a:extLst>
           </p:cNvPr>
@@ -11380,7 +11380,7 @@
           <p:cNvPr id="15" name="">
             <a:extLst xmlns:a="http://schemas.openxmlformats.org/drawingml/2006/main">
               <a:ext uri="{FF2B5EF4-FFF2-40B4-BE49-F238E27FC236}">
-                <a16:creationId xmlns:a16="http://schemas.microsoft.com/office/drawing/2014/main" id="{DCECF34A-B9C0-4BA9-BC82-9F94F97B96FB}"/>
+                <a16:creationId xmlns:a16="http://schemas.microsoft.com/office/drawing/2014/main" id="{12AAD6C6-5A1A-4EEF-8F58-5BA3F834DC35}"/>
               </a:ext>
             </a:extLst>
           </p:cNvPr>
@@ -11501,7 +11501,7 @@
           <p:cNvPr id="16" name="">
             <a:extLst xmlns:a="http://schemas.openxmlformats.org/drawingml/2006/main">
               <a:ext uri="{FF2B5EF4-FFF2-40B4-BE49-F238E27FC236}">
-                <a16:creationId xmlns:a16="http://schemas.microsoft.com/office/drawing/2014/main" id="{263874D3-E86F-46B5-A560-7D7690B28728}"/>
+                <a16:creationId xmlns:a16="http://schemas.microsoft.com/office/drawing/2014/main" id="{8E8FD0E7-369C-4368-A644-250A78F2F4D5}"/>
               </a:ext>
             </a:extLst>
           </p:cNvPr>
@@ -11622,7 +11622,7 @@
           <p:cNvPr id="17" name="">
             <a:extLst xmlns:a="http://schemas.openxmlformats.org/drawingml/2006/main">
               <a:ext uri="{FF2B5EF4-FFF2-40B4-BE49-F238E27FC236}">
-                <a16:creationId xmlns:a16="http://schemas.microsoft.com/office/drawing/2014/main" id="{52E1B11F-B8BA-4413-83E1-1AAF49E92669}"/>
+                <a16:creationId xmlns:a16="http://schemas.microsoft.com/office/drawing/2014/main" id="{AE7128BE-D405-4D64-916B-46A0B373739E}"/>
               </a:ext>
             </a:extLst>
           </p:cNvPr>
@@ -11653,7 +11653,7 @@
           <p:cNvPr id="18" name="">
             <a:extLst xmlns:a="http://schemas.openxmlformats.org/drawingml/2006/main">
               <a:ext uri="{FF2B5EF4-FFF2-40B4-BE49-F238E27FC236}">
-                <a16:creationId xmlns:a16="http://schemas.microsoft.com/office/drawing/2014/main" id="{5018A589-F461-4A85-8AAD-0AD50A5FCF66}"/>
+                <a16:creationId xmlns:a16="http://schemas.microsoft.com/office/drawing/2014/main" id="{47C7B813-E3F3-41D0-9D18-C92A80381CB0}"/>
               </a:ext>
             </a:extLst>
           </p:cNvPr>
@@ -11774,7 +11774,7 @@
           <p:cNvPr id="19" name="">
             <a:extLst xmlns:a="http://schemas.openxmlformats.org/drawingml/2006/main">
               <a:ext uri="{FF2B5EF4-FFF2-40B4-BE49-F238E27FC236}">
-                <a16:creationId xmlns:a16="http://schemas.microsoft.com/office/drawing/2014/main" id="{DDAB7186-D061-40A9-9F98-3BE7C44D4672}"/>
+                <a16:creationId xmlns:a16="http://schemas.microsoft.com/office/drawing/2014/main" id="{D961B4C9-2F47-47AA-838E-F754A69037E1}"/>
               </a:ext>
             </a:extLst>
           </p:cNvPr>
@@ -11895,7 +11895,7 @@
           <p:cNvPr id="20" name="">
             <a:extLst xmlns:a="http://schemas.openxmlformats.org/drawingml/2006/main">
               <a:ext uri="{FF2B5EF4-FFF2-40B4-BE49-F238E27FC236}">
-                <a16:creationId xmlns:a16="http://schemas.microsoft.com/office/drawing/2014/main" id="{C4F3477D-AA6B-41DE-81BD-DDE42942B5B5}"/>
+                <a16:creationId xmlns:a16="http://schemas.microsoft.com/office/drawing/2014/main" id="{4F9D42A7-05E2-494E-A3BA-180392DF89F2}"/>
               </a:ext>
             </a:extLst>
           </p:cNvPr>
@@ -12016,7 +12016,7 @@
           <p:cNvPr id="21" name="">
             <a:extLst xmlns:a="http://schemas.openxmlformats.org/drawingml/2006/main">
               <a:ext uri="{FF2B5EF4-FFF2-40B4-BE49-F238E27FC236}">
-                <a16:creationId xmlns:a16="http://schemas.microsoft.com/office/drawing/2014/main" id="{0414A6BD-7F68-4A71-B7EC-AB1816B04A42}"/>
+                <a16:creationId xmlns:a16="http://schemas.microsoft.com/office/drawing/2014/main" id="{327427B1-2754-4B30-B913-C5FD233A31FB}"/>
               </a:ext>
             </a:extLst>
           </p:cNvPr>
@@ -12047,7 +12047,7 @@
           <p:cNvPr id="22" name="">
             <a:extLst xmlns:a="http://schemas.openxmlformats.org/drawingml/2006/main">
               <a:ext uri="{FF2B5EF4-FFF2-40B4-BE49-F238E27FC236}">
-                <a16:creationId xmlns:a16="http://schemas.microsoft.com/office/drawing/2014/main" id="{1FD74AFB-0565-4798-B60A-B8D4D673F673}"/>
+                <a16:creationId xmlns:a16="http://schemas.microsoft.com/office/drawing/2014/main" id="{FC0759A7-CD6C-4275-A6A9-D643C75302DD}"/>
               </a:ext>
             </a:extLst>
           </p:cNvPr>
@@ -12168,7 +12168,7 @@
           <p:cNvPr id="23" name="">
             <a:extLst xmlns:a="http://schemas.openxmlformats.org/drawingml/2006/main">
               <a:ext uri="{FF2B5EF4-FFF2-40B4-BE49-F238E27FC236}">
-                <a16:creationId xmlns:a16="http://schemas.microsoft.com/office/drawing/2014/main" id="{7E7C719E-CA5C-426F-812D-F6BE9B560169}"/>
+                <a16:creationId xmlns:a16="http://schemas.microsoft.com/office/drawing/2014/main" id="{6CC39176-DDB1-427E-849A-56F4CF81A6FB}"/>
               </a:ext>
             </a:extLst>
           </p:cNvPr>
@@ -12289,7 +12289,7 @@
           <p:cNvPr id="24" name="">
             <a:extLst xmlns:a="http://schemas.openxmlformats.org/drawingml/2006/main">
               <a:ext uri="{FF2B5EF4-FFF2-40B4-BE49-F238E27FC236}">
-                <a16:creationId xmlns:a16="http://schemas.microsoft.com/office/drawing/2014/main" id="{99B09D49-DFA4-47CC-8D9F-52DB24129E84}"/>
+                <a16:creationId xmlns:a16="http://schemas.microsoft.com/office/drawing/2014/main" id="{0AFF26A4-3DAF-4576-BD7F-582C425EF5DB}"/>
               </a:ext>
             </a:extLst>
           </p:cNvPr>
@@ -12410,7 +12410,7 @@
           <p:cNvPr id="25" name="">
             <a:extLst xmlns:a="http://schemas.openxmlformats.org/drawingml/2006/main">
               <a:ext uri="{FF2B5EF4-FFF2-40B4-BE49-F238E27FC236}">
-                <a16:creationId xmlns:a16="http://schemas.microsoft.com/office/drawing/2014/main" id="{165D3FEF-451B-4797-99DE-2B9650EA5C68}"/>
+                <a16:creationId xmlns:a16="http://schemas.microsoft.com/office/drawing/2014/main" id="{BC48578E-692A-4C07-B04E-01796035DD68}"/>
               </a:ext>
             </a:extLst>
           </p:cNvPr>
@@ -12441,7 +12441,7 @@
           <p:cNvPr id="26" name="">
             <a:extLst xmlns:a="http://schemas.openxmlformats.org/drawingml/2006/main">
               <a:ext uri="{FF2B5EF4-FFF2-40B4-BE49-F238E27FC236}">
-                <a16:creationId xmlns:a16="http://schemas.microsoft.com/office/drawing/2014/main" id="{15AEB148-7F2E-4046-BB06-A60868049532}"/>
+                <a16:creationId xmlns:a16="http://schemas.microsoft.com/office/drawing/2014/main" id="{41D35EE3-E6FA-4A18-882B-DF6BD37BB884}"/>
               </a:ext>
             </a:extLst>
           </p:cNvPr>
@@ -12562,7 +12562,7 @@
           <p:cNvPr id="27" name="">
             <a:extLst xmlns:a="http://schemas.openxmlformats.org/drawingml/2006/main">
               <a:ext uri="{FF2B5EF4-FFF2-40B4-BE49-F238E27FC236}">
-                <a16:creationId xmlns:a16="http://schemas.microsoft.com/office/drawing/2014/main" id="{BD7B6644-1F18-4A17-B8B6-27859D1BFD46}"/>
+                <a16:creationId xmlns:a16="http://schemas.microsoft.com/office/drawing/2014/main" id="{F5BF9643-2912-46D2-80FD-9448ABB924EE}"/>
               </a:ext>
             </a:extLst>
           </p:cNvPr>
@@ -12683,7 +12683,7 @@
           <p:cNvPr id="28" name="">
             <a:extLst xmlns:a="http://schemas.openxmlformats.org/drawingml/2006/main">
               <a:ext uri="{FF2B5EF4-FFF2-40B4-BE49-F238E27FC236}">
-                <a16:creationId xmlns:a16="http://schemas.microsoft.com/office/drawing/2014/main" id="{EDE72933-431A-43E6-B8B7-43473288FC45}"/>
+                <a16:creationId xmlns:a16="http://schemas.microsoft.com/office/drawing/2014/main" id="{63C38EFA-B2F0-456E-B20E-CFF51338D5BB}"/>
               </a:ext>
             </a:extLst>
           </p:cNvPr>
@@ -12804,7 +12804,7 @@
           <p:cNvPr id="29" name="">
             <a:extLst xmlns:a="http://schemas.openxmlformats.org/drawingml/2006/main">
               <a:ext uri="{FF2B5EF4-FFF2-40B4-BE49-F238E27FC236}">
-                <a16:creationId xmlns:a16="http://schemas.microsoft.com/office/drawing/2014/main" id="{84E223B5-08A6-4EEE-8B66-A82E7E6AAF2B}"/>
+                <a16:creationId xmlns:a16="http://schemas.microsoft.com/office/drawing/2014/main" id="{45E7D16B-9B06-4A32-A939-826606EDE119}"/>
               </a:ext>
             </a:extLst>
           </p:cNvPr>
@@ -12835,7 +12835,7 @@
           <p:cNvPr id="30" name="">
             <a:extLst xmlns:a="http://schemas.openxmlformats.org/drawingml/2006/main">
               <a:ext uri="{FF2B5EF4-FFF2-40B4-BE49-F238E27FC236}">
-                <a16:creationId xmlns:a16="http://schemas.microsoft.com/office/drawing/2014/main" id="{CE101335-B99F-4927-9EC7-56FFE4254009}"/>
+                <a16:creationId xmlns:a16="http://schemas.microsoft.com/office/drawing/2014/main" id="{09D06EDB-D0A9-4C56-AD34-800705A9FDF1}"/>
               </a:ext>
             </a:extLst>
           </p:cNvPr>
@@ -12956,7 +12956,7 @@
           <p:cNvPr id="31" name="">
             <a:extLst xmlns:a="http://schemas.openxmlformats.org/drawingml/2006/main">
               <a:ext uri="{FF2B5EF4-FFF2-40B4-BE49-F238E27FC236}">
-                <a16:creationId xmlns:a16="http://schemas.microsoft.com/office/drawing/2014/main" id="{3060BFA2-44D2-4369-AAB0-906970E51D49}"/>
+                <a16:creationId xmlns:a16="http://schemas.microsoft.com/office/drawing/2014/main" id="{1FF8787C-C02A-4B26-9D0B-5FF365A7AD45}"/>
               </a:ext>
             </a:extLst>
           </p:cNvPr>
@@ -13077,7 +13077,7 @@
           <p:cNvPr id="32" name="">
             <a:extLst xmlns:a="http://schemas.openxmlformats.org/drawingml/2006/main">
               <a:ext uri="{FF2B5EF4-FFF2-40B4-BE49-F238E27FC236}">
-                <a16:creationId xmlns:a16="http://schemas.microsoft.com/office/drawing/2014/main" id="{B7D032CA-E73F-4B8D-B553-E1CD09855E5E}"/>
+                <a16:creationId xmlns:a16="http://schemas.microsoft.com/office/drawing/2014/main" id="{80C74E1C-BEE5-4639-9966-F2A45AE9713B}"/>
               </a:ext>
             </a:extLst>
           </p:cNvPr>
@@ -13198,7 +13198,7 @@
           <p:cNvPr id="33" name="">
             <a:extLst xmlns:a="http://schemas.openxmlformats.org/drawingml/2006/main">
               <a:ext uri="{FF2B5EF4-FFF2-40B4-BE49-F238E27FC236}">
-                <a16:creationId xmlns:a16="http://schemas.microsoft.com/office/drawing/2014/main" id="{9B23AB92-BAAC-4AC7-99C2-63742003A29E}"/>
+                <a16:creationId xmlns:a16="http://schemas.microsoft.com/office/drawing/2014/main" id="{E6DAC924-78BC-4015-9487-0BA30C0CD19A}"/>
               </a:ext>
             </a:extLst>
           </p:cNvPr>
@@ -13229,7 +13229,7 @@
           <p:cNvPr id="34" name="">
             <a:extLst xmlns:a="http://schemas.openxmlformats.org/drawingml/2006/main">
               <a:ext uri="{FF2B5EF4-FFF2-40B4-BE49-F238E27FC236}">
-                <a16:creationId xmlns:a16="http://schemas.microsoft.com/office/drawing/2014/main" id="{B0CC26FB-CDA6-4EA2-93B6-BE2BE8B99A1C}"/>
+                <a16:creationId xmlns:a16="http://schemas.microsoft.com/office/drawing/2014/main" id="{3148B485-A6B0-4B37-B4D2-696B616B7FC0}"/>
               </a:ext>
             </a:extLst>
           </p:cNvPr>
@@ -13350,7 +13350,7 @@
           <p:cNvPr id="35" name="">
             <a:extLst xmlns:a="http://schemas.openxmlformats.org/drawingml/2006/main">
               <a:ext uri="{FF2B5EF4-FFF2-40B4-BE49-F238E27FC236}">
-                <a16:creationId xmlns:a16="http://schemas.microsoft.com/office/drawing/2014/main" id="{5698BC8E-E26D-4579-AAD9-7054840EDD3C}"/>
+                <a16:creationId xmlns:a16="http://schemas.microsoft.com/office/drawing/2014/main" id="{E3051CBF-EFCF-4C8E-B29E-1ABE2FD54018}"/>
               </a:ext>
             </a:extLst>
           </p:cNvPr>
@@ -13471,7 +13471,7 @@
           <p:cNvPr id="36" name="">
             <a:extLst xmlns:a="http://schemas.openxmlformats.org/drawingml/2006/main">
               <a:ext uri="{FF2B5EF4-FFF2-40B4-BE49-F238E27FC236}">
-                <a16:creationId xmlns:a16="http://schemas.microsoft.com/office/drawing/2014/main" id="{9956B472-1336-47B5-B09F-B1405F01166E}"/>
+                <a16:creationId xmlns:a16="http://schemas.microsoft.com/office/drawing/2014/main" id="{EA9BC3B5-B8C6-421D-B979-CB297214253F}"/>
               </a:ext>
             </a:extLst>
           </p:cNvPr>
@@ -13592,7 +13592,7 @@
           <p:cNvPr id="37" name="">
             <a:extLst xmlns:a="http://schemas.openxmlformats.org/drawingml/2006/main">
               <a:ext uri="{FF2B5EF4-FFF2-40B4-BE49-F238E27FC236}">
-                <a16:creationId xmlns:a16="http://schemas.microsoft.com/office/drawing/2014/main" id="{983F7D97-361C-42C6-948C-9ABDBCC6E47F}"/>
+                <a16:creationId xmlns:a16="http://schemas.microsoft.com/office/drawing/2014/main" id="{7E9607A3-4ADC-4A17-B6F5-1A65EE10E54E}"/>
               </a:ext>
             </a:extLst>
           </p:cNvPr>
@@ -13623,7 +13623,7 @@
           <p:cNvPr id="38" name="">
             <a:extLst xmlns:a="http://schemas.openxmlformats.org/drawingml/2006/main">
               <a:ext uri="{FF2B5EF4-FFF2-40B4-BE49-F238E27FC236}">
-                <a16:creationId xmlns:a16="http://schemas.microsoft.com/office/drawing/2014/main" id="{AB171A95-EA82-4C79-A13A-47CB10094BED}"/>
+                <a16:creationId xmlns:a16="http://schemas.microsoft.com/office/drawing/2014/main" id="{12E522CF-7834-480B-B37E-82A93B9305D1}"/>
               </a:ext>
             </a:extLst>
           </p:cNvPr>
@@ -13744,7 +13744,7 @@
           <p:cNvPr id="39" name="">
             <a:extLst xmlns:a="http://schemas.openxmlformats.org/drawingml/2006/main">
               <a:ext uri="{FF2B5EF4-FFF2-40B4-BE49-F238E27FC236}">
-                <a16:creationId xmlns:a16="http://schemas.microsoft.com/office/drawing/2014/main" id="{555AD709-AA99-4ECB-8DB4-1048AD968632}"/>
+                <a16:creationId xmlns:a16="http://schemas.microsoft.com/office/drawing/2014/main" id="{6E3FBED5-AD65-4552-9E76-FDA7EC847206}"/>
               </a:ext>
             </a:extLst>
           </p:cNvPr>
@@ -13865,7 +13865,7 @@
           <p:cNvPr id="40" name="">
             <a:extLst xmlns:a="http://schemas.openxmlformats.org/drawingml/2006/main">
               <a:ext uri="{FF2B5EF4-FFF2-40B4-BE49-F238E27FC236}">
-                <a16:creationId xmlns:a16="http://schemas.microsoft.com/office/drawing/2014/main" id="{04631F1B-D665-4EB1-BC59-81BCE55E366D}"/>
+                <a16:creationId xmlns:a16="http://schemas.microsoft.com/office/drawing/2014/main" id="{3D88CA29-491A-4023-8B7B-E218EAC5BA58}"/>
               </a:ext>
             </a:extLst>
           </p:cNvPr>
@@ -13986,7 +13986,7 @@
           <p:cNvPr id="41" name="">
             <a:extLst xmlns:a="http://schemas.openxmlformats.org/drawingml/2006/main">
               <a:ext uri="{FF2B5EF4-FFF2-40B4-BE49-F238E27FC236}">
-                <a16:creationId xmlns:a16="http://schemas.microsoft.com/office/drawing/2014/main" id="{E58318C0-EFF1-41FF-A459-DE2CBDCF7F82}"/>
+                <a16:creationId xmlns:a16="http://schemas.microsoft.com/office/drawing/2014/main" id="{9B9EBD93-28D5-4646-A2AD-C7BB6264582D}"/>
               </a:ext>
             </a:extLst>
           </p:cNvPr>
@@ -14017,7 +14017,7 @@
           <p:cNvPr id="42" name="">
             <a:extLst xmlns:a="http://schemas.openxmlformats.org/drawingml/2006/main">
               <a:ext uri="{FF2B5EF4-FFF2-40B4-BE49-F238E27FC236}">
-                <a16:creationId xmlns:a16="http://schemas.microsoft.com/office/drawing/2014/main" id="{0070F214-2510-41BF-A11C-9FBE19164EAE}"/>
+                <a16:creationId xmlns:a16="http://schemas.microsoft.com/office/drawing/2014/main" id="{970C018E-9826-4E66-B853-FE5245EEE961}"/>
               </a:ext>
             </a:extLst>
           </p:cNvPr>
@@ -14138,7 +14138,7 @@
           <p:cNvPr id="43" name="">
             <a:extLst xmlns:a="http://schemas.openxmlformats.org/drawingml/2006/main">
               <a:ext uri="{FF2B5EF4-FFF2-40B4-BE49-F238E27FC236}">
-                <a16:creationId xmlns:a16="http://schemas.microsoft.com/office/drawing/2014/main" id="{AA276F42-DD48-4C0F-AEC2-E2A7D2E53472}"/>
+                <a16:creationId xmlns:a16="http://schemas.microsoft.com/office/drawing/2014/main" id="{9EF75219-7C3E-4022-9EF4-BFD9CC9411F0}"/>
               </a:ext>
             </a:extLst>
           </p:cNvPr>
@@ -14259,7 +14259,7 @@
           <p:cNvPr id="44" name="">
             <a:extLst xmlns:a="http://schemas.openxmlformats.org/drawingml/2006/main">
               <a:ext uri="{FF2B5EF4-FFF2-40B4-BE49-F238E27FC236}">
-                <a16:creationId xmlns:a16="http://schemas.microsoft.com/office/drawing/2014/main" id="{83AE9CEB-D4F9-40E1-BB42-080A5DDFAC01}"/>
+                <a16:creationId xmlns:a16="http://schemas.microsoft.com/office/drawing/2014/main" id="{BDE03DF0-6576-44B4-8C1B-198C60EB33C5}"/>
               </a:ext>
             </a:extLst>
           </p:cNvPr>
@@ -14380,7 +14380,7 @@
           <p:cNvPr id="45" name="">
             <a:extLst xmlns:a="http://schemas.openxmlformats.org/drawingml/2006/main">
               <a:ext uri="{FF2B5EF4-FFF2-40B4-BE49-F238E27FC236}">
-                <a16:creationId xmlns:a16="http://schemas.microsoft.com/office/drawing/2014/main" id="{EA7B1725-DF36-4FF4-AC64-CD295415182E}"/>
+                <a16:creationId xmlns:a16="http://schemas.microsoft.com/office/drawing/2014/main" id="{3E6BFB82-69BD-456E-AB0B-FBD4BFB134DD}"/>
               </a:ext>
             </a:extLst>
           </p:cNvPr>
@@ -14411,7 +14411,7 @@
           <p:cNvPr id="46" name="">
             <a:extLst xmlns:a="http://schemas.openxmlformats.org/drawingml/2006/main">
               <a:ext uri="{FF2B5EF4-FFF2-40B4-BE49-F238E27FC236}">
-                <a16:creationId xmlns:a16="http://schemas.microsoft.com/office/drawing/2014/main" id="{B68D816C-B335-4F3D-811B-A62A01BBF3A1}"/>
+                <a16:creationId xmlns:a16="http://schemas.microsoft.com/office/drawing/2014/main" id="{669AF017-90AD-4899-A3C1-09225D4E6B4D}"/>
               </a:ext>
             </a:extLst>
           </p:cNvPr>
@@ -14532,7 +14532,7 @@
           <p:cNvPr id="47" name="">
             <a:extLst xmlns:a="http://schemas.openxmlformats.org/drawingml/2006/main">
               <a:ext uri="{FF2B5EF4-FFF2-40B4-BE49-F238E27FC236}">
-                <a16:creationId xmlns:a16="http://schemas.microsoft.com/office/drawing/2014/main" id="{B42DED40-F64D-476A-9C42-E2F6F0598D06}"/>
+                <a16:creationId xmlns:a16="http://schemas.microsoft.com/office/drawing/2014/main" id="{88BC4CD8-B12D-4CE6-AB8A-F53BF4EE5B74}"/>
               </a:ext>
             </a:extLst>
           </p:cNvPr>
@@ -14653,7 +14653,7 @@
           <p:cNvPr id="48" name="">
             <a:extLst xmlns:a="http://schemas.openxmlformats.org/drawingml/2006/main">
               <a:ext uri="{FF2B5EF4-FFF2-40B4-BE49-F238E27FC236}">
-                <a16:creationId xmlns:a16="http://schemas.microsoft.com/office/drawing/2014/main" id="{386027A7-1B20-432D-B94E-9E9570C51269}"/>
+                <a16:creationId xmlns:a16="http://schemas.microsoft.com/office/drawing/2014/main" id="{C1621DD9-C874-4F80-96DD-5817719E64E6}"/>
               </a:ext>
             </a:extLst>
           </p:cNvPr>
@@ -14774,7 +14774,7 @@
           <p:cNvPr id="49" name="">
             <a:extLst xmlns:a="http://schemas.openxmlformats.org/drawingml/2006/main">
               <a:ext uri="{FF2B5EF4-FFF2-40B4-BE49-F238E27FC236}">
-                <a16:creationId xmlns:a16="http://schemas.microsoft.com/office/drawing/2014/main" id="{515C59B2-7712-4573-A824-17E7F04147D4}"/>
+                <a16:creationId xmlns:a16="http://schemas.microsoft.com/office/drawing/2014/main" id="{4379DB86-4942-4425-8397-B081F1690300}"/>
               </a:ext>
             </a:extLst>
           </p:cNvPr>
@@ -14805,7 +14805,7 @@
           <p:cNvPr id="50" name="">
             <a:extLst xmlns:a="http://schemas.openxmlformats.org/drawingml/2006/main">
               <a:ext uri="{FF2B5EF4-FFF2-40B4-BE49-F238E27FC236}">
-                <a16:creationId xmlns:a16="http://schemas.microsoft.com/office/drawing/2014/main" id="{CC922F8F-E0CD-4224-9A76-E00ED620EB28}"/>
+                <a16:creationId xmlns:a16="http://schemas.microsoft.com/office/drawing/2014/main" id="{D6F15EED-AC8D-4286-92E2-D0B83F2A674D}"/>
               </a:ext>
             </a:extLst>
           </p:cNvPr>
@@ -14926,7 +14926,7 @@
           <p:cNvPr id="51" name="">
             <a:extLst xmlns:a="http://schemas.openxmlformats.org/drawingml/2006/main">
               <a:ext uri="{FF2B5EF4-FFF2-40B4-BE49-F238E27FC236}">
-                <a16:creationId xmlns:a16="http://schemas.microsoft.com/office/drawing/2014/main" id="{FE7EFED0-C96F-4A01-98DE-2BF581CF8EAC}"/>
+                <a16:creationId xmlns:a16="http://schemas.microsoft.com/office/drawing/2014/main" id="{E4A2C01E-F449-4AED-8692-C2665243BFA6}"/>
               </a:ext>
             </a:extLst>
           </p:cNvPr>
@@ -15047,7 +15047,7 @@
           <p:cNvPr id="52" name="">
             <a:extLst xmlns:a="http://schemas.openxmlformats.org/drawingml/2006/main">
               <a:ext uri="{FF2B5EF4-FFF2-40B4-BE49-F238E27FC236}">
-                <a16:creationId xmlns:a16="http://schemas.microsoft.com/office/drawing/2014/main" id="{981B32BD-21A8-47EB-B470-69DF4C503246}"/>
+                <a16:creationId xmlns:a16="http://schemas.microsoft.com/office/drawing/2014/main" id="{2F30FA60-E732-4FCB-A44B-BDD8E4B01E86}"/>
               </a:ext>
             </a:extLst>
           </p:cNvPr>
@@ -15166,7 +15166,7 @@
     </p:spTree>
     <p:extLst>
       <p:ext uri="{BB962C8B-B14F-4D97-AF65-F5344CB8AC3E}">
-        <p14:creationId xmlns:p14="http://schemas.microsoft.com/office/powerpoint/2010/main" val="1267723403"/>
+        <p14:creationId xmlns:p14="http://schemas.microsoft.com/office/powerpoint/2010/main" val="353316572"/>
       </p:ext>
     </p:extLst>
   </p:cSld>
@@ -15197,7 +15197,7 @@
           <p:cNvPr id="57" name="">
             <a:extLst xmlns:a="http://schemas.openxmlformats.org/drawingml/2006/main">
               <a:ext uri="{FF2B5EF4-FFF2-40B4-BE49-F238E27FC236}">
-                <a16:creationId xmlns:a16="http://schemas.microsoft.com/office/drawing/2014/main" id="{A4BA8D3D-991F-417C-87DB-BC7D5CA6A211}"/>
+                <a16:creationId xmlns:a16="http://schemas.microsoft.com/office/drawing/2014/main" id="{FA0FFC1E-94D3-4FEB-B90B-792214A5B45D}"/>
               </a:ext>
             </a:extLst>
           </p:cNvPr>
@@ -15228,7 +15228,7 @@
           <p:cNvPr id="2" name="">
             <a:extLst xmlns:a="http://schemas.openxmlformats.org/drawingml/2006/main">
               <a:ext uri="{FF2B5EF4-FFF2-40B4-BE49-F238E27FC236}">
-                <a16:creationId xmlns:a16="http://schemas.microsoft.com/office/drawing/2014/main" id="{76D748D5-F4C3-4B54-992A-EBFD4A53BF6D}"/>
+                <a16:creationId xmlns:a16="http://schemas.microsoft.com/office/drawing/2014/main" id="{ECA6DBCB-FC24-4EF4-AD0F-7E0C18B4713A}"/>
               </a:ext>
             </a:extLst>
           </p:cNvPr>
@@ -15349,7 +15349,7 @@
           <p:cNvPr id="3" name="">
             <a:extLst xmlns:a="http://schemas.openxmlformats.org/drawingml/2006/main">
               <a:ext uri="{FF2B5EF4-FFF2-40B4-BE49-F238E27FC236}">
-                <a16:creationId xmlns:a16="http://schemas.microsoft.com/office/drawing/2014/main" id="{01F9ECF7-104B-41B0-9778-861377D30620}"/>
+                <a16:creationId xmlns:a16="http://schemas.microsoft.com/office/drawing/2014/main" id="{B1B2E27E-376F-4885-86BF-A11F74BD853C}"/>
               </a:ext>
             </a:extLst>
           </p:cNvPr>
@@ -15470,7 +15470,7 @@
           <p:cNvPr id="4" name="">
             <a:extLst xmlns:a="http://schemas.openxmlformats.org/drawingml/2006/main">
               <a:ext uri="{FF2B5EF4-FFF2-40B4-BE49-F238E27FC236}">
-                <a16:creationId xmlns:a16="http://schemas.microsoft.com/office/drawing/2014/main" id="{54A562A9-7BFD-4FA3-925C-DC888BA4FC0B}"/>
+                <a16:creationId xmlns:a16="http://schemas.microsoft.com/office/drawing/2014/main" id="{5AE82F66-9EDC-4820-8529-884218DAC94A}"/>
               </a:ext>
             </a:extLst>
           </p:cNvPr>
@@ -15501,7 +15501,7 @@
           <p:cNvPr id="5" name="">
             <a:extLst xmlns:a="http://schemas.openxmlformats.org/drawingml/2006/main">
               <a:ext uri="{FF2B5EF4-FFF2-40B4-BE49-F238E27FC236}">
-                <a16:creationId xmlns:a16="http://schemas.microsoft.com/office/drawing/2014/main" id="{45713258-CC6A-435F-9BCE-89A2217641B6}"/>
+                <a16:creationId xmlns:a16="http://schemas.microsoft.com/office/drawing/2014/main" id="{E1063AE8-9F11-4989-9FB3-14772BB9B79A}"/>
               </a:ext>
             </a:extLst>
           </p:cNvPr>
@@ -15622,7 +15622,7 @@
           <p:cNvPr id="6" name="">
             <a:extLst xmlns:a="http://schemas.openxmlformats.org/drawingml/2006/main">
               <a:ext uri="{FF2B5EF4-FFF2-40B4-BE49-F238E27FC236}">
-                <a16:creationId xmlns:a16="http://schemas.microsoft.com/office/drawing/2014/main" id="{25C43895-E1BF-436A-959A-6A30AEF9D467}"/>
+                <a16:creationId xmlns:a16="http://schemas.microsoft.com/office/drawing/2014/main" id="{F007D3DC-D568-481D-8DC4-13FF87E2085D}"/>
               </a:ext>
             </a:extLst>
           </p:cNvPr>
@@ -15743,7 +15743,7 @@
           <p:cNvPr id="7" name="">
             <a:extLst xmlns:a="http://schemas.openxmlformats.org/drawingml/2006/main">
               <a:ext uri="{FF2B5EF4-FFF2-40B4-BE49-F238E27FC236}">
-                <a16:creationId xmlns:a16="http://schemas.microsoft.com/office/drawing/2014/main" id="{DE791755-869B-4850-AF10-797B95FF8D63}"/>
+                <a16:creationId xmlns:a16="http://schemas.microsoft.com/office/drawing/2014/main" id="{3B12A4F9-FD0A-442B-A49C-1D470840391F}"/>
               </a:ext>
             </a:extLst>
           </p:cNvPr>
@@ -15864,7 +15864,7 @@
           <p:cNvPr id="8" name="">
             <a:extLst xmlns:a="http://schemas.openxmlformats.org/drawingml/2006/main">
               <a:ext uri="{FF2B5EF4-FFF2-40B4-BE49-F238E27FC236}">
-                <a16:creationId xmlns:a16="http://schemas.microsoft.com/office/drawing/2014/main" id="{92FEC065-1929-47F7-ABB1-15AB7D99211E}"/>
+                <a16:creationId xmlns:a16="http://schemas.microsoft.com/office/drawing/2014/main" id="{69786949-49FF-460A-9090-543B473067C6}"/>
               </a:ext>
             </a:extLst>
           </p:cNvPr>
@@ -15985,7 +15985,7 @@
           <p:cNvPr id="9" name="">
             <a:extLst xmlns:a="http://schemas.openxmlformats.org/drawingml/2006/main">
               <a:ext uri="{FF2B5EF4-FFF2-40B4-BE49-F238E27FC236}">
-                <a16:creationId xmlns:a16="http://schemas.microsoft.com/office/drawing/2014/main" id="{725DA63D-5666-4589-BD38-A671CF174482}"/>
+                <a16:creationId xmlns:a16="http://schemas.microsoft.com/office/drawing/2014/main" id="{549261E8-DD0D-4BD1-8AAC-B178225C28E0}"/>
               </a:ext>
             </a:extLst>
           </p:cNvPr>
@@ -16016,7 +16016,7 @@
           <p:cNvPr id="10" name="">
             <a:extLst xmlns:a="http://schemas.openxmlformats.org/drawingml/2006/main">
               <a:ext uri="{FF2B5EF4-FFF2-40B4-BE49-F238E27FC236}">
-                <a16:creationId xmlns:a16="http://schemas.microsoft.com/office/drawing/2014/main" id="{59466A98-5DDB-4667-9AD9-9EAA6AA7B18A}"/>
+                <a16:creationId xmlns:a16="http://schemas.microsoft.com/office/drawing/2014/main" id="{8E48C048-EA82-48EF-8CA7-A9130E070E00}"/>
               </a:ext>
             </a:extLst>
           </p:cNvPr>
@@ -16137,7 +16137,7 @@
           <p:cNvPr id="11" name="">
             <a:extLst xmlns:a="http://schemas.openxmlformats.org/drawingml/2006/main">
               <a:ext uri="{FF2B5EF4-FFF2-40B4-BE49-F238E27FC236}">
-                <a16:creationId xmlns:a16="http://schemas.microsoft.com/office/drawing/2014/main" id="{E577B374-C0B2-4780-82C6-5247A0B1AF0E}"/>
+                <a16:creationId xmlns:a16="http://schemas.microsoft.com/office/drawing/2014/main" id="{F583D71A-CEE6-491E-B620-FB690D20B3F3}"/>
               </a:ext>
             </a:extLst>
           </p:cNvPr>
@@ -16258,7 +16258,7 @@
           <p:cNvPr id="12" name="">
             <a:extLst xmlns:a="http://schemas.openxmlformats.org/drawingml/2006/main">
               <a:ext uri="{FF2B5EF4-FFF2-40B4-BE49-F238E27FC236}">
-                <a16:creationId xmlns:a16="http://schemas.microsoft.com/office/drawing/2014/main" id="{14A0B8A0-8BF7-4DEF-A0EA-8E575B750A26}"/>
+                <a16:creationId xmlns:a16="http://schemas.microsoft.com/office/drawing/2014/main" id="{EF36E3B5-BCB5-48B7-9C96-DDE57AD88C37}"/>
               </a:ext>
             </a:extLst>
           </p:cNvPr>
@@ -16379,7 +16379,7 @@
           <p:cNvPr id="13" name="">
             <a:extLst xmlns:a="http://schemas.openxmlformats.org/drawingml/2006/main">
               <a:ext uri="{FF2B5EF4-FFF2-40B4-BE49-F238E27FC236}">
-                <a16:creationId xmlns:a16="http://schemas.microsoft.com/office/drawing/2014/main" id="{B5669B29-E1B3-4321-A5D4-CEC0C74E15B5}"/>
+                <a16:creationId xmlns:a16="http://schemas.microsoft.com/office/drawing/2014/main" id="{06FA980B-38A8-4BF1-8685-EE4D2BB001E9}"/>
               </a:ext>
             </a:extLst>
           </p:cNvPr>
@@ -16410,7 +16410,7 @@
           <p:cNvPr id="14" name="">
             <a:extLst xmlns:a="http://schemas.openxmlformats.org/drawingml/2006/main">
               <a:ext uri="{FF2B5EF4-FFF2-40B4-BE49-F238E27FC236}">
-                <a16:creationId xmlns:a16="http://schemas.microsoft.com/office/drawing/2014/main" id="{EAD5C7BC-FBFE-49D9-BB5C-A01E9F7D2CE2}"/>
+                <a16:creationId xmlns:a16="http://schemas.microsoft.com/office/drawing/2014/main" id="{5BC9A211-02DA-412D-9D6A-EB421773A4CE}"/>
               </a:ext>
             </a:extLst>
           </p:cNvPr>
@@ -16531,7 +16531,7 @@
           <p:cNvPr id="15" name="">
             <a:extLst xmlns:a="http://schemas.openxmlformats.org/drawingml/2006/main">
               <a:ext uri="{FF2B5EF4-FFF2-40B4-BE49-F238E27FC236}">
-                <a16:creationId xmlns:a16="http://schemas.microsoft.com/office/drawing/2014/main" id="{284F9EBB-99A5-4B4B-B6D3-211FD18C828C}"/>
+                <a16:creationId xmlns:a16="http://schemas.microsoft.com/office/drawing/2014/main" id="{5DCC0595-89D8-488B-8C0F-A9D58D9865C9}"/>
               </a:ext>
             </a:extLst>
           </p:cNvPr>
@@ -16652,7 +16652,7 @@
           <p:cNvPr id="16" name="">
             <a:extLst xmlns:a="http://schemas.openxmlformats.org/drawingml/2006/main">
               <a:ext uri="{FF2B5EF4-FFF2-40B4-BE49-F238E27FC236}">
-                <a16:creationId xmlns:a16="http://schemas.microsoft.com/office/drawing/2014/main" id="{92186C7B-7B8E-4677-B8D1-C4556508EF5F}"/>
+                <a16:creationId xmlns:a16="http://schemas.microsoft.com/office/drawing/2014/main" id="{EDDADD60-9146-46E8-B010-820B06317FBE}"/>
               </a:ext>
             </a:extLst>
           </p:cNvPr>
@@ -16773,7 +16773,7 @@
           <p:cNvPr id="17" name="">
             <a:extLst xmlns:a="http://schemas.openxmlformats.org/drawingml/2006/main">
               <a:ext uri="{FF2B5EF4-FFF2-40B4-BE49-F238E27FC236}">
-                <a16:creationId xmlns:a16="http://schemas.microsoft.com/office/drawing/2014/main" id="{C56A28F7-0AC0-47D5-B43C-75343CD14D17}"/>
+                <a16:creationId xmlns:a16="http://schemas.microsoft.com/office/drawing/2014/main" id="{A33AA8C1-BDE7-4944-818C-7F8F9853B784}"/>
               </a:ext>
             </a:extLst>
           </p:cNvPr>
@@ -16804,7 +16804,7 @@
           <p:cNvPr id="18" name="">
             <a:extLst xmlns:a="http://schemas.openxmlformats.org/drawingml/2006/main">
               <a:ext uri="{FF2B5EF4-FFF2-40B4-BE49-F238E27FC236}">
-                <a16:creationId xmlns:a16="http://schemas.microsoft.com/office/drawing/2014/main" id="{48A0DA06-0D6A-44EA-A9D2-6F2F05D92CC1}"/>
+                <a16:creationId xmlns:a16="http://schemas.microsoft.com/office/drawing/2014/main" id="{5EAC0E71-5D20-428E-A5DC-B22DF2AF28CD}"/>
               </a:ext>
             </a:extLst>
           </p:cNvPr>
@@ -16925,7 +16925,7 @@
           <p:cNvPr id="19" name="">
             <a:extLst xmlns:a="http://schemas.openxmlformats.org/drawingml/2006/main">
               <a:ext uri="{FF2B5EF4-FFF2-40B4-BE49-F238E27FC236}">
-                <a16:creationId xmlns:a16="http://schemas.microsoft.com/office/drawing/2014/main" id="{382C1E5C-C72B-4E1C-8F9C-290DE897B671}"/>
+                <a16:creationId xmlns:a16="http://schemas.microsoft.com/office/drawing/2014/main" id="{C783E235-F2B6-47EE-A4F5-0C967CE8AD3D}"/>
               </a:ext>
             </a:extLst>
           </p:cNvPr>
@@ -17046,7 +17046,7 @@
           <p:cNvPr id="20" name="">
             <a:extLst xmlns:a="http://schemas.openxmlformats.org/drawingml/2006/main">
               <a:ext uri="{FF2B5EF4-FFF2-40B4-BE49-F238E27FC236}">
-                <a16:creationId xmlns:a16="http://schemas.microsoft.com/office/drawing/2014/main" id="{CA4FBF84-9634-4AF0-A0CB-7DD9F1992D14}"/>
+                <a16:creationId xmlns:a16="http://schemas.microsoft.com/office/drawing/2014/main" id="{59D2F00A-E7CC-4455-B396-2BFF531FAE5A}"/>
               </a:ext>
             </a:extLst>
           </p:cNvPr>
@@ -17167,7 +17167,7 @@
           <p:cNvPr id="21" name="">
             <a:extLst xmlns:a="http://schemas.openxmlformats.org/drawingml/2006/main">
               <a:ext uri="{FF2B5EF4-FFF2-40B4-BE49-F238E27FC236}">
-                <a16:creationId xmlns:a16="http://schemas.microsoft.com/office/drawing/2014/main" id="{0C94EA9C-6D16-4194-A5DE-A9DD3A7D8783}"/>
+                <a16:creationId xmlns:a16="http://schemas.microsoft.com/office/drawing/2014/main" id="{6DFED2CE-C30B-49D6-8D6F-6CC823C4E3AC}"/>
               </a:ext>
             </a:extLst>
           </p:cNvPr>
@@ -17198,7 +17198,7 @@
           <p:cNvPr id="22" name="">
             <a:extLst xmlns:a="http://schemas.openxmlformats.org/drawingml/2006/main">
               <a:ext uri="{FF2B5EF4-FFF2-40B4-BE49-F238E27FC236}">
-                <a16:creationId xmlns:a16="http://schemas.microsoft.com/office/drawing/2014/main" id="{9AE710FD-5E5C-40A4-BD45-ED8C951E3254}"/>
+                <a16:creationId xmlns:a16="http://schemas.microsoft.com/office/drawing/2014/main" id="{AC2CB2E2-9379-472D-BA0F-DB43E79BD21F}"/>
               </a:ext>
             </a:extLst>
           </p:cNvPr>
@@ -17319,7 +17319,7 @@
           <p:cNvPr id="23" name="">
             <a:extLst xmlns:a="http://schemas.openxmlformats.org/drawingml/2006/main">
               <a:ext uri="{FF2B5EF4-FFF2-40B4-BE49-F238E27FC236}">
-                <a16:creationId xmlns:a16="http://schemas.microsoft.com/office/drawing/2014/main" id="{A29AC66F-2CB6-4450-9342-B49551977DC2}"/>
+                <a16:creationId xmlns:a16="http://schemas.microsoft.com/office/drawing/2014/main" id="{92A5618D-FB78-48E6-B8F5-DB592B6E3264}"/>
               </a:ext>
             </a:extLst>
           </p:cNvPr>
@@ -17440,7 +17440,7 @@
           <p:cNvPr id="24" name="">
             <a:extLst xmlns:a="http://schemas.openxmlformats.org/drawingml/2006/main">
               <a:ext uri="{FF2B5EF4-FFF2-40B4-BE49-F238E27FC236}">
-                <a16:creationId xmlns:a16="http://schemas.microsoft.com/office/drawing/2014/main" id="{93D2F337-235C-46FC-B53E-EB97BFBC5DAA}"/>
+                <a16:creationId xmlns:a16="http://schemas.microsoft.com/office/drawing/2014/main" id="{D5A31ABA-962B-4F8D-8EE1-C4BFE89770FC}"/>
               </a:ext>
             </a:extLst>
           </p:cNvPr>
@@ -17561,7 +17561,7 @@
           <p:cNvPr id="25" name="">
             <a:extLst xmlns:a="http://schemas.openxmlformats.org/drawingml/2006/main">
               <a:ext uri="{FF2B5EF4-FFF2-40B4-BE49-F238E27FC236}">
-                <a16:creationId xmlns:a16="http://schemas.microsoft.com/office/drawing/2014/main" id="{EB7D733B-0F06-4B19-B079-C05FBD3EF5DD}"/>
+                <a16:creationId xmlns:a16="http://schemas.microsoft.com/office/drawing/2014/main" id="{02D581B3-B0E2-4261-86A6-9F81336CE8AF}"/>
               </a:ext>
             </a:extLst>
           </p:cNvPr>
@@ -17592,7 +17592,7 @@
           <p:cNvPr id="26" name="">
             <a:extLst xmlns:a="http://schemas.openxmlformats.org/drawingml/2006/main">
               <a:ext uri="{FF2B5EF4-FFF2-40B4-BE49-F238E27FC236}">
-                <a16:creationId xmlns:a16="http://schemas.microsoft.com/office/drawing/2014/main" id="{E7A13059-D6BF-4CAF-9C5E-0783F78E90F0}"/>
+                <a16:creationId xmlns:a16="http://schemas.microsoft.com/office/drawing/2014/main" id="{D97B70C0-C986-4704-AD3B-34A8B729CFED}"/>
               </a:ext>
             </a:extLst>
           </p:cNvPr>
@@ -17713,7 +17713,7 @@
           <p:cNvPr id="27" name="">
             <a:extLst xmlns:a="http://schemas.openxmlformats.org/drawingml/2006/main">
               <a:ext uri="{FF2B5EF4-FFF2-40B4-BE49-F238E27FC236}">
-                <a16:creationId xmlns:a16="http://schemas.microsoft.com/office/drawing/2014/main" id="{503D4838-F930-4645-8B32-67885C1BF407}"/>
+                <a16:creationId xmlns:a16="http://schemas.microsoft.com/office/drawing/2014/main" id="{542AA924-8BFF-4DB8-842E-29BF3F6F9076}"/>
               </a:ext>
             </a:extLst>
           </p:cNvPr>
@@ -17834,7 +17834,7 @@
           <p:cNvPr id="28" name="">
             <a:extLst xmlns:a="http://schemas.openxmlformats.org/drawingml/2006/main">
               <a:ext uri="{FF2B5EF4-FFF2-40B4-BE49-F238E27FC236}">
-                <a16:creationId xmlns:a16="http://schemas.microsoft.com/office/drawing/2014/main" id="{91939585-7893-45A1-BD48-E3B8D7CE74DD}"/>
+                <a16:creationId xmlns:a16="http://schemas.microsoft.com/office/drawing/2014/main" id="{FA51F396-EFB5-4C54-BA40-0FB7B6532000}"/>
               </a:ext>
             </a:extLst>
           </p:cNvPr>
@@ -17955,7 +17955,7 @@
           <p:cNvPr id="29" name="">
             <a:extLst xmlns:a="http://schemas.openxmlformats.org/drawingml/2006/main">
               <a:ext uri="{FF2B5EF4-FFF2-40B4-BE49-F238E27FC236}">
-                <a16:creationId xmlns:a16="http://schemas.microsoft.com/office/drawing/2014/main" id="{AA5A3BBA-FA87-4B32-B359-6FBC02580FA9}"/>
+                <a16:creationId xmlns:a16="http://schemas.microsoft.com/office/drawing/2014/main" id="{AD1CC2E4-3004-4769-AC79-5AB4E9A8913E}"/>
               </a:ext>
             </a:extLst>
           </p:cNvPr>
@@ -17986,7 +17986,7 @@
           <p:cNvPr id="30" name="">
             <a:extLst xmlns:a="http://schemas.openxmlformats.org/drawingml/2006/main">
               <a:ext uri="{FF2B5EF4-FFF2-40B4-BE49-F238E27FC236}">
-                <a16:creationId xmlns:a16="http://schemas.microsoft.com/office/drawing/2014/main" id="{63E8763F-6200-4F55-A76F-C56CA771C849}"/>
+                <a16:creationId xmlns:a16="http://schemas.microsoft.com/office/drawing/2014/main" id="{80C61055-096C-4A2C-8D00-04ECBCB0EAD6}"/>
               </a:ext>
             </a:extLst>
           </p:cNvPr>
@@ -18107,7 +18107,7 @@
           <p:cNvPr id="31" name="">
             <a:extLst xmlns:a="http://schemas.openxmlformats.org/drawingml/2006/main">
               <a:ext uri="{FF2B5EF4-FFF2-40B4-BE49-F238E27FC236}">
-                <a16:creationId xmlns:a16="http://schemas.microsoft.com/office/drawing/2014/main" id="{5C7D19E9-47D7-4C40-9493-67E20F524FE3}"/>
+                <a16:creationId xmlns:a16="http://schemas.microsoft.com/office/drawing/2014/main" id="{60CDAF3E-D07D-4B66-BF42-B93F1C577613}"/>
               </a:ext>
             </a:extLst>
           </p:cNvPr>
@@ -18228,7 +18228,7 @@
           <p:cNvPr id="32" name="">
             <a:extLst xmlns:a="http://schemas.openxmlformats.org/drawingml/2006/main">
               <a:ext uri="{FF2B5EF4-FFF2-40B4-BE49-F238E27FC236}">
-                <a16:creationId xmlns:a16="http://schemas.microsoft.com/office/drawing/2014/main" id="{7C6CF4EE-22C9-4FF3-BA18-E9DC033BFDF0}"/>
+                <a16:creationId xmlns:a16="http://schemas.microsoft.com/office/drawing/2014/main" id="{3034F5B0-1FAF-437B-98F6-619FE52BBF60}"/>
               </a:ext>
             </a:extLst>
           </p:cNvPr>
@@ -18349,7 +18349,7 @@
           <p:cNvPr id="33" name="">
             <a:extLst xmlns:a="http://schemas.openxmlformats.org/drawingml/2006/main">
               <a:ext uri="{FF2B5EF4-FFF2-40B4-BE49-F238E27FC236}">
-                <a16:creationId xmlns:a16="http://schemas.microsoft.com/office/drawing/2014/main" id="{572C3E13-A6C4-40B3-BC91-18A4076B799F}"/>
+                <a16:creationId xmlns:a16="http://schemas.microsoft.com/office/drawing/2014/main" id="{ECC6761D-3D8B-42FD-BCAB-32D67F2EF68C}"/>
               </a:ext>
             </a:extLst>
           </p:cNvPr>
@@ -18380,7 +18380,7 @@
           <p:cNvPr id="34" name="">
             <a:extLst xmlns:a="http://schemas.openxmlformats.org/drawingml/2006/main">
               <a:ext uri="{FF2B5EF4-FFF2-40B4-BE49-F238E27FC236}">
-                <a16:creationId xmlns:a16="http://schemas.microsoft.com/office/drawing/2014/main" id="{BC988926-3085-486B-BC4C-346C4B69C83A}"/>
+                <a16:creationId xmlns:a16="http://schemas.microsoft.com/office/drawing/2014/main" id="{5304F9A5-9A48-413C-BB78-CD4199582AB2}"/>
               </a:ext>
             </a:extLst>
           </p:cNvPr>
@@ -18501,7 +18501,7 @@
           <p:cNvPr id="35" name="">
             <a:extLst xmlns:a="http://schemas.openxmlformats.org/drawingml/2006/main">
               <a:ext uri="{FF2B5EF4-FFF2-40B4-BE49-F238E27FC236}">
-                <a16:creationId xmlns:a16="http://schemas.microsoft.com/office/drawing/2014/main" id="{EB1E5BE1-8AB2-415A-B520-197431F51E3B}"/>
+                <a16:creationId xmlns:a16="http://schemas.microsoft.com/office/drawing/2014/main" id="{E9C19D9F-9227-4007-A13F-B00B26729DB5}"/>
               </a:ext>
             </a:extLst>
           </p:cNvPr>
@@ -18622,7 +18622,7 @@
           <p:cNvPr id="36" name="">
             <a:extLst xmlns:a="http://schemas.openxmlformats.org/drawingml/2006/main">
               <a:ext uri="{FF2B5EF4-FFF2-40B4-BE49-F238E27FC236}">
-                <a16:creationId xmlns:a16="http://schemas.microsoft.com/office/drawing/2014/main" id="{70970689-1F62-4196-8710-3BE7C6341B0F}"/>
+                <a16:creationId xmlns:a16="http://schemas.microsoft.com/office/drawing/2014/main" id="{F08FEA01-9046-4A8A-8DF3-86536893C86D}"/>
               </a:ext>
             </a:extLst>
           </p:cNvPr>
@@ -18743,7 +18743,7 @@
           <p:cNvPr id="37" name="">
             <a:extLst xmlns:a="http://schemas.openxmlformats.org/drawingml/2006/main">
               <a:ext uri="{FF2B5EF4-FFF2-40B4-BE49-F238E27FC236}">
-                <a16:creationId xmlns:a16="http://schemas.microsoft.com/office/drawing/2014/main" id="{A9311F2A-1018-4439-A3D8-2E2587EA17B4}"/>
+                <a16:creationId xmlns:a16="http://schemas.microsoft.com/office/drawing/2014/main" id="{964CE1BB-BF5F-460B-8A7C-F0B9E91CDF5F}"/>
               </a:ext>
             </a:extLst>
           </p:cNvPr>
@@ -18774,7 +18774,7 @@
           <p:cNvPr id="38" name="">
             <a:extLst xmlns:a="http://schemas.openxmlformats.org/drawingml/2006/main">
               <a:ext uri="{FF2B5EF4-FFF2-40B4-BE49-F238E27FC236}">
-                <a16:creationId xmlns:a16="http://schemas.microsoft.com/office/drawing/2014/main" id="{7231884E-F749-4F09-BBC3-072F61DF3209}"/>
+                <a16:creationId xmlns:a16="http://schemas.microsoft.com/office/drawing/2014/main" id="{9B9FC297-3D18-4CAC-9520-D44D62B2AFCF}"/>
               </a:ext>
             </a:extLst>
           </p:cNvPr>
@@ -18895,7 +18895,7 @@
           <p:cNvPr id="39" name="">
             <a:extLst xmlns:a="http://schemas.openxmlformats.org/drawingml/2006/main">
               <a:ext uri="{FF2B5EF4-FFF2-40B4-BE49-F238E27FC236}">
-                <a16:creationId xmlns:a16="http://schemas.microsoft.com/office/drawing/2014/main" id="{EC772EAC-C22B-4D4C-B531-0A5357733627}"/>
+                <a16:creationId xmlns:a16="http://schemas.microsoft.com/office/drawing/2014/main" id="{9C889D90-D928-4A84-AB9B-64B97CF82C39}"/>
               </a:ext>
             </a:extLst>
           </p:cNvPr>
@@ -19016,7 +19016,7 @@
           <p:cNvPr id="40" name="">
             <a:extLst xmlns:a="http://schemas.openxmlformats.org/drawingml/2006/main">
               <a:ext uri="{FF2B5EF4-FFF2-40B4-BE49-F238E27FC236}">
-                <a16:creationId xmlns:a16="http://schemas.microsoft.com/office/drawing/2014/main" id="{A447E5B5-D860-4749-9BB4-3256DD3FCCBE}"/>
+                <a16:creationId xmlns:a16="http://schemas.microsoft.com/office/drawing/2014/main" id="{0CE1A8BD-2D4C-47C3-8B59-5AFF4A550531}"/>
               </a:ext>
             </a:extLst>
           </p:cNvPr>
@@ -19137,7 +19137,7 @@
           <p:cNvPr id="41" name="">
             <a:extLst xmlns:a="http://schemas.openxmlformats.org/drawingml/2006/main">
               <a:ext uri="{FF2B5EF4-FFF2-40B4-BE49-F238E27FC236}">
-                <a16:creationId xmlns:a16="http://schemas.microsoft.com/office/drawing/2014/main" id="{26F06E66-A9D7-46EF-A9E9-9464CFC48D1B}"/>
+                <a16:creationId xmlns:a16="http://schemas.microsoft.com/office/drawing/2014/main" id="{A7F93ACC-EF31-4882-8799-0E6FEB62FD1D}"/>
               </a:ext>
             </a:extLst>
           </p:cNvPr>
@@ -19168,7 +19168,7 @@
           <p:cNvPr id="42" name="">
             <a:extLst xmlns:a="http://schemas.openxmlformats.org/drawingml/2006/main">
               <a:ext uri="{FF2B5EF4-FFF2-40B4-BE49-F238E27FC236}">
-                <a16:creationId xmlns:a16="http://schemas.microsoft.com/office/drawing/2014/main" id="{9F45E76C-941D-4B14-8192-D8EA5B66CD83}"/>
+                <a16:creationId xmlns:a16="http://schemas.microsoft.com/office/drawing/2014/main" id="{5EB649A7-1B54-46B7-A605-4C7F3F763A2A}"/>
               </a:ext>
             </a:extLst>
           </p:cNvPr>
@@ -19289,7 +19289,7 @@
           <p:cNvPr id="43" name="">
             <a:extLst xmlns:a="http://schemas.openxmlformats.org/drawingml/2006/main">
               <a:ext uri="{FF2B5EF4-FFF2-40B4-BE49-F238E27FC236}">
-                <a16:creationId xmlns:a16="http://schemas.microsoft.com/office/drawing/2014/main" id="{CE04C5DA-8740-4B33-953C-9EC9CF11E383}"/>
+                <a16:creationId xmlns:a16="http://schemas.microsoft.com/office/drawing/2014/main" id="{29F61203-41A9-4153-82EB-9D1CB651AAC1}"/>
               </a:ext>
             </a:extLst>
           </p:cNvPr>
@@ -19410,7 +19410,7 @@
           <p:cNvPr id="44" name="">
             <a:extLst xmlns:a="http://schemas.openxmlformats.org/drawingml/2006/main">
               <a:ext uri="{FF2B5EF4-FFF2-40B4-BE49-F238E27FC236}">
-                <a16:creationId xmlns:a16="http://schemas.microsoft.com/office/drawing/2014/main" id="{41AEF8E3-DFD7-4922-BF97-6853F84164DE}"/>
+                <a16:creationId xmlns:a16="http://schemas.microsoft.com/office/drawing/2014/main" id="{B288048E-5812-4CC1-B019-6936B6E3CDBD}"/>
               </a:ext>
             </a:extLst>
           </p:cNvPr>
@@ -19531,7 +19531,7 @@
           <p:cNvPr id="45" name="">
             <a:extLst xmlns:a="http://schemas.openxmlformats.org/drawingml/2006/main">
               <a:ext uri="{FF2B5EF4-FFF2-40B4-BE49-F238E27FC236}">
-                <a16:creationId xmlns:a16="http://schemas.microsoft.com/office/drawing/2014/main" id="{8B7A0374-FB45-4CE5-BD2B-06699A726B6B}"/>
+                <a16:creationId xmlns:a16="http://schemas.microsoft.com/office/drawing/2014/main" id="{B69AA658-0EAC-4EA1-B2A8-BFA2112FC5B6}"/>
               </a:ext>
             </a:extLst>
           </p:cNvPr>
@@ -19562,7 +19562,7 @@
           <p:cNvPr id="46" name="">
             <a:extLst xmlns:a="http://schemas.openxmlformats.org/drawingml/2006/main">
               <a:ext uri="{FF2B5EF4-FFF2-40B4-BE49-F238E27FC236}">
-                <a16:creationId xmlns:a16="http://schemas.microsoft.com/office/drawing/2014/main" id="{42216640-3E6D-4C23-918F-C38EB59FCE1B}"/>
+                <a16:creationId xmlns:a16="http://schemas.microsoft.com/office/drawing/2014/main" id="{B4BEAE7E-3185-44D9-93AE-796DFD95C40B}"/>
               </a:ext>
             </a:extLst>
           </p:cNvPr>
@@ -19683,7 +19683,7 @@
           <p:cNvPr id="47" name="">
             <a:extLst xmlns:a="http://schemas.openxmlformats.org/drawingml/2006/main">
               <a:ext uri="{FF2B5EF4-FFF2-40B4-BE49-F238E27FC236}">
-                <a16:creationId xmlns:a16="http://schemas.microsoft.com/office/drawing/2014/main" id="{C164275E-64BC-4931-B4F7-9EBEB6C2E460}"/>
+                <a16:creationId xmlns:a16="http://schemas.microsoft.com/office/drawing/2014/main" id="{5DA2DF78-19FA-453A-A635-4450DCABF243}"/>
               </a:ext>
             </a:extLst>
           </p:cNvPr>
@@ -19804,7 +19804,7 @@
           <p:cNvPr id="48" name="">
             <a:extLst xmlns:a="http://schemas.openxmlformats.org/drawingml/2006/main">
               <a:ext uri="{FF2B5EF4-FFF2-40B4-BE49-F238E27FC236}">
-                <a16:creationId xmlns:a16="http://schemas.microsoft.com/office/drawing/2014/main" id="{70DD5CFC-17D3-408C-9033-C15DAF41CFAA}"/>
+                <a16:creationId xmlns:a16="http://schemas.microsoft.com/office/drawing/2014/main" id="{1BC6A304-652E-4B83-92AD-BBD564ACFDA4}"/>
               </a:ext>
             </a:extLst>
           </p:cNvPr>
@@ -19925,7 +19925,7 @@
           <p:cNvPr id="49" name="">
             <a:extLst xmlns:a="http://schemas.openxmlformats.org/drawingml/2006/main">
               <a:ext uri="{FF2B5EF4-FFF2-40B4-BE49-F238E27FC236}">
-                <a16:creationId xmlns:a16="http://schemas.microsoft.com/office/drawing/2014/main" id="{064C8A6F-F767-46F7-AEA4-1DC586C488AF}"/>
+                <a16:creationId xmlns:a16="http://schemas.microsoft.com/office/drawing/2014/main" id="{73A4ABE0-A76D-4FD0-B4DC-7B03B235979C}"/>
               </a:ext>
             </a:extLst>
           </p:cNvPr>
@@ -19956,7 +19956,7 @@
           <p:cNvPr id="50" name="">
             <a:extLst xmlns:a="http://schemas.openxmlformats.org/drawingml/2006/main">
               <a:ext uri="{FF2B5EF4-FFF2-40B4-BE49-F238E27FC236}">
-                <a16:creationId xmlns:a16="http://schemas.microsoft.com/office/drawing/2014/main" id="{D20CA376-9C47-42C3-88CE-FBD22A1B09F2}"/>
+                <a16:creationId xmlns:a16="http://schemas.microsoft.com/office/drawing/2014/main" id="{2A1A8C8C-21A4-4EC1-8C4E-18E53EF37930}"/>
               </a:ext>
             </a:extLst>
           </p:cNvPr>
@@ -20077,7 +20077,7 @@
           <p:cNvPr id="51" name="">
             <a:extLst xmlns:a="http://schemas.openxmlformats.org/drawingml/2006/main">
               <a:ext uri="{FF2B5EF4-FFF2-40B4-BE49-F238E27FC236}">
-                <a16:creationId xmlns:a16="http://schemas.microsoft.com/office/drawing/2014/main" id="{FC36E992-C3E1-4E28-A10C-32C53E3C898B}"/>
+                <a16:creationId xmlns:a16="http://schemas.microsoft.com/office/drawing/2014/main" id="{211514C2-3139-418D-A869-5A571E2F5233}"/>
               </a:ext>
             </a:extLst>
           </p:cNvPr>
@@ -20198,7 +20198,7 @@
           <p:cNvPr id="52" name="">
             <a:extLst xmlns:a="http://schemas.openxmlformats.org/drawingml/2006/main">
               <a:ext uri="{FF2B5EF4-FFF2-40B4-BE49-F238E27FC236}">
-                <a16:creationId xmlns:a16="http://schemas.microsoft.com/office/drawing/2014/main" id="{AC90C3AD-7742-4244-9B41-DE891014F8FD}"/>
+                <a16:creationId xmlns:a16="http://schemas.microsoft.com/office/drawing/2014/main" id="{010F46F2-510D-4FA2-9950-86427C215625}"/>
               </a:ext>
             </a:extLst>
           </p:cNvPr>
@@ -20319,7 +20319,7 @@
           <p:cNvPr id="53" name="">
             <a:extLst xmlns:a="http://schemas.openxmlformats.org/drawingml/2006/main">
               <a:ext uri="{FF2B5EF4-FFF2-40B4-BE49-F238E27FC236}">
-                <a16:creationId xmlns:a16="http://schemas.microsoft.com/office/drawing/2014/main" id="{3E9F41BB-4B72-4ABF-94FB-8984CD02F83C}"/>
+                <a16:creationId xmlns:a16="http://schemas.microsoft.com/office/drawing/2014/main" id="{719C1185-EADB-44F5-80CC-92A45923957D}"/>
               </a:ext>
             </a:extLst>
           </p:cNvPr>
@@ -20350,7 +20350,7 @@
           <p:cNvPr id="54" name="">
             <a:extLst xmlns:a="http://schemas.openxmlformats.org/drawingml/2006/main">
               <a:ext uri="{FF2B5EF4-FFF2-40B4-BE49-F238E27FC236}">
-                <a16:creationId xmlns:a16="http://schemas.microsoft.com/office/drawing/2014/main" id="{32E91A69-BE63-4E7A-AB97-E4D53A5E673B}"/>
+                <a16:creationId xmlns:a16="http://schemas.microsoft.com/office/drawing/2014/main" id="{0CC1D44F-5991-47CF-879E-D8DBA622D852}"/>
               </a:ext>
             </a:extLst>
           </p:cNvPr>
@@ -20471,7 +20471,7 @@
           <p:cNvPr id="55" name="">
             <a:extLst xmlns:a="http://schemas.openxmlformats.org/drawingml/2006/main">
               <a:ext uri="{FF2B5EF4-FFF2-40B4-BE49-F238E27FC236}">
-                <a16:creationId xmlns:a16="http://schemas.microsoft.com/office/drawing/2014/main" id="{D75F4B76-0E86-44F1-BCAA-2F97B7B34672}"/>
+                <a16:creationId xmlns:a16="http://schemas.microsoft.com/office/drawing/2014/main" id="{EE9C4C4E-AFDC-427A-8321-04462B597782}"/>
               </a:ext>
             </a:extLst>
           </p:cNvPr>
@@ -20592,7 +20592,7 @@
           <p:cNvPr id="56" name="">
             <a:extLst xmlns:a="http://schemas.openxmlformats.org/drawingml/2006/main">
               <a:ext uri="{FF2B5EF4-FFF2-40B4-BE49-F238E27FC236}">
-                <a16:creationId xmlns:a16="http://schemas.microsoft.com/office/drawing/2014/main" id="{8A07FF41-C992-43E6-BE92-4E9B4439F227}"/>
+                <a16:creationId xmlns:a16="http://schemas.microsoft.com/office/drawing/2014/main" id="{24A4BEC7-BFDE-49AB-9E9B-B479C6258302}"/>
               </a:ext>
             </a:extLst>
           </p:cNvPr>
@@ -20711,7 +20711,7 @@
     </p:spTree>
     <p:extLst>
       <p:ext uri="{BB962C8B-B14F-4D97-AF65-F5344CB8AC3E}">
-        <p14:creationId xmlns:p14="http://schemas.microsoft.com/office/powerpoint/2010/main" val="1048776899"/>
+        <p14:creationId xmlns:p14="http://schemas.microsoft.com/office/powerpoint/2010/main" val="438322379"/>
       </p:ext>
     </p:extLst>
   </p:cSld>
@@ -20742,7 +20742,7 @@
           <p:cNvPr id="19" name="">
             <a:extLst xmlns:a="http://schemas.openxmlformats.org/drawingml/2006/main">
               <a:ext uri="{FF2B5EF4-FFF2-40B4-BE49-F238E27FC236}">
-                <a16:creationId xmlns:a16="http://schemas.microsoft.com/office/drawing/2014/main" id="{C1A370F0-0C02-479D-B46B-41767F139D22}"/>
+                <a16:creationId xmlns:a16="http://schemas.microsoft.com/office/drawing/2014/main" id="{5E85BB4D-98CB-495F-BB7B-57AF6EA062BE}"/>
               </a:ext>
             </a:extLst>
           </p:cNvPr>
@@ -20773,7 +20773,7 @@
           <p:cNvPr id="2" name="">
             <a:extLst xmlns:a="http://schemas.openxmlformats.org/drawingml/2006/main">
               <a:ext uri="{FF2B5EF4-FFF2-40B4-BE49-F238E27FC236}">
-                <a16:creationId xmlns:a16="http://schemas.microsoft.com/office/drawing/2014/main" id="{D7E49124-3F36-4D4F-982D-471A8AE33CDC}"/>
+                <a16:creationId xmlns:a16="http://schemas.microsoft.com/office/drawing/2014/main" id="{36C0F82B-23A0-405F-9D6F-62EE46DA7862}"/>
               </a:ext>
             </a:extLst>
           </p:cNvPr>
@@ -20894,7 +20894,7 @@
           <p:cNvPr id="3" name="">
             <a:extLst xmlns:a="http://schemas.openxmlformats.org/drawingml/2006/main">
               <a:ext uri="{FF2B5EF4-FFF2-40B4-BE49-F238E27FC236}">
-                <a16:creationId xmlns:a16="http://schemas.microsoft.com/office/drawing/2014/main" id="{939F7237-7C93-483F-8DC5-1C4995E97ADD}"/>
+                <a16:creationId xmlns:a16="http://schemas.microsoft.com/office/drawing/2014/main" id="{3F4B585C-ED31-4304-B7A6-B6FC4BB7D209}"/>
               </a:ext>
             </a:extLst>
           </p:cNvPr>
@@ -21015,7 +21015,7 @@
           <p:cNvPr id="4" name="">
             <a:extLst xmlns:a="http://schemas.openxmlformats.org/drawingml/2006/main">
               <a:ext uri="{FF2B5EF4-FFF2-40B4-BE49-F238E27FC236}">
-                <a16:creationId xmlns:a16="http://schemas.microsoft.com/office/drawing/2014/main" id="{4AB61EF5-47D9-44FC-8F91-D0928041D20D}"/>
+                <a16:creationId xmlns:a16="http://schemas.microsoft.com/office/drawing/2014/main" id="{DF1CAD56-6733-4B6C-AAC7-701574BA60FB}"/>
               </a:ext>
             </a:extLst>
           </p:cNvPr>
@@ -21046,7 +21046,7 @@
           <p:cNvPr id="5" name="">
             <a:extLst xmlns:a="http://schemas.openxmlformats.org/drawingml/2006/main">
               <a:ext uri="{FF2B5EF4-FFF2-40B4-BE49-F238E27FC236}">
-                <a16:creationId xmlns:a16="http://schemas.microsoft.com/office/drawing/2014/main" id="{BA6F4C0E-3AC5-4F0C-A068-E2CD8472D400}"/>
+                <a16:creationId xmlns:a16="http://schemas.microsoft.com/office/drawing/2014/main" id="{68995C88-6F9E-422F-B814-D2D1DAA3B533}"/>
               </a:ext>
             </a:extLst>
           </p:cNvPr>
@@ -21167,7 +21167,7 @@
           <p:cNvPr id="6" name="">
             <a:extLst xmlns:a="http://schemas.openxmlformats.org/drawingml/2006/main">
               <a:ext uri="{FF2B5EF4-FFF2-40B4-BE49-F238E27FC236}">
-                <a16:creationId xmlns:a16="http://schemas.microsoft.com/office/drawing/2014/main" id="{05D4689D-94F3-4A6C-8321-1CEBBA793272}"/>
+                <a16:creationId xmlns:a16="http://schemas.microsoft.com/office/drawing/2014/main" id="{736AB175-D20D-4909-BD18-8B4445DD2F32}"/>
               </a:ext>
             </a:extLst>
           </p:cNvPr>
@@ -21288,7 +21288,7 @@
           <p:cNvPr id="7" name="">
             <a:extLst xmlns:a="http://schemas.openxmlformats.org/drawingml/2006/main">
               <a:ext uri="{FF2B5EF4-FFF2-40B4-BE49-F238E27FC236}">
-                <a16:creationId xmlns:a16="http://schemas.microsoft.com/office/drawing/2014/main" id="{2F4D81DB-21FC-4F89-9931-D4DA0A275CC8}"/>
+                <a16:creationId xmlns:a16="http://schemas.microsoft.com/office/drawing/2014/main" id="{7E75D972-E4CD-4110-A868-DE53CDDF6CDC}"/>
               </a:ext>
             </a:extLst>
           </p:cNvPr>
@@ -21409,7 +21409,7 @@
           <p:cNvPr id="8" name="">
             <a:extLst xmlns:a="http://schemas.openxmlformats.org/drawingml/2006/main">
               <a:ext uri="{FF2B5EF4-FFF2-40B4-BE49-F238E27FC236}">
-                <a16:creationId xmlns:a16="http://schemas.microsoft.com/office/drawing/2014/main" id="{5CD6D8EA-98BF-4CFA-A8B9-E4D4BE54C69D}"/>
+                <a16:creationId xmlns:a16="http://schemas.microsoft.com/office/drawing/2014/main" id="{A2CEC8DC-EE53-47BB-972A-A0FC168EA286}"/>
               </a:ext>
             </a:extLst>
           </p:cNvPr>
@@ -21440,7 +21440,7 @@
           <p:cNvPr id="9" name="">
             <a:extLst xmlns:a="http://schemas.openxmlformats.org/drawingml/2006/main">
               <a:ext uri="{FF2B5EF4-FFF2-40B4-BE49-F238E27FC236}">
-                <a16:creationId xmlns:a16="http://schemas.microsoft.com/office/drawing/2014/main" id="{78C94208-C38E-4465-9728-94E3DE86B647}"/>
+                <a16:creationId xmlns:a16="http://schemas.microsoft.com/office/drawing/2014/main" id="{87970130-FC28-4DD8-8C78-7443A42D59F7}"/>
               </a:ext>
             </a:extLst>
           </p:cNvPr>
@@ -21561,7 +21561,7 @@
           <p:cNvPr id="10" name="">
             <a:extLst xmlns:a="http://schemas.openxmlformats.org/drawingml/2006/main">
               <a:ext uri="{FF2B5EF4-FFF2-40B4-BE49-F238E27FC236}">
-                <a16:creationId xmlns:a16="http://schemas.microsoft.com/office/drawing/2014/main" id="{335AB7A8-9B25-4847-AD1B-F958F86B2279}"/>
+                <a16:creationId xmlns:a16="http://schemas.microsoft.com/office/drawing/2014/main" id="{725DE37D-236F-4B92-8267-0A0731519991}"/>
               </a:ext>
             </a:extLst>
           </p:cNvPr>
@@ -21682,7 +21682,7 @@
           <p:cNvPr id="11" name="">
             <a:extLst xmlns:a="http://schemas.openxmlformats.org/drawingml/2006/main">
               <a:ext uri="{FF2B5EF4-FFF2-40B4-BE49-F238E27FC236}">
-                <a16:creationId xmlns:a16="http://schemas.microsoft.com/office/drawing/2014/main" id="{7AADAF44-55C5-4746-9AAB-90F0A51AE0C0}"/>
+                <a16:creationId xmlns:a16="http://schemas.microsoft.com/office/drawing/2014/main" id="{B5B2F0C8-DA57-4709-A467-E3F97B171047}"/>
               </a:ext>
             </a:extLst>
           </p:cNvPr>
@@ -21713,7 +21713,7 @@
           <p:cNvPr id="12" name="">
             <a:extLst xmlns:a="http://schemas.openxmlformats.org/drawingml/2006/main">
               <a:ext uri="{FF2B5EF4-FFF2-40B4-BE49-F238E27FC236}">
-                <a16:creationId xmlns:a16="http://schemas.microsoft.com/office/drawing/2014/main" id="{E7DB3651-92C1-4A48-BD86-EB0651E4D7CD}"/>
+                <a16:creationId xmlns:a16="http://schemas.microsoft.com/office/drawing/2014/main" id="{0E9F9C5E-5625-439A-8389-A35774C5634C}"/>
               </a:ext>
             </a:extLst>
           </p:cNvPr>
@@ -21834,7 +21834,7 @@
           <p:cNvPr id="13" name="">
             <a:extLst xmlns:a="http://schemas.openxmlformats.org/drawingml/2006/main">
               <a:ext uri="{FF2B5EF4-FFF2-40B4-BE49-F238E27FC236}">
-                <a16:creationId xmlns:a16="http://schemas.microsoft.com/office/drawing/2014/main" id="{BF57BB46-D5E5-4CED-9C0D-851B749FC144}"/>
+                <a16:creationId xmlns:a16="http://schemas.microsoft.com/office/drawing/2014/main" id="{DE3F6C5C-38E8-45CD-9136-AF6682D6E3F6}"/>
               </a:ext>
             </a:extLst>
           </p:cNvPr>
@@ -21955,7 +21955,7 @@
           <p:cNvPr id="14" name="">
             <a:extLst xmlns:a="http://schemas.openxmlformats.org/drawingml/2006/main">
               <a:ext uri="{FF2B5EF4-FFF2-40B4-BE49-F238E27FC236}">
-                <a16:creationId xmlns:a16="http://schemas.microsoft.com/office/drawing/2014/main" id="{EF624D59-9E02-49B0-9535-8C3EC4C9CACB}"/>
+                <a16:creationId xmlns:a16="http://schemas.microsoft.com/office/drawing/2014/main" id="{0CC96668-381B-4297-B978-AD65B3322C6B}"/>
               </a:ext>
             </a:extLst>
           </p:cNvPr>
@@ -21986,7 +21986,7 @@
           <p:cNvPr id="15" name="">
             <a:extLst xmlns:a="http://schemas.openxmlformats.org/drawingml/2006/main">
               <a:ext uri="{FF2B5EF4-FFF2-40B4-BE49-F238E27FC236}">
-                <a16:creationId xmlns:a16="http://schemas.microsoft.com/office/drawing/2014/main" id="{CB1B563C-46F2-4D5C-8A22-01AC6E5E844F}"/>
+                <a16:creationId xmlns:a16="http://schemas.microsoft.com/office/drawing/2014/main" id="{00A32563-D7BB-447B-900B-A3026EC9F7A0}"/>
               </a:ext>
             </a:extLst>
           </p:cNvPr>
@@ -22107,7 +22107,7 @@
           <p:cNvPr id="16" name="">
             <a:extLst xmlns:a="http://schemas.openxmlformats.org/drawingml/2006/main">
               <a:ext uri="{FF2B5EF4-FFF2-40B4-BE49-F238E27FC236}">
-                <a16:creationId xmlns:a16="http://schemas.microsoft.com/office/drawing/2014/main" id="{9C88EDC6-7D82-43D2-933F-F8FEF876D9CB}"/>
+                <a16:creationId xmlns:a16="http://schemas.microsoft.com/office/drawing/2014/main" id="{478F7BA2-8960-487C-922C-35528E277FBB}"/>
               </a:ext>
             </a:extLst>
           </p:cNvPr>
@@ -22228,7 +22228,7 @@
           <p:cNvPr id="17" name="">
             <a:extLst xmlns:a="http://schemas.openxmlformats.org/drawingml/2006/main">
               <a:ext uri="{FF2B5EF4-FFF2-40B4-BE49-F238E27FC236}">
-                <a16:creationId xmlns:a16="http://schemas.microsoft.com/office/drawing/2014/main" id="{379E6D80-420A-4CED-AD90-08911EF1D9FD}"/>
+                <a16:creationId xmlns:a16="http://schemas.microsoft.com/office/drawing/2014/main" id="{2BB79D2D-DDB1-41A1-8FE7-DAB32BB9682C}"/>
               </a:ext>
             </a:extLst>
           </p:cNvPr>
@@ -22259,7 +22259,7 @@
           <p:cNvPr id="18" name="">
             <a:extLst xmlns:a="http://schemas.openxmlformats.org/drawingml/2006/main">
               <a:ext uri="{FF2B5EF4-FFF2-40B4-BE49-F238E27FC236}">
-                <a16:creationId xmlns:a16="http://schemas.microsoft.com/office/drawing/2014/main" id="{0A98E65F-FEC0-4BA6-97B8-E6F944BACBF5}"/>
+                <a16:creationId xmlns:a16="http://schemas.microsoft.com/office/drawing/2014/main" id="{EA00C339-F6EB-431E-9FD7-3E76C2F375C4}"/>
               </a:ext>
             </a:extLst>
           </p:cNvPr>
@@ -22378,7 +22378,7 @@
     </p:spTree>
     <p:extLst>
       <p:ext uri="{BB962C8B-B14F-4D97-AF65-F5344CB8AC3E}">
-        <p14:creationId xmlns:p14="http://schemas.microsoft.com/office/powerpoint/2010/main" val="1263779196"/>
+        <p14:creationId xmlns:p14="http://schemas.microsoft.com/office/powerpoint/2010/main" val="175790858"/>
       </p:ext>
     </p:extLst>
   </p:cSld>
@@ -22409,7 +22409,7 @@
           <p:cNvPr id="30" name="">
             <a:extLst xmlns:a="http://schemas.openxmlformats.org/drawingml/2006/main">
               <a:ext uri="{FF2B5EF4-FFF2-40B4-BE49-F238E27FC236}">
-                <a16:creationId xmlns:a16="http://schemas.microsoft.com/office/drawing/2014/main" id="{04F11DE9-E2CD-433C-8CEF-9B43C917F6DA}"/>
+                <a16:creationId xmlns:a16="http://schemas.microsoft.com/office/drawing/2014/main" id="{E5BE9CE0-09A9-4601-871D-5987B4057539}"/>
               </a:ext>
             </a:extLst>
           </p:cNvPr>
@@ -22440,7 +22440,7 @@
           <p:cNvPr id="2" name="">
             <a:extLst xmlns:a="http://schemas.openxmlformats.org/drawingml/2006/main">
               <a:ext uri="{FF2B5EF4-FFF2-40B4-BE49-F238E27FC236}">
-                <a16:creationId xmlns:a16="http://schemas.microsoft.com/office/drawing/2014/main" id="{FCB061AB-FDF8-4D5F-9AB8-8ECACC4D03F8}"/>
+                <a16:creationId xmlns:a16="http://schemas.microsoft.com/office/drawing/2014/main" id="{F87AA374-F705-4BA1-827F-7559D01F85C6}"/>
               </a:ext>
             </a:extLst>
           </p:cNvPr>
@@ -22561,7 +22561,7 @@
           <p:cNvPr id="3" name="">
             <a:extLst xmlns:a="http://schemas.openxmlformats.org/drawingml/2006/main">
               <a:ext uri="{FF2B5EF4-FFF2-40B4-BE49-F238E27FC236}">
-                <a16:creationId xmlns:a16="http://schemas.microsoft.com/office/drawing/2014/main" id="{B62682D8-33DA-45EF-9BAF-8B50F849D112}"/>
+                <a16:creationId xmlns:a16="http://schemas.microsoft.com/office/drawing/2014/main" id="{82F12DD0-FCBB-4D7C-9280-D6A6D70D1875}"/>
               </a:ext>
             </a:extLst>
           </p:cNvPr>
@@ -22682,7 +22682,7 @@
           <p:cNvPr id="4" name="">
             <a:extLst xmlns:a="http://schemas.openxmlformats.org/drawingml/2006/main">
               <a:ext uri="{FF2B5EF4-FFF2-40B4-BE49-F238E27FC236}">
-                <a16:creationId xmlns:a16="http://schemas.microsoft.com/office/drawing/2014/main" id="{0BC5CE04-153C-452A-9CE6-1D8CBCF2B027}"/>
+                <a16:creationId xmlns:a16="http://schemas.microsoft.com/office/drawing/2014/main" id="{7C341135-B7FF-436E-90F0-104889090207}"/>
               </a:ext>
             </a:extLst>
           </p:cNvPr>
@@ -22713,7 +22713,7 @@
           <p:cNvPr id="5" name="">
             <a:extLst xmlns:a="http://schemas.openxmlformats.org/drawingml/2006/main">
               <a:ext uri="{FF2B5EF4-FFF2-40B4-BE49-F238E27FC236}">
-                <a16:creationId xmlns:a16="http://schemas.microsoft.com/office/drawing/2014/main" id="{23EA8B3C-8EB3-4C03-9FA8-E7A0BB62A615}"/>
+                <a16:creationId xmlns:a16="http://schemas.microsoft.com/office/drawing/2014/main" id="{545EBF3F-314F-49AD-A8B3-07F36C9809E6}"/>
               </a:ext>
             </a:extLst>
           </p:cNvPr>
@@ -22834,7 +22834,7 @@
           <p:cNvPr id="6" name="">
             <a:extLst xmlns:a="http://schemas.openxmlformats.org/drawingml/2006/main">
               <a:ext uri="{FF2B5EF4-FFF2-40B4-BE49-F238E27FC236}">
-                <a16:creationId xmlns:a16="http://schemas.microsoft.com/office/drawing/2014/main" id="{ED5CC541-FD54-4860-845B-8AE627C3FCA6}"/>
+                <a16:creationId xmlns:a16="http://schemas.microsoft.com/office/drawing/2014/main" id="{64185DAE-56A2-4D89-A7AE-6D2687823047}"/>
               </a:ext>
             </a:extLst>
           </p:cNvPr>
@@ -22955,7 +22955,7 @@
           <p:cNvPr id="7" name="">
             <a:extLst xmlns:a="http://schemas.openxmlformats.org/drawingml/2006/main">
               <a:ext uri="{FF2B5EF4-FFF2-40B4-BE49-F238E27FC236}">
-                <a16:creationId xmlns:a16="http://schemas.microsoft.com/office/drawing/2014/main" id="{B429DB1B-4651-403B-8904-4EB91A5AB528}"/>
+                <a16:creationId xmlns:a16="http://schemas.microsoft.com/office/drawing/2014/main" id="{6E9D9532-0441-424C-9D0C-C4AB7BF10458}"/>
               </a:ext>
             </a:extLst>
           </p:cNvPr>
@@ -23076,7 +23076,7 @@
           <p:cNvPr id="8" name="">
             <a:extLst xmlns:a="http://schemas.openxmlformats.org/drawingml/2006/main">
               <a:ext uri="{FF2B5EF4-FFF2-40B4-BE49-F238E27FC236}">
-                <a16:creationId xmlns:a16="http://schemas.microsoft.com/office/drawing/2014/main" id="{2C9EC387-D863-4D1F-8318-56252F36E6D6}"/>
+                <a16:creationId xmlns:a16="http://schemas.microsoft.com/office/drawing/2014/main" id="{2C06C833-968F-4FD8-8B1D-BC82B8D7794B}"/>
               </a:ext>
             </a:extLst>
           </p:cNvPr>
@@ -23107,7 +23107,7 @@
           <p:cNvPr id="9" name="">
             <a:extLst xmlns:a="http://schemas.openxmlformats.org/drawingml/2006/main">
               <a:ext uri="{FF2B5EF4-FFF2-40B4-BE49-F238E27FC236}">
-                <a16:creationId xmlns:a16="http://schemas.microsoft.com/office/drawing/2014/main" id="{2598D32A-82DE-4E9F-84C5-CF86BEF8BD4D}"/>
+                <a16:creationId xmlns:a16="http://schemas.microsoft.com/office/drawing/2014/main" id="{E2B0D13C-F3C2-4F55-A45D-C78BA0C349DE}"/>
               </a:ext>
             </a:extLst>
           </p:cNvPr>
@@ -23228,7 +23228,7 @@
           <p:cNvPr id="10" name="">
             <a:extLst xmlns:a="http://schemas.openxmlformats.org/drawingml/2006/main">
               <a:ext uri="{FF2B5EF4-FFF2-40B4-BE49-F238E27FC236}">
-                <a16:creationId xmlns:a16="http://schemas.microsoft.com/office/drawing/2014/main" id="{7CBA261C-BFA8-4931-B062-291044C825A2}"/>
+                <a16:creationId xmlns:a16="http://schemas.microsoft.com/office/drawing/2014/main" id="{C4A73723-3B12-401F-B7AE-802E2185241D}"/>
               </a:ext>
             </a:extLst>
           </p:cNvPr>
@@ -23259,7 +23259,7 @@
           <p:cNvPr id="11" name="">
             <a:extLst xmlns:a="http://schemas.openxmlformats.org/drawingml/2006/main">
               <a:ext uri="{FF2B5EF4-FFF2-40B4-BE49-F238E27FC236}">
-                <a16:creationId xmlns:a16="http://schemas.microsoft.com/office/drawing/2014/main" id="{84172C85-EE5A-4022-84C1-AECFBBF304FF}"/>
+                <a16:creationId xmlns:a16="http://schemas.microsoft.com/office/drawing/2014/main" id="{33CC3E57-93CC-4EF7-A3C7-C440F470A894}"/>
               </a:ext>
             </a:extLst>
           </p:cNvPr>
@@ -23380,7 +23380,7 @@
           <p:cNvPr id="12" name="">
             <a:extLst xmlns:a="http://schemas.openxmlformats.org/drawingml/2006/main">
               <a:ext uri="{FF2B5EF4-FFF2-40B4-BE49-F238E27FC236}">
-                <a16:creationId xmlns:a16="http://schemas.microsoft.com/office/drawing/2014/main" id="{D9BD31F8-E276-427F-B682-C585046C4380}"/>
+                <a16:creationId xmlns:a16="http://schemas.microsoft.com/office/drawing/2014/main" id="{4B415363-AC89-4BA9-B978-33FC91508867}"/>
               </a:ext>
             </a:extLst>
           </p:cNvPr>
@@ -23411,7 +23411,7 @@
           <p:cNvPr id="13" name="">
             <a:extLst xmlns:a="http://schemas.openxmlformats.org/drawingml/2006/main">
               <a:ext uri="{FF2B5EF4-FFF2-40B4-BE49-F238E27FC236}">
-                <a16:creationId xmlns:a16="http://schemas.microsoft.com/office/drawing/2014/main" id="{B36037B9-0A54-446A-BBE4-F4469359998F}"/>
+                <a16:creationId xmlns:a16="http://schemas.microsoft.com/office/drawing/2014/main" id="{80CF3D50-EA24-488D-9EF3-AC2B33D226D5}"/>
               </a:ext>
             </a:extLst>
           </p:cNvPr>
@@ -23532,7 +23532,7 @@
           <p:cNvPr id="14" name="">
             <a:extLst xmlns:a="http://schemas.openxmlformats.org/drawingml/2006/main">
               <a:ext uri="{FF2B5EF4-FFF2-40B4-BE49-F238E27FC236}">
-                <a16:creationId xmlns:a16="http://schemas.microsoft.com/office/drawing/2014/main" id="{B7677FFF-4B63-4AB6-AF71-B14EFDFB72BE}"/>
+                <a16:creationId xmlns:a16="http://schemas.microsoft.com/office/drawing/2014/main" id="{F4CC4D2F-C7A2-47FC-BC4F-F856B74705F9}"/>
               </a:ext>
             </a:extLst>
           </p:cNvPr>
@@ -23563,7 +23563,7 @@
           <p:cNvPr id="15" name="">
             <a:extLst xmlns:a="http://schemas.openxmlformats.org/drawingml/2006/main">
               <a:ext uri="{FF2B5EF4-FFF2-40B4-BE49-F238E27FC236}">
-                <a16:creationId xmlns:a16="http://schemas.microsoft.com/office/drawing/2014/main" id="{72D8B8E3-EBFD-4B65-B455-2BD1C45126B7}"/>
+                <a16:creationId xmlns:a16="http://schemas.microsoft.com/office/drawing/2014/main" id="{B7558D2C-7556-46A7-AD23-FE3857CEBAD9}"/>
               </a:ext>
             </a:extLst>
           </p:cNvPr>
@@ -23684,7 +23684,7 @@
           <p:cNvPr id="16" name="">
             <a:extLst xmlns:a="http://schemas.openxmlformats.org/drawingml/2006/main">
               <a:ext uri="{FF2B5EF4-FFF2-40B4-BE49-F238E27FC236}">
-                <a16:creationId xmlns:a16="http://schemas.microsoft.com/office/drawing/2014/main" id="{B77F5574-07E8-451B-A1AA-5B577E445EF8}"/>
+                <a16:creationId xmlns:a16="http://schemas.microsoft.com/office/drawing/2014/main" id="{19298A54-9ACD-4D75-9526-5155E6745291}"/>
               </a:ext>
             </a:extLst>
           </p:cNvPr>
@@ -23715,7 +23715,7 @@
           <p:cNvPr id="17" name="">
             <a:extLst xmlns:a="http://schemas.openxmlformats.org/drawingml/2006/main">
               <a:ext uri="{FF2B5EF4-FFF2-40B4-BE49-F238E27FC236}">
-                <a16:creationId xmlns:a16="http://schemas.microsoft.com/office/drawing/2014/main" id="{87DFCCD3-0CEA-4AA8-917D-0315D643DE76}"/>
+                <a16:creationId xmlns:a16="http://schemas.microsoft.com/office/drawing/2014/main" id="{C88039E3-1E55-4617-9C62-56B3CFCE4BD3}"/>
               </a:ext>
             </a:extLst>
           </p:cNvPr>
@@ -23836,7 +23836,7 @@
           <p:cNvPr id="18" name="">
             <a:extLst xmlns:a="http://schemas.openxmlformats.org/drawingml/2006/main">
               <a:ext uri="{FF2B5EF4-FFF2-40B4-BE49-F238E27FC236}">
-                <a16:creationId xmlns:a16="http://schemas.microsoft.com/office/drawing/2014/main" id="{632B1DA8-6C86-4405-A76E-94AAE15B6BBE}"/>
+                <a16:creationId xmlns:a16="http://schemas.microsoft.com/office/drawing/2014/main" id="{EA277535-E70D-4EAF-8444-DD6604BB5EFB}"/>
               </a:ext>
             </a:extLst>
           </p:cNvPr>
@@ -23957,7 +23957,7 @@
           <p:cNvPr id="19" name="">
             <a:extLst xmlns:a="http://schemas.openxmlformats.org/drawingml/2006/main">
               <a:ext uri="{FF2B5EF4-FFF2-40B4-BE49-F238E27FC236}">
-                <a16:creationId xmlns:a16="http://schemas.microsoft.com/office/drawing/2014/main" id="{96C92A91-E601-4A0B-BBCF-EE457B1DDD79}"/>
+                <a16:creationId xmlns:a16="http://schemas.microsoft.com/office/drawing/2014/main" id="{7DA0A214-DFB6-4249-A5F6-991B4981978B}"/>
               </a:ext>
             </a:extLst>
           </p:cNvPr>
@@ -24078,7 +24078,7 @@
           <p:cNvPr id="20" name="">
             <a:extLst xmlns:a="http://schemas.openxmlformats.org/drawingml/2006/main">
               <a:ext uri="{FF2B5EF4-FFF2-40B4-BE49-F238E27FC236}">
-                <a16:creationId xmlns:a16="http://schemas.microsoft.com/office/drawing/2014/main" id="{537D3311-339E-4D8E-9C30-A318AAEF540C}"/>
+                <a16:creationId xmlns:a16="http://schemas.microsoft.com/office/drawing/2014/main" id="{0EF08B49-A576-45ED-B2D3-B5497CE19F78}"/>
               </a:ext>
             </a:extLst>
           </p:cNvPr>
@@ -24199,7 +24199,7 @@
           <p:cNvPr id="21" name="">
             <a:extLst xmlns:a="http://schemas.openxmlformats.org/drawingml/2006/main">
               <a:ext uri="{FF2B5EF4-FFF2-40B4-BE49-F238E27FC236}">
-                <a16:creationId xmlns:a16="http://schemas.microsoft.com/office/drawing/2014/main" id="{4C728782-5EDA-45F7-A9C6-7D2E82A66CE5}"/>
+                <a16:creationId xmlns:a16="http://schemas.microsoft.com/office/drawing/2014/main" id="{23019AC2-D4B0-45EB-8C2C-26B8F0638878}"/>
               </a:ext>
             </a:extLst>
           </p:cNvPr>
@@ -24320,7 +24320,7 @@
           <p:cNvPr id="22" name="">
             <a:extLst xmlns:a="http://schemas.openxmlformats.org/drawingml/2006/main">
               <a:ext uri="{FF2B5EF4-FFF2-40B4-BE49-F238E27FC236}">
-                <a16:creationId xmlns:a16="http://schemas.microsoft.com/office/drawing/2014/main" id="{D571668C-B328-4CAD-A1A1-71D33BB09FB6}"/>
+                <a16:creationId xmlns:a16="http://schemas.microsoft.com/office/drawing/2014/main" id="{DD854624-C140-49AB-B457-F1EB5A2AFBEE}"/>
               </a:ext>
             </a:extLst>
           </p:cNvPr>
@@ -24441,7 +24441,7 @@
           <p:cNvPr id="23" name="">
             <a:extLst xmlns:a="http://schemas.openxmlformats.org/drawingml/2006/main">
               <a:ext uri="{FF2B5EF4-FFF2-40B4-BE49-F238E27FC236}">
-                <a16:creationId xmlns:a16="http://schemas.microsoft.com/office/drawing/2014/main" id="{C2EBDDFD-5C4D-444C-99D6-4FA2BE2671DC}"/>
+                <a16:creationId xmlns:a16="http://schemas.microsoft.com/office/drawing/2014/main" id="{63E7356B-0A35-47CA-AC2B-97C130386B7E}"/>
               </a:ext>
             </a:extLst>
           </p:cNvPr>
@@ -24562,7 +24562,7 @@
           <p:cNvPr id="24" name="">
             <a:extLst xmlns:a="http://schemas.openxmlformats.org/drawingml/2006/main">
               <a:ext uri="{FF2B5EF4-FFF2-40B4-BE49-F238E27FC236}">
-                <a16:creationId xmlns:a16="http://schemas.microsoft.com/office/drawing/2014/main" id="{943F7230-09FC-4E52-9499-2FC0A7678D09}"/>
+                <a16:creationId xmlns:a16="http://schemas.microsoft.com/office/drawing/2014/main" id="{806AE93A-DE03-4DD8-9C26-F18BC139686B}"/>
               </a:ext>
             </a:extLst>
           </p:cNvPr>
@@ -24683,7 +24683,7 @@
           <p:cNvPr id="25" name="">
             <a:extLst xmlns:a="http://schemas.openxmlformats.org/drawingml/2006/main">
               <a:ext uri="{FF2B5EF4-FFF2-40B4-BE49-F238E27FC236}">
-                <a16:creationId xmlns:a16="http://schemas.microsoft.com/office/drawing/2014/main" id="{7A0FF303-5C54-4150-BF0E-F0CA2DD87A2A}"/>
+                <a16:creationId xmlns:a16="http://schemas.microsoft.com/office/drawing/2014/main" id="{3FE9D505-0F47-4296-AF9F-8CFE13964812}"/>
               </a:ext>
             </a:extLst>
           </p:cNvPr>
@@ -24804,7 +24804,7 @@
           <p:cNvPr id="26" name="">
             <a:extLst xmlns:a="http://schemas.openxmlformats.org/drawingml/2006/main">
               <a:ext uri="{FF2B5EF4-FFF2-40B4-BE49-F238E27FC236}">
-                <a16:creationId xmlns:a16="http://schemas.microsoft.com/office/drawing/2014/main" id="{F143A89C-9F1F-4484-A0C8-2E439381417F}"/>
+                <a16:creationId xmlns:a16="http://schemas.microsoft.com/office/drawing/2014/main" id="{8DDBAF5D-A69B-4ACA-B29E-05E50FD03903}"/>
               </a:ext>
             </a:extLst>
           </p:cNvPr>
@@ -24925,7 +24925,7 @@
           <p:cNvPr id="27" name="">
             <a:extLst xmlns:a="http://schemas.openxmlformats.org/drawingml/2006/main">
               <a:ext uri="{FF2B5EF4-FFF2-40B4-BE49-F238E27FC236}">
-                <a16:creationId xmlns:a16="http://schemas.microsoft.com/office/drawing/2014/main" id="{1B525DE9-2C91-44D4-81EF-047C8F57F9D5}"/>
+                <a16:creationId xmlns:a16="http://schemas.microsoft.com/office/drawing/2014/main" id="{624470CB-2045-4475-8EAF-17FFE495B60F}"/>
               </a:ext>
             </a:extLst>
           </p:cNvPr>
@@ -25046,7 +25046,7 @@
           <p:cNvPr id="28" name="">
             <a:extLst xmlns:a="http://schemas.openxmlformats.org/drawingml/2006/main">
               <a:ext uri="{FF2B5EF4-FFF2-40B4-BE49-F238E27FC236}">
-                <a16:creationId xmlns:a16="http://schemas.microsoft.com/office/drawing/2014/main" id="{508E1015-99EA-45B7-81A1-EBC065EAF30E}"/>
+                <a16:creationId xmlns:a16="http://schemas.microsoft.com/office/drawing/2014/main" id="{7A11186D-0AA5-4DF6-A043-B0680592D002}"/>
               </a:ext>
             </a:extLst>
           </p:cNvPr>
@@ -25079,7 +25079,7 @@
           <p:cNvPr id="29" name="">
             <a:extLst xmlns:a="http://schemas.openxmlformats.org/drawingml/2006/main">
               <a:ext uri="{FF2B5EF4-FFF2-40B4-BE49-F238E27FC236}">
-                <a16:creationId xmlns:a16="http://schemas.microsoft.com/office/drawing/2014/main" id="{164B7973-1076-4F77-864D-C00BC0B3B570}"/>
+                <a16:creationId xmlns:a16="http://schemas.microsoft.com/office/drawing/2014/main" id="{A6494E4E-92F1-4287-A92C-7DB83582737E}"/>
               </a:ext>
             </a:extLst>
           </p:cNvPr>
@@ -25198,7 +25198,7 @@
     </p:spTree>
     <p:extLst>
       <p:ext uri="{BB962C8B-B14F-4D97-AF65-F5344CB8AC3E}">
-        <p14:creationId xmlns:p14="http://schemas.microsoft.com/office/powerpoint/2010/main" val="1872902708"/>
+        <p14:creationId xmlns:p14="http://schemas.microsoft.com/office/powerpoint/2010/main" val="291509762"/>
       </p:ext>
     </p:extLst>
   </p:cSld>
@@ -25229,7 +25229,7 @@
           <p:cNvPr id="19" name="">
             <a:extLst xmlns:a="http://schemas.openxmlformats.org/drawingml/2006/main">
               <a:ext uri="{FF2B5EF4-FFF2-40B4-BE49-F238E27FC236}">
-                <a16:creationId xmlns:a16="http://schemas.microsoft.com/office/drawing/2014/main" id="{9A9E0F6A-B217-47EA-A3A4-9A45CD1AD22D}"/>
+                <a16:creationId xmlns:a16="http://schemas.microsoft.com/office/drawing/2014/main" id="{B33F6061-6814-49F1-935B-2B869A4E1533}"/>
               </a:ext>
             </a:extLst>
           </p:cNvPr>
@@ -25260,7 +25260,7 @@
           <p:cNvPr id="2" name="">
             <a:extLst xmlns:a="http://schemas.openxmlformats.org/drawingml/2006/main">
               <a:ext uri="{FF2B5EF4-FFF2-40B4-BE49-F238E27FC236}">
-                <a16:creationId xmlns:a16="http://schemas.microsoft.com/office/drawing/2014/main" id="{BFDA6DA5-9187-495D-83AC-F7F1BB8B95CC}"/>
+                <a16:creationId xmlns:a16="http://schemas.microsoft.com/office/drawing/2014/main" id="{63E1486E-8FEF-4DED-92B3-1E64C11B399F}"/>
               </a:ext>
             </a:extLst>
           </p:cNvPr>
@@ -25381,7 +25381,7 @@
           <p:cNvPr id="3" name="">
             <a:extLst xmlns:a="http://schemas.openxmlformats.org/drawingml/2006/main">
               <a:ext uri="{FF2B5EF4-FFF2-40B4-BE49-F238E27FC236}">
-                <a16:creationId xmlns:a16="http://schemas.microsoft.com/office/drawing/2014/main" id="{E0B409F6-E1A3-4088-A07D-B390B0C25677}"/>
+                <a16:creationId xmlns:a16="http://schemas.microsoft.com/office/drawing/2014/main" id="{7B7E7316-9E1D-4D9C-BE4B-546A1BA6D48E}"/>
               </a:ext>
             </a:extLst>
           </p:cNvPr>
@@ -25502,7 +25502,7 @@
           <p:cNvPr id="4" name="">
             <a:extLst xmlns:a="http://schemas.openxmlformats.org/drawingml/2006/main">
               <a:ext uri="{FF2B5EF4-FFF2-40B4-BE49-F238E27FC236}">
-                <a16:creationId xmlns:a16="http://schemas.microsoft.com/office/drawing/2014/main" id="{E47C695E-91FD-4DEB-9EBF-3B4318C4EDEC}"/>
+                <a16:creationId xmlns:a16="http://schemas.microsoft.com/office/drawing/2014/main" id="{2F9C3575-24E5-4673-B59D-EE1C68137622}"/>
               </a:ext>
             </a:extLst>
           </p:cNvPr>
@@ -25533,7 +25533,7 @@
           <p:cNvPr id="5" name="">
             <a:extLst xmlns:a="http://schemas.openxmlformats.org/drawingml/2006/main">
               <a:ext uri="{FF2B5EF4-FFF2-40B4-BE49-F238E27FC236}">
-                <a16:creationId xmlns:a16="http://schemas.microsoft.com/office/drawing/2014/main" id="{90C7BFCC-8A80-4452-9339-73747668260D}"/>
+                <a16:creationId xmlns:a16="http://schemas.microsoft.com/office/drawing/2014/main" id="{950B178C-EABD-489B-9CEF-F6B5A2B4F0A4}"/>
               </a:ext>
             </a:extLst>
           </p:cNvPr>
@@ -25654,7 +25654,7 @@
           <p:cNvPr id="6" name="">
             <a:extLst xmlns:a="http://schemas.openxmlformats.org/drawingml/2006/main">
               <a:ext uri="{FF2B5EF4-FFF2-40B4-BE49-F238E27FC236}">
-                <a16:creationId xmlns:a16="http://schemas.microsoft.com/office/drawing/2014/main" id="{C55AA8B9-7FBF-46B3-BD07-EA9713D9F6EB}"/>
+                <a16:creationId xmlns:a16="http://schemas.microsoft.com/office/drawing/2014/main" id="{D7A45303-8F45-42B9-9571-197A0413638D}"/>
               </a:ext>
             </a:extLst>
           </p:cNvPr>
@@ -25775,7 +25775,7 @@
           <p:cNvPr id="7" name="">
             <a:extLst xmlns:a="http://schemas.openxmlformats.org/drawingml/2006/main">
               <a:ext uri="{FF2B5EF4-FFF2-40B4-BE49-F238E27FC236}">
-                <a16:creationId xmlns:a16="http://schemas.microsoft.com/office/drawing/2014/main" id="{FB86463B-BDF2-42DB-A3C5-98A369CE7B8E}"/>
+                <a16:creationId xmlns:a16="http://schemas.microsoft.com/office/drawing/2014/main" id="{81897396-EC88-41FF-93AC-669806F962B4}"/>
               </a:ext>
             </a:extLst>
           </p:cNvPr>
@@ -25896,7 +25896,7 @@
           <p:cNvPr id="8" name="">
             <a:extLst xmlns:a="http://schemas.openxmlformats.org/drawingml/2006/main">
               <a:ext uri="{FF2B5EF4-FFF2-40B4-BE49-F238E27FC236}">
-                <a16:creationId xmlns:a16="http://schemas.microsoft.com/office/drawing/2014/main" id="{42CE3521-3EE5-4FA2-906E-ABCF654C957B}"/>
+                <a16:creationId xmlns:a16="http://schemas.microsoft.com/office/drawing/2014/main" id="{99221965-F521-415A-924E-E2A3CF7F5389}"/>
               </a:ext>
             </a:extLst>
           </p:cNvPr>
@@ -26017,7 +26017,7 @@
           <p:cNvPr id="9" name="">
             <a:extLst xmlns:a="http://schemas.openxmlformats.org/drawingml/2006/main">
               <a:ext uri="{FF2B5EF4-FFF2-40B4-BE49-F238E27FC236}">
-                <a16:creationId xmlns:a16="http://schemas.microsoft.com/office/drawing/2014/main" id="{812C18C4-A22E-4074-B2D4-522536DE9EAF}"/>
+                <a16:creationId xmlns:a16="http://schemas.microsoft.com/office/drawing/2014/main" id="{650870F1-2C68-42BB-9C48-CFAB692B5186}"/>
               </a:ext>
             </a:extLst>
           </p:cNvPr>
@@ -26138,7 +26138,7 @@
           <p:cNvPr id="10" name="">
             <a:extLst xmlns:a="http://schemas.openxmlformats.org/drawingml/2006/main">
               <a:ext uri="{FF2B5EF4-FFF2-40B4-BE49-F238E27FC236}">
-                <a16:creationId xmlns:a16="http://schemas.microsoft.com/office/drawing/2014/main" id="{068CF7A2-32BD-418F-946D-64A0AD2F9A59}"/>
+                <a16:creationId xmlns:a16="http://schemas.microsoft.com/office/drawing/2014/main" id="{08CEF8E7-67B1-4872-A4F8-E8420ADD8C89}"/>
               </a:ext>
             </a:extLst>
           </p:cNvPr>
@@ -26259,7 +26259,7 @@
           <p:cNvPr id="11" name="">
             <a:extLst xmlns:a="http://schemas.openxmlformats.org/drawingml/2006/main">
               <a:ext uri="{FF2B5EF4-FFF2-40B4-BE49-F238E27FC236}">
-                <a16:creationId xmlns:a16="http://schemas.microsoft.com/office/drawing/2014/main" id="{76C57566-EB77-43A6-AFEF-3668F6A03B5C}"/>
+                <a16:creationId xmlns:a16="http://schemas.microsoft.com/office/drawing/2014/main" id="{98BB7893-DCAF-4A87-8AFC-B9E5E6DB0012}"/>
               </a:ext>
             </a:extLst>
           </p:cNvPr>
@@ -26380,7 +26380,7 @@
           <p:cNvPr id="12" name="">
             <a:extLst xmlns:a="http://schemas.openxmlformats.org/drawingml/2006/main">
               <a:ext uri="{FF2B5EF4-FFF2-40B4-BE49-F238E27FC236}">
-                <a16:creationId xmlns:a16="http://schemas.microsoft.com/office/drawing/2014/main" id="{185BC7EF-121C-4024-A1F0-1F6FBF69C165}"/>
+                <a16:creationId xmlns:a16="http://schemas.microsoft.com/office/drawing/2014/main" id="{205D385A-E600-47AA-BE01-7BBC123C0B08}"/>
               </a:ext>
             </a:extLst>
           </p:cNvPr>
@@ -26413,7 +26413,7 @@
           <p:cNvPr id="13" name="">
             <a:extLst xmlns:a="http://schemas.openxmlformats.org/drawingml/2006/main">
               <a:ext uri="{FF2B5EF4-FFF2-40B4-BE49-F238E27FC236}">
-                <a16:creationId xmlns:a16="http://schemas.microsoft.com/office/drawing/2014/main" id="{A08318D1-82A4-4E2B-A7D0-F7DB1B4EC5C1}"/>
+                <a16:creationId xmlns:a16="http://schemas.microsoft.com/office/drawing/2014/main" id="{F783E10B-E354-4296-A68B-FBC1DAD12D18}"/>
               </a:ext>
             </a:extLst>
           </p:cNvPr>
@@ -26534,7 +26534,7 @@
           <p:cNvPr id="14" name="">
             <a:extLst xmlns:a="http://schemas.openxmlformats.org/drawingml/2006/main">
               <a:ext uri="{FF2B5EF4-FFF2-40B4-BE49-F238E27FC236}">
-                <a16:creationId xmlns:a16="http://schemas.microsoft.com/office/drawing/2014/main" id="{D58536C6-B899-4DD6-8BB9-F41031276A74}"/>
+                <a16:creationId xmlns:a16="http://schemas.microsoft.com/office/drawing/2014/main" id="{F31F7F09-C4DE-4A21-86F5-5755AD897582}"/>
               </a:ext>
             </a:extLst>
           </p:cNvPr>
@@ -26655,7 +26655,7 @@
           <p:cNvPr id="15" name="">
             <a:extLst xmlns:a="http://schemas.openxmlformats.org/drawingml/2006/main">
               <a:ext uri="{FF2B5EF4-FFF2-40B4-BE49-F238E27FC236}">
-                <a16:creationId xmlns:a16="http://schemas.microsoft.com/office/drawing/2014/main" id="{7090C815-A1CD-4645-967C-0C3F1803A8EC}"/>
+                <a16:creationId xmlns:a16="http://schemas.microsoft.com/office/drawing/2014/main" id="{A03340B8-E241-466A-BA81-4442A6DE9E3F}"/>
               </a:ext>
             </a:extLst>
           </p:cNvPr>
@@ -26776,7 +26776,7 @@
           <p:cNvPr id="16" name="">
             <a:extLst xmlns:a="http://schemas.openxmlformats.org/drawingml/2006/main">
               <a:ext uri="{FF2B5EF4-FFF2-40B4-BE49-F238E27FC236}">
-                <a16:creationId xmlns:a16="http://schemas.microsoft.com/office/drawing/2014/main" id="{85C8D42E-DCFC-41D8-8F7D-9A1F0F3BAF37}"/>
+                <a16:creationId xmlns:a16="http://schemas.microsoft.com/office/drawing/2014/main" id="{43320C65-A38B-4FD7-B8AF-84FAB0D206BB}"/>
               </a:ext>
             </a:extLst>
           </p:cNvPr>
@@ -26897,7 +26897,7 @@
           <p:cNvPr id="17" name="">
             <a:extLst xmlns:a="http://schemas.openxmlformats.org/drawingml/2006/main">
               <a:ext uri="{FF2B5EF4-FFF2-40B4-BE49-F238E27FC236}">
-                <a16:creationId xmlns:a16="http://schemas.microsoft.com/office/drawing/2014/main" id="{FF7A9F5C-84A7-409E-88F4-F07F2DA39932}"/>
+                <a16:creationId xmlns:a16="http://schemas.microsoft.com/office/drawing/2014/main" id="{1E2D5C19-1588-4B91-ADB6-2076CF702365}"/>
               </a:ext>
             </a:extLst>
           </p:cNvPr>
@@ -27018,7 +27018,7 @@
           <p:cNvPr id="18" name="">
             <a:extLst xmlns:a="http://schemas.openxmlformats.org/drawingml/2006/main">
               <a:ext uri="{FF2B5EF4-FFF2-40B4-BE49-F238E27FC236}">
-                <a16:creationId xmlns:a16="http://schemas.microsoft.com/office/drawing/2014/main" id="{7B5B9296-690A-40A3-A92F-ABB6779E4644}"/>
+                <a16:creationId xmlns:a16="http://schemas.microsoft.com/office/drawing/2014/main" id="{54D1AED2-9B9C-4137-B5FC-47576B5D1576}"/>
               </a:ext>
             </a:extLst>
           </p:cNvPr>
@@ -27137,7 +27137,7 @@
     </p:spTree>
     <p:extLst>
       <p:ext uri="{BB962C8B-B14F-4D97-AF65-F5344CB8AC3E}">
-        <p14:creationId xmlns:p14="http://schemas.microsoft.com/office/powerpoint/2010/main" val="454012543"/>
+        <p14:creationId xmlns:p14="http://schemas.microsoft.com/office/powerpoint/2010/main" val="1059157319"/>
       </p:ext>
     </p:extLst>
   </p:cSld>
@@ -27168,7 +27168,7 @@
           <p:cNvPr id="16" name="">
             <a:extLst xmlns:a="http://schemas.openxmlformats.org/drawingml/2006/main">
               <a:ext uri="{FF2B5EF4-FFF2-40B4-BE49-F238E27FC236}">
-                <a16:creationId xmlns:a16="http://schemas.microsoft.com/office/drawing/2014/main" id="{B554A1D8-72A3-48F4-BB57-B569767B38F6}"/>
+                <a16:creationId xmlns:a16="http://schemas.microsoft.com/office/drawing/2014/main" id="{FE1A650C-EFD6-4E18-82DD-DA0A66D889D9}"/>
               </a:ext>
             </a:extLst>
           </p:cNvPr>
@@ -27199,7 +27199,7 @@
           <p:cNvPr id="2" name="">
             <a:extLst xmlns:a="http://schemas.openxmlformats.org/drawingml/2006/main">
               <a:ext uri="{FF2B5EF4-FFF2-40B4-BE49-F238E27FC236}">
-                <a16:creationId xmlns:a16="http://schemas.microsoft.com/office/drawing/2014/main" id="{E7C8F9F3-72A1-40D3-9E0A-EE14DA040956}"/>
+                <a16:creationId xmlns:a16="http://schemas.microsoft.com/office/drawing/2014/main" id="{A017B84C-4AD3-4CBB-BFF2-46F82B4EC7B0}"/>
               </a:ext>
             </a:extLst>
           </p:cNvPr>
@@ -27320,7 +27320,7 @@
           <p:cNvPr id="3" name="">
             <a:extLst xmlns:a="http://schemas.openxmlformats.org/drawingml/2006/main">
               <a:ext uri="{FF2B5EF4-FFF2-40B4-BE49-F238E27FC236}">
-                <a16:creationId xmlns:a16="http://schemas.microsoft.com/office/drawing/2014/main" id="{CBB9AC81-B613-45C2-A05A-4A192A91497F}"/>
+                <a16:creationId xmlns:a16="http://schemas.microsoft.com/office/drawing/2014/main" id="{B0D5B551-01CE-4EE9-9451-DBDE1642FFED}"/>
               </a:ext>
             </a:extLst>
           </p:cNvPr>
@@ -27441,7 +27441,7 @@
           <p:cNvPr id="4" name="">
             <a:extLst xmlns:a="http://schemas.openxmlformats.org/drawingml/2006/main">
               <a:ext uri="{FF2B5EF4-FFF2-40B4-BE49-F238E27FC236}">
-                <a16:creationId xmlns:a16="http://schemas.microsoft.com/office/drawing/2014/main" id="{2BE55A51-D224-4DB7-B6B0-49EE02327B09}"/>
+                <a16:creationId xmlns:a16="http://schemas.microsoft.com/office/drawing/2014/main" id="{ABE56053-CF05-48F4-896B-3F33807499D1}"/>
               </a:ext>
             </a:extLst>
           </p:cNvPr>
@@ -27472,7 +27472,7 @@
           <p:cNvPr id="5" name="">
             <a:extLst xmlns:a="http://schemas.openxmlformats.org/drawingml/2006/main">
               <a:ext uri="{FF2B5EF4-FFF2-40B4-BE49-F238E27FC236}">
-                <a16:creationId xmlns:a16="http://schemas.microsoft.com/office/drawing/2014/main" id="{69F175F9-BA81-40C7-8B84-A2E8A08B537C}"/>
+                <a16:creationId xmlns:a16="http://schemas.microsoft.com/office/drawing/2014/main" id="{61816014-A130-4DFC-B490-6F4185A90E5B}"/>
               </a:ext>
             </a:extLst>
           </p:cNvPr>
@@ -27593,7 +27593,7 @@
           <p:cNvPr id="6" name="">
             <a:extLst xmlns:a="http://schemas.openxmlformats.org/drawingml/2006/main">
               <a:ext uri="{FF2B5EF4-FFF2-40B4-BE49-F238E27FC236}">
-                <a16:creationId xmlns:a16="http://schemas.microsoft.com/office/drawing/2014/main" id="{9A06A4CB-641A-4FF0-8C64-396F4ED6204D}"/>
+                <a16:creationId xmlns:a16="http://schemas.microsoft.com/office/drawing/2014/main" id="{ACEBD212-B153-4D2B-A760-41726F9E0B6A}"/>
               </a:ext>
             </a:extLst>
           </p:cNvPr>
@@ -27714,7 +27714,7 @@
           <p:cNvPr id="7" name="">
             <a:extLst xmlns:a="http://schemas.openxmlformats.org/drawingml/2006/main">
               <a:ext uri="{FF2B5EF4-FFF2-40B4-BE49-F238E27FC236}">
-                <a16:creationId xmlns:a16="http://schemas.microsoft.com/office/drawing/2014/main" id="{5F3AD73C-6319-4E27-9E2E-F3FFFFFF00E3}"/>
+                <a16:creationId xmlns:a16="http://schemas.microsoft.com/office/drawing/2014/main" id="{F40F42B0-F568-4B2F-9C2B-C7F34075248C}"/>
               </a:ext>
             </a:extLst>
           </p:cNvPr>
@@ -27835,7 +27835,7 @@
           <p:cNvPr id="8" name="">
             <a:extLst xmlns:a="http://schemas.openxmlformats.org/drawingml/2006/main">
               <a:ext uri="{FF2B5EF4-FFF2-40B4-BE49-F238E27FC236}">
-                <a16:creationId xmlns:a16="http://schemas.microsoft.com/office/drawing/2014/main" id="{08C9499A-93DA-4AC2-A813-8BA87C6C25AC}"/>
+                <a16:creationId xmlns:a16="http://schemas.microsoft.com/office/drawing/2014/main" id="{C1E1A14E-BF0C-4978-903C-19C7FE228052}"/>
               </a:ext>
             </a:extLst>
           </p:cNvPr>
@@ -27956,7 +27956,7 @@
           <p:cNvPr id="9" name="">
             <a:extLst xmlns:a="http://schemas.openxmlformats.org/drawingml/2006/main">
               <a:ext uri="{FF2B5EF4-FFF2-40B4-BE49-F238E27FC236}">
-                <a16:creationId xmlns:a16="http://schemas.microsoft.com/office/drawing/2014/main" id="{BAA2D978-B9B1-4CEE-A6D1-C3C22E9B1E63}"/>
+                <a16:creationId xmlns:a16="http://schemas.microsoft.com/office/drawing/2014/main" id="{CB79B4B4-FEED-40B9-AA2B-92D3DA510B3A}"/>
               </a:ext>
             </a:extLst>
           </p:cNvPr>
@@ -28077,7 +28077,7 @@
           <p:cNvPr id="10" name="">
             <a:extLst xmlns:a="http://schemas.openxmlformats.org/drawingml/2006/main">
               <a:ext uri="{FF2B5EF4-FFF2-40B4-BE49-F238E27FC236}">
-                <a16:creationId xmlns:a16="http://schemas.microsoft.com/office/drawing/2014/main" id="{A0BF26F0-DAF2-45C1-A1A8-B79CABF86642}"/>
+                <a16:creationId xmlns:a16="http://schemas.microsoft.com/office/drawing/2014/main" id="{4F3CA8F2-30BA-4EB4-93AA-B3424C2CB4D0}"/>
               </a:ext>
             </a:extLst>
           </p:cNvPr>
@@ -28198,7 +28198,7 @@
           <p:cNvPr id="11" name="">
             <a:extLst xmlns:a="http://schemas.openxmlformats.org/drawingml/2006/main">
               <a:ext uri="{FF2B5EF4-FFF2-40B4-BE49-F238E27FC236}">
-                <a16:creationId xmlns:a16="http://schemas.microsoft.com/office/drawing/2014/main" id="{45096084-2C23-4916-A1AF-F6837FED7D5E}"/>
+                <a16:creationId xmlns:a16="http://schemas.microsoft.com/office/drawing/2014/main" id="{F0A3B37D-69D5-44D3-82EA-DE0A307FA27B}"/>
               </a:ext>
             </a:extLst>
           </p:cNvPr>
@@ -28319,7 +28319,7 @@
           <p:cNvPr id="12" name="">
             <a:extLst xmlns:a="http://schemas.openxmlformats.org/drawingml/2006/main">
               <a:ext uri="{FF2B5EF4-FFF2-40B4-BE49-F238E27FC236}">
-                <a16:creationId xmlns:a16="http://schemas.microsoft.com/office/drawing/2014/main" id="{F527AFE7-1A6E-4E1F-BEEC-31B2C172E1AB}"/>
+                <a16:creationId xmlns:a16="http://schemas.microsoft.com/office/drawing/2014/main" id="{F4249F20-2906-4FB9-8C55-6AD80FB746CF}"/>
               </a:ext>
             </a:extLst>
           </p:cNvPr>
@@ -28440,7 +28440,7 @@
           <p:cNvPr id="13" name="">
             <a:extLst xmlns:a="http://schemas.openxmlformats.org/drawingml/2006/main">
               <a:ext uri="{FF2B5EF4-FFF2-40B4-BE49-F238E27FC236}">
-                <a16:creationId xmlns:a16="http://schemas.microsoft.com/office/drawing/2014/main" id="{388C775E-869A-4294-AD92-4B9A047F6F37}"/>
+                <a16:creationId xmlns:a16="http://schemas.microsoft.com/office/drawing/2014/main" id="{140F02F4-883A-4471-8D94-C91A0C7895A1}"/>
               </a:ext>
             </a:extLst>
           </p:cNvPr>
@@ -28561,7 +28561,7 @@
           <p:cNvPr id="14" name="">
             <a:extLst xmlns:a="http://schemas.openxmlformats.org/drawingml/2006/main">
               <a:ext uri="{FF2B5EF4-FFF2-40B4-BE49-F238E27FC236}">
-                <a16:creationId xmlns:a16="http://schemas.microsoft.com/office/drawing/2014/main" id="{9C01A859-4EE1-4C54-8804-79D9CA03BABC}"/>
+                <a16:creationId xmlns:a16="http://schemas.microsoft.com/office/drawing/2014/main" id="{7FB6F322-DA12-4318-8884-CD6455C4D431}"/>
               </a:ext>
             </a:extLst>
           </p:cNvPr>
@@ -28594,7 +28594,7 @@
           <p:cNvPr id="15" name="">
             <a:extLst xmlns:a="http://schemas.openxmlformats.org/drawingml/2006/main">
               <a:ext uri="{FF2B5EF4-FFF2-40B4-BE49-F238E27FC236}">
-                <a16:creationId xmlns:a16="http://schemas.microsoft.com/office/drawing/2014/main" id="{13B273FB-64B0-4747-B029-34A41062832D}"/>
+                <a16:creationId xmlns:a16="http://schemas.microsoft.com/office/drawing/2014/main" id="{71710211-8E12-4D62-B719-39E1A5C8B17E}"/>
               </a:ext>
             </a:extLst>
           </p:cNvPr>
@@ -28713,7 +28713,7 @@
     </p:spTree>
     <p:extLst>
       <p:ext uri="{BB962C8B-B14F-4D97-AF65-F5344CB8AC3E}">
-        <p14:creationId xmlns:p14="http://schemas.microsoft.com/office/powerpoint/2010/main" val="1706627730"/>
+        <p14:creationId xmlns:p14="http://schemas.microsoft.com/office/powerpoint/2010/main" val="941113738"/>
       </p:ext>
     </p:extLst>
   </p:cSld>
@@ -28744,7 +28744,7 @@
           <p:cNvPr id="27" name="">
             <a:extLst xmlns:a="http://schemas.openxmlformats.org/drawingml/2006/main">
               <a:ext uri="{FF2B5EF4-FFF2-40B4-BE49-F238E27FC236}">
-                <a16:creationId xmlns:a16="http://schemas.microsoft.com/office/drawing/2014/main" id="{DECB4394-AEF6-4845-94AC-400948FBCCFF}"/>
+                <a16:creationId xmlns:a16="http://schemas.microsoft.com/office/drawing/2014/main" id="{436E13BB-4931-4E97-B959-18BB1427E825}"/>
               </a:ext>
             </a:extLst>
           </p:cNvPr>
@@ -28775,7 +28775,7 @@
           <p:cNvPr id="2" name="">
             <a:extLst xmlns:a="http://schemas.openxmlformats.org/drawingml/2006/main">
               <a:ext uri="{FF2B5EF4-FFF2-40B4-BE49-F238E27FC236}">
-                <a16:creationId xmlns:a16="http://schemas.microsoft.com/office/drawing/2014/main" id="{2BAE6CF0-6769-4D38-A108-5A6B4D869BCD}"/>
+                <a16:creationId xmlns:a16="http://schemas.microsoft.com/office/drawing/2014/main" id="{86043466-C593-4A72-8570-4E07813F9743}"/>
               </a:ext>
             </a:extLst>
           </p:cNvPr>
@@ -28896,7 +28896,7 @@
           <p:cNvPr id="3" name="">
             <a:extLst xmlns:a="http://schemas.openxmlformats.org/drawingml/2006/main">
               <a:ext uri="{FF2B5EF4-FFF2-40B4-BE49-F238E27FC236}">
-                <a16:creationId xmlns:a16="http://schemas.microsoft.com/office/drawing/2014/main" id="{4FCF93EE-118D-4284-977B-09B29CE766CD}"/>
+                <a16:creationId xmlns:a16="http://schemas.microsoft.com/office/drawing/2014/main" id="{22A78D57-7DC5-45C5-BB8B-7A8F50497DA5}"/>
               </a:ext>
             </a:extLst>
           </p:cNvPr>
@@ -29017,7 +29017,7 @@
           <p:cNvPr id="4" name="">
             <a:extLst xmlns:a="http://schemas.openxmlformats.org/drawingml/2006/main">
               <a:ext uri="{FF2B5EF4-FFF2-40B4-BE49-F238E27FC236}">
-                <a16:creationId xmlns:a16="http://schemas.microsoft.com/office/drawing/2014/main" id="{9B4DD9A0-93BB-420B-9F98-F4F456565997}"/>
+                <a16:creationId xmlns:a16="http://schemas.microsoft.com/office/drawing/2014/main" id="{1547ED0D-E875-47CB-8B7B-B1B58CF4E583}"/>
               </a:ext>
             </a:extLst>
           </p:cNvPr>
@@ -29048,7 +29048,7 @@
           <p:cNvPr id="5" name="">
             <a:extLst xmlns:a="http://schemas.openxmlformats.org/drawingml/2006/main">
               <a:ext uri="{FF2B5EF4-FFF2-40B4-BE49-F238E27FC236}">
-                <a16:creationId xmlns:a16="http://schemas.microsoft.com/office/drawing/2014/main" id="{AED9B771-8FF0-47EA-B0EC-CF06A063FEBE}"/>
+                <a16:creationId xmlns:a16="http://schemas.microsoft.com/office/drawing/2014/main" id="{ECB2C5E4-65AE-4A06-B2B1-D8D019F8A7FC}"/>
               </a:ext>
             </a:extLst>
           </p:cNvPr>
@@ -29169,7 +29169,7 @@
           <p:cNvPr id="6" name="">
             <a:extLst xmlns:a="http://schemas.openxmlformats.org/drawingml/2006/main">
               <a:ext uri="{FF2B5EF4-FFF2-40B4-BE49-F238E27FC236}">
-                <a16:creationId xmlns:a16="http://schemas.microsoft.com/office/drawing/2014/main" id="{CB54204E-2014-4084-8B72-F00FC38FF814}"/>
+                <a16:creationId xmlns:a16="http://schemas.microsoft.com/office/drawing/2014/main" id="{B170C133-5525-46A6-BFD0-BAEF1107C787}"/>
               </a:ext>
             </a:extLst>
           </p:cNvPr>
@@ -29290,7 +29290,7 @@
           <p:cNvPr id="7" name="">
             <a:extLst xmlns:a="http://schemas.openxmlformats.org/drawingml/2006/main">
               <a:ext uri="{FF2B5EF4-FFF2-40B4-BE49-F238E27FC236}">
-                <a16:creationId xmlns:a16="http://schemas.microsoft.com/office/drawing/2014/main" id="{66CACF6C-7045-4D0A-8543-848E1EE8B942}"/>
+                <a16:creationId xmlns:a16="http://schemas.microsoft.com/office/drawing/2014/main" id="{F242428B-B722-49A7-9EE1-74E94BE37254}"/>
               </a:ext>
             </a:extLst>
           </p:cNvPr>
@@ -29411,7 +29411,7 @@
           <p:cNvPr id="8" name="">
             <a:extLst xmlns:a="http://schemas.openxmlformats.org/drawingml/2006/main">
               <a:ext uri="{FF2B5EF4-FFF2-40B4-BE49-F238E27FC236}">
-                <a16:creationId xmlns:a16="http://schemas.microsoft.com/office/drawing/2014/main" id="{F63B913B-3E99-4821-9EA3-8339B2743D11}"/>
+                <a16:creationId xmlns:a16="http://schemas.microsoft.com/office/drawing/2014/main" id="{44743F0B-2972-4515-BF2B-67C6D0F7957F}"/>
               </a:ext>
             </a:extLst>
           </p:cNvPr>
@@ -29532,7 +29532,7 @@
           <p:cNvPr id="9" name="">
             <a:extLst xmlns:a="http://schemas.openxmlformats.org/drawingml/2006/main">
               <a:ext uri="{FF2B5EF4-FFF2-40B4-BE49-F238E27FC236}">
-                <a16:creationId xmlns:a16="http://schemas.microsoft.com/office/drawing/2014/main" id="{327F955B-7D5C-473C-8839-948EFF16E850}"/>
+                <a16:creationId xmlns:a16="http://schemas.microsoft.com/office/drawing/2014/main" id="{B7A56987-DD65-4D9A-9723-8B8C79B5F6F4}"/>
               </a:ext>
             </a:extLst>
           </p:cNvPr>
@@ -29563,7 +29563,7 @@
           <p:cNvPr id="10" name="">
             <a:extLst xmlns:a="http://schemas.openxmlformats.org/drawingml/2006/main">
               <a:ext uri="{FF2B5EF4-FFF2-40B4-BE49-F238E27FC236}">
-                <a16:creationId xmlns:a16="http://schemas.microsoft.com/office/drawing/2014/main" id="{DA25E61F-A307-47AF-9317-0D04A2B4F903}"/>
+                <a16:creationId xmlns:a16="http://schemas.microsoft.com/office/drawing/2014/main" id="{90F27B8D-6CAD-410A-99ED-E15F39B6376E}"/>
               </a:ext>
             </a:extLst>
           </p:cNvPr>
@@ -29684,7 +29684,7 @@
           <p:cNvPr id="11" name="">
             <a:extLst xmlns:a="http://schemas.openxmlformats.org/drawingml/2006/main">
               <a:ext uri="{FF2B5EF4-FFF2-40B4-BE49-F238E27FC236}">
-                <a16:creationId xmlns:a16="http://schemas.microsoft.com/office/drawing/2014/main" id="{AAB84208-3D90-4879-898B-5D14F612C618}"/>
+                <a16:creationId xmlns:a16="http://schemas.microsoft.com/office/drawing/2014/main" id="{F7F22B0B-32C9-4155-8351-4106DD89421C}"/>
               </a:ext>
             </a:extLst>
           </p:cNvPr>
@@ -29805,7 +29805,7 @@
           <p:cNvPr id="12" name="">
             <a:extLst xmlns:a="http://schemas.openxmlformats.org/drawingml/2006/main">
               <a:ext uri="{FF2B5EF4-FFF2-40B4-BE49-F238E27FC236}">
-                <a16:creationId xmlns:a16="http://schemas.microsoft.com/office/drawing/2014/main" id="{2227C549-9D9B-4A93-AECF-E814C6805165}"/>
+                <a16:creationId xmlns:a16="http://schemas.microsoft.com/office/drawing/2014/main" id="{FDA88DEF-6E95-4C2A-87FF-24E5BB88C6F8}"/>
               </a:ext>
             </a:extLst>
           </p:cNvPr>
@@ -29926,7 +29926,7 @@
           <p:cNvPr id="13" name="">
             <a:extLst xmlns:a="http://schemas.openxmlformats.org/drawingml/2006/main">
               <a:ext uri="{FF2B5EF4-FFF2-40B4-BE49-F238E27FC236}">
-                <a16:creationId xmlns:a16="http://schemas.microsoft.com/office/drawing/2014/main" id="{FEBAA563-3E21-42A3-920F-D47812A8F0E1}"/>
+                <a16:creationId xmlns:a16="http://schemas.microsoft.com/office/drawing/2014/main" id="{E2254059-C1CA-4579-800F-DF03CC7055B6}"/>
               </a:ext>
             </a:extLst>
           </p:cNvPr>
@@ -29957,7 +29957,7 @@
           <p:cNvPr id="14" name="">
             <a:extLst xmlns:a="http://schemas.openxmlformats.org/drawingml/2006/main">
               <a:ext uri="{FF2B5EF4-FFF2-40B4-BE49-F238E27FC236}">
-                <a16:creationId xmlns:a16="http://schemas.microsoft.com/office/drawing/2014/main" id="{41696774-0A04-4E8E-9D89-33962C345EBE}"/>
+                <a16:creationId xmlns:a16="http://schemas.microsoft.com/office/drawing/2014/main" id="{A32E6E88-8A17-4226-B170-AFF861B3EBD3}"/>
               </a:ext>
             </a:extLst>
           </p:cNvPr>
@@ -30078,7 +30078,7 @@
           <p:cNvPr id="15" name="">
             <a:extLst xmlns:a="http://schemas.openxmlformats.org/drawingml/2006/main">
               <a:ext uri="{FF2B5EF4-FFF2-40B4-BE49-F238E27FC236}">
-                <a16:creationId xmlns:a16="http://schemas.microsoft.com/office/drawing/2014/main" id="{03D116A1-2BDB-4A42-8237-392998FA0617}"/>
+                <a16:creationId xmlns:a16="http://schemas.microsoft.com/office/drawing/2014/main" id="{06C93E2F-020B-4CF3-AA31-F94ED36BEC37}"/>
               </a:ext>
             </a:extLst>
           </p:cNvPr>
@@ -30199,7 +30199,7 @@
           <p:cNvPr id="16" name="">
             <a:extLst xmlns:a="http://schemas.openxmlformats.org/drawingml/2006/main">
               <a:ext uri="{FF2B5EF4-FFF2-40B4-BE49-F238E27FC236}">
-                <a16:creationId xmlns:a16="http://schemas.microsoft.com/office/drawing/2014/main" id="{F044F1B2-313E-4EE6-AD53-CC2F1B0F3ABC}"/>
+                <a16:creationId xmlns:a16="http://schemas.microsoft.com/office/drawing/2014/main" id="{FA7276DF-3843-41F2-8ACD-391E624AC012}"/>
               </a:ext>
             </a:extLst>
           </p:cNvPr>
@@ -30320,7 +30320,7 @@
           <p:cNvPr id="17" name="">
             <a:extLst xmlns:a="http://schemas.openxmlformats.org/drawingml/2006/main">
               <a:ext uri="{FF2B5EF4-FFF2-40B4-BE49-F238E27FC236}">
-                <a16:creationId xmlns:a16="http://schemas.microsoft.com/office/drawing/2014/main" id="{B6312062-CC55-4451-9E02-60E8367BAD49}"/>
+                <a16:creationId xmlns:a16="http://schemas.microsoft.com/office/drawing/2014/main" id="{35FA4628-D9D4-49D2-BEB9-9CA39706D2D5}"/>
               </a:ext>
             </a:extLst>
           </p:cNvPr>
@@ -30351,7 +30351,7 @@
           <p:cNvPr id="18" name="">
             <a:extLst xmlns:a="http://schemas.openxmlformats.org/drawingml/2006/main">
               <a:ext uri="{FF2B5EF4-FFF2-40B4-BE49-F238E27FC236}">
-                <a16:creationId xmlns:a16="http://schemas.microsoft.com/office/drawing/2014/main" id="{CDD761E9-12C3-4762-8C43-6BC69788506A}"/>
+                <a16:creationId xmlns:a16="http://schemas.microsoft.com/office/drawing/2014/main" id="{DD70DB5F-6383-4358-8922-E0CE26F3BA80}"/>
               </a:ext>
             </a:extLst>
           </p:cNvPr>
@@ -30472,7 +30472,7 @@
           <p:cNvPr id="19" name="">
             <a:extLst xmlns:a="http://schemas.openxmlformats.org/drawingml/2006/main">
               <a:ext uri="{FF2B5EF4-FFF2-40B4-BE49-F238E27FC236}">
-                <a16:creationId xmlns:a16="http://schemas.microsoft.com/office/drawing/2014/main" id="{7F838546-5098-4428-B598-D3D53BCE436D}"/>
+                <a16:creationId xmlns:a16="http://schemas.microsoft.com/office/drawing/2014/main" id="{A71482BB-D218-4C43-BB82-1EE5297BE03B}"/>
               </a:ext>
             </a:extLst>
           </p:cNvPr>
@@ -30593,7 +30593,7 @@
           <p:cNvPr id="20" name="">
             <a:extLst xmlns:a="http://schemas.openxmlformats.org/drawingml/2006/main">
               <a:ext uri="{FF2B5EF4-FFF2-40B4-BE49-F238E27FC236}">
-                <a16:creationId xmlns:a16="http://schemas.microsoft.com/office/drawing/2014/main" id="{DAE2D60B-19A7-4F02-992D-95CC4086DD59}"/>
+                <a16:creationId xmlns:a16="http://schemas.microsoft.com/office/drawing/2014/main" id="{45529971-AD4D-4F2D-85D6-4C15E3161EB3}"/>
               </a:ext>
             </a:extLst>
           </p:cNvPr>
@@ -30714,7 +30714,7 @@
           <p:cNvPr id="21" name="">
             <a:extLst xmlns:a="http://schemas.openxmlformats.org/drawingml/2006/main">
               <a:ext uri="{FF2B5EF4-FFF2-40B4-BE49-F238E27FC236}">
-                <a16:creationId xmlns:a16="http://schemas.microsoft.com/office/drawing/2014/main" id="{47201EE6-DFB6-4288-A4F0-4EA4AE309EB9}"/>
+                <a16:creationId xmlns:a16="http://schemas.microsoft.com/office/drawing/2014/main" id="{E2A1B15B-4F9B-474D-9ACA-67C54DC79021}"/>
               </a:ext>
             </a:extLst>
           </p:cNvPr>
@@ -30745,7 +30745,7 @@
           <p:cNvPr id="22" name="">
             <a:extLst xmlns:a="http://schemas.openxmlformats.org/drawingml/2006/main">
               <a:ext uri="{FF2B5EF4-FFF2-40B4-BE49-F238E27FC236}">
-                <a16:creationId xmlns:a16="http://schemas.microsoft.com/office/drawing/2014/main" id="{CE9DF6E5-E2BC-417C-B92F-509DAC30E74B}"/>
+                <a16:creationId xmlns:a16="http://schemas.microsoft.com/office/drawing/2014/main" id="{B1A167D6-0FFF-454F-9DC9-EF1551CB4446}"/>
               </a:ext>
             </a:extLst>
           </p:cNvPr>
@@ -30866,7 +30866,7 @@
           <p:cNvPr id="23" name="">
             <a:extLst xmlns:a="http://schemas.openxmlformats.org/drawingml/2006/main">
               <a:ext uri="{FF2B5EF4-FFF2-40B4-BE49-F238E27FC236}">
-                <a16:creationId xmlns:a16="http://schemas.microsoft.com/office/drawing/2014/main" id="{B7CDC69A-1660-4538-95EE-999894B76F79}"/>
+                <a16:creationId xmlns:a16="http://schemas.microsoft.com/office/drawing/2014/main" id="{FD24CAB5-AA08-4509-9DBC-E1110605564F}"/>
               </a:ext>
             </a:extLst>
           </p:cNvPr>
@@ -30987,7 +30987,7 @@
           <p:cNvPr id="24" name="">
             <a:extLst xmlns:a="http://schemas.openxmlformats.org/drawingml/2006/main">
               <a:ext uri="{FF2B5EF4-FFF2-40B4-BE49-F238E27FC236}">
-                <a16:creationId xmlns:a16="http://schemas.microsoft.com/office/drawing/2014/main" id="{B4BFD519-D438-42C1-AF42-F464F4F1916B}"/>
+                <a16:creationId xmlns:a16="http://schemas.microsoft.com/office/drawing/2014/main" id="{D20DB8D7-4501-4845-AED4-9E81EDB830F4}"/>
               </a:ext>
             </a:extLst>
           </p:cNvPr>
@@ -31108,7 +31108,7 @@
           <p:cNvPr id="25" name="">
             <a:extLst xmlns:a="http://schemas.openxmlformats.org/drawingml/2006/main">
               <a:ext uri="{FF2B5EF4-FFF2-40B4-BE49-F238E27FC236}">
-                <a16:creationId xmlns:a16="http://schemas.microsoft.com/office/drawing/2014/main" id="{762C1A6A-3892-4AEA-B5A2-7A0A6754708D}"/>
+                <a16:creationId xmlns:a16="http://schemas.microsoft.com/office/drawing/2014/main" id="{4E43501C-1C2D-4C5D-B85B-FAF0696E0203}"/>
               </a:ext>
             </a:extLst>
           </p:cNvPr>
@@ -31139,7 +31139,7 @@
           <p:cNvPr id="26" name="">
             <a:extLst xmlns:a="http://schemas.openxmlformats.org/drawingml/2006/main">
               <a:ext uri="{FF2B5EF4-FFF2-40B4-BE49-F238E27FC236}">
-                <a16:creationId xmlns:a16="http://schemas.microsoft.com/office/drawing/2014/main" id="{665E7D2F-CE71-4434-BF3D-73A475279503}"/>
+                <a16:creationId xmlns:a16="http://schemas.microsoft.com/office/drawing/2014/main" id="{4893A974-D3FA-49B2-BE8D-BC6F3F37B3C3}"/>
               </a:ext>
             </a:extLst>
           </p:cNvPr>
@@ -31258,7 +31258,7 @@
     </p:spTree>
     <p:extLst>
       <p:ext uri="{BB962C8B-B14F-4D97-AF65-F5344CB8AC3E}">
-        <p14:creationId xmlns:p14="http://schemas.microsoft.com/office/powerpoint/2010/main" val="1852063280"/>
+        <p14:creationId xmlns:p14="http://schemas.microsoft.com/office/powerpoint/2010/main" val="547090185"/>
       </p:ext>
     </p:extLst>
   </p:cSld>
@@ -31289,7 +31289,7 @@
           <p:cNvPr id="18" name="">
             <a:extLst xmlns:a="http://schemas.openxmlformats.org/drawingml/2006/main">
               <a:ext uri="{FF2B5EF4-FFF2-40B4-BE49-F238E27FC236}">
-                <a16:creationId xmlns:a16="http://schemas.microsoft.com/office/drawing/2014/main" id="{543E01FE-F15B-4DB6-A19B-F53FB85EE6D6}"/>
+                <a16:creationId xmlns:a16="http://schemas.microsoft.com/office/drawing/2014/main" id="{E2B74394-1D6E-4A7D-9724-1BFEFB5226A4}"/>
               </a:ext>
             </a:extLst>
           </p:cNvPr>
@@ -31320,7 +31320,7 @@
           <p:cNvPr id="2" name="">
             <a:extLst xmlns:a="http://schemas.openxmlformats.org/drawingml/2006/main">
               <a:ext uri="{FF2B5EF4-FFF2-40B4-BE49-F238E27FC236}">
-                <a16:creationId xmlns:a16="http://schemas.microsoft.com/office/drawing/2014/main" id="{8440F707-6C86-481C-80F7-2E68D2C34AB7}"/>
+                <a16:creationId xmlns:a16="http://schemas.microsoft.com/office/drawing/2014/main" id="{B3A9B096-0B69-4384-8411-18B79DBE8F29}"/>
               </a:ext>
             </a:extLst>
           </p:cNvPr>
@@ -31441,7 +31441,7 @@
           <p:cNvPr id="3" name="">
             <a:extLst xmlns:a="http://schemas.openxmlformats.org/drawingml/2006/main">
               <a:ext uri="{FF2B5EF4-FFF2-40B4-BE49-F238E27FC236}">
-                <a16:creationId xmlns:a16="http://schemas.microsoft.com/office/drawing/2014/main" id="{31730738-8313-4ABC-B71E-25BA81FC949D}"/>
+                <a16:creationId xmlns:a16="http://schemas.microsoft.com/office/drawing/2014/main" id="{FE610A2A-6576-4314-BE09-535D5DCB0C37}"/>
               </a:ext>
             </a:extLst>
           </p:cNvPr>
@@ -31562,7 +31562,7 @@
           <p:cNvPr id="4" name="">
             <a:extLst xmlns:a="http://schemas.openxmlformats.org/drawingml/2006/main">
               <a:ext uri="{FF2B5EF4-FFF2-40B4-BE49-F238E27FC236}">
-                <a16:creationId xmlns:a16="http://schemas.microsoft.com/office/drawing/2014/main" id="{877C39AD-3DE6-4A8C-B1AD-7451DA3DFADD}"/>
+                <a16:creationId xmlns:a16="http://schemas.microsoft.com/office/drawing/2014/main" id="{80151607-B600-4622-8399-285EC255CBDD}"/>
               </a:ext>
             </a:extLst>
           </p:cNvPr>
@@ -31593,7 +31593,7 @@
           <p:cNvPr id="5" name="">
             <a:extLst xmlns:a="http://schemas.openxmlformats.org/drawingml/2006/main">
               <a:ext uri="{FF2B5EF4-FFF2-40B4-BE49-F238E27FC236}">
-                <a16:creationId xmlns:a16="http://schemas.microsoft.com/office/drawing/2014/main" id="{9A6E0278-9193-453E-899B-0517897914AC}"/>
+                <a16:creationId xmlns:a16="http://schemas.microsoft.com/office/drawing/2014/main" id="{8F1101AF-052A-49D5-A90F-FAA43EB5C003}"/>
               </a:ext>
             </a:extLst>
           </p:cNvPr>
@@ -31714,7 +31714,7 @@
           <p:cNvPr id="6" name="">
             <a:extLst xmlns:a="http://schemas.openxmlformats.org/drawingml/2006/main">
               <a:ext uri="{FF2B5EF4-FFF2-40B4-BE49-F238E27FC236}">
-                <a16:creationId xmlns:a16="http://schemas.microsoft.com/office/drawing/2014/main" id="{CF67A923-8541-4099-9B19-FEDFEB592EE6}"/>
+                <a16:creationId xmlns:a16="http://schemas.microsoft.com/office/drawing/2014/main" id="{1627E6A9-9950-4058-AB8C-43F3844D362F}"/>
               </a:ext>
             </a:extLst>
           </p:cNvPr>
@@ -31835,7 +31835,7 @@
           <p:cNvPr id="7" name="">
             <a:extLst xmlns:a="http://schemas.openxmlformats.org/drawingml/2006/main">
               <a:ext uri="{FF2B5EF4-FFF2-40B4-BE49-F238E27FC236}">
-                <a16:creationId xmlns:a16="http://schemas.microsoft.com/office/drawing/2014/main" id="{EBDB050D-F425-4A0A-ADFC-3B3E3AE613D3}"/>
+                <a16:creationId xmlns:a16="http://schemas.microsoft.com/office/drawing/2014/main" id="{72859282-2CA2-4A07-89CF-15E37C51628C}"/>
               </a:ext>
             </a:extLst>
           </p:cNvPr>
@@ -31956,7 +31956,7 @@
           <p:cNvPr id="8" name="">
             <a:extLst xmlns:a="http://schemas.openxmlformats.org/drawingml/2006/main">
               <a:ext uri="{FF2B5EF4-FFF2-40B4-BE49-F238E27FC236}">
-                <a16:creationId xmlns:a16="http://schemas.microsoft.com/office/drawing/2014/main" id="{7D906EEC-BF4D-412D-A3E0-4D2B5257083B}"/>
+                <a16:creationId xmlns:a16="http://schemas.microsoft.com/office/drawing/2014/main" id="{AA0A6940-0A65-4821-A124-59C59AA5A63F}"/>
               </a:ext>
             </a:extLst>
           </p:cNvPr>
@@ -32077,7 +32077,7 @@
           <p:cNvPr id="9" name="">
             <a:extLst xmlns:a="http://schemas.openxmlformats.org/drawingml/2006/main">
               <a:ext uri="{FF2B5EF4-FFF2-40B4-BE49-F238E27FC236}">
-                <a16:creationId xmlns:a16="http://schemas.microsoft.com/office/drawing/2014/main" id="{9010947D-C9B6-4E9D-92B4-D33C332B4AF8}"/>
+                <a16:creationId xmlns:a16="http://schemas.microsoft.com/office/drawing/2014/main" id="{B74D3B78-1CA7-458E-8FEE-E9C5E78B99FB}"/>
               </a:ext>
             </a:extLst>
           </p:cNvPr>
@@ -32198,7 +32198,7 @@
           <p:cNvPr id="10" name="">
             <a:extLst xmlns:a="http://schemas.openxmlformats.org/drawingml/2006/main">
               <a:ext uri="{FF2B5EF4-FFF2-40B4-BE49-F238E27FC236}">
-                <a16:creationId xmlns:a16="http://schemas.microsoft.com/office/drawing/2014/main" id="{DB506D37-F0BC-4B87-8415-64206CB1C3EA}"/>
+                <a16:creationId xmlns:a16="http://schemas.microsoft.com/office/drawing/2014/main" id="{69D33A8C-DF36-462A-B477-9DBF3E53E226}"/>
               </a:ext>
             </a:extLst>
           </p:cNvPr>
@@ -32319,7 +32319,7 @@
           <p:cNvPr id="11" name="">
             <a:extLst xmlns:a="http://schemas.openxmlformats.org/drawingml/2006/main">
               <a:ext uri="{FF2B5EF4-FFF2-40B4-BE49-F238E27FC236}">
-                <a16:creationId xmlns:a16="http://schemas.microsoft.com/office/drawing/2014/main" id="{B2436536-ABE5-4517-AC30-D54757FC29B8}"/>
+                <a16:creationId xmlns:a16="http://schemas.microsoft.com/office/drawing/2014/main" id="{AD04F24E-C13E-40A8-9D4C-C0FB35BD202E}"/>
               </a:ext>
             </a:extLst>
           </p:cNvPr>
@@ -32440,7 +32440,7 @@
           <p:cNvPr id="12" name="">
             <a:extLst xmlns:a="http://schemas.openxmlformats.org/drawingml/2006/main">
               <a:ext uri="{FF2B5EF4-FFF2-40B4-BE49-F238E27FC236}">
-                <a16:creationId xmlns:a16="http://schemas.microsoft.com/office/drawing/2014/main" id="{31A8114D-6202-453E-9C13-D2110832025C}"/>
+                <a16:creationId xmlns:a16="http://schemas.microsoft.com/office/drawing/2014/main" id="{C3F9735A-E9FC-45CC-8B90-BF97092C5E11}"/>
               </a:ext>
             </a:extLst>
           </p:cNvPr>
@@ -32561,7 +32561,7 @@
           <p:cNvPr id="13" name="">
             <a:extLst xmlns:a="http://schemas.openxmlformats.org/drawingml/2006/main">
               <a:ext uri="{FF2B5EF4-FFF2-40B4-BE49-F238E27FC236}">
-                <a16:creationId xmlns:a16="http://schemas.microsoft.com/office/drawing/2014/main" id="{7D217EA1-EA27-45A9-9C16-EE6FBB4A6604}"/>
+                <a16:creationId xmlns:a16="http://schemas.microsoft.com/office/drawing/2014/main" id="{9C399B20-FDB2-4C91-873E-0EFECD61102A}"/>
               </a:ext>
             </a:extLst>
           </p:cNvPr>
@@ -32682,7 +32682,7 @@
           <p:cNvPr id="14" name="">
             <a:extLst xmlns:a="http://schemas.openxmlformats.org/drawingml/2006/main">
               <a:ext uri="{FF2B5EF4-FFF2-40B4-BE49-F238E27FC236}">
-                <a16:creationId xmlns:a16="http://schemas.microsoft.com/office/drawing/2014/main" id="{4FB8BB7D-D6F3-4A19-851F-ACE4DF1BA678}"/>
+                <a16:creationId xmlns:a16="http://schemas.microsoft.com/office/drawing/2014/main" id="{63E70269-9B1E-4B38-BC1D-259C593266E6}"/>
               </a:ext>
             </a:extLst>
           </p:cNvPr>
@@ -32803,7 +32803,7 @@
           <p:cNvPr id="15" name="">
             <a:extLst xmlns:a="http://schemas.openxmlformats.org/drawingml/2006/main">
               <a:ext uri="{FF2B5EF4-FFF2-40B4-BE49-F238E27FC236}">
-                <a16:creationId xmlns:a16="http://schemas.microsoft.com/office/drawing/2014/main" id="{443EF16D-1FE4-4AEE-93DC-C6289708BD53}"/>
+                <a16:creationId xmlns:a16="http://schemas.microsoft.com/office/drawing/2014/main" id="{AEE147C9-A08B-4B58-A992-800101B37569}"/>
               </a:ext>
             </a:extLst>
           </p:cNvPr>
@@ -32924,7 +32924,7 @@
           <p:cNvPr id="16" name="">
             <a:extLst xmlns:a="http://schemas.openxmlformats.org/drawingml/2006/main">
               <a:ext uri="{FF2B5EF4-FFF2-40B4-BE49-F238E27FC236}">
-                <a16:creationId xmlns:a16="http://schemas.microsoft.com/office/drawing/2014/main" id="{0B2594BA-CA00-4F2A-8EB1-2F3396F0EE8F}"/>
+                <a16:creationId xmlns:a16="http://schemas.microsoft.com/office/drawing/2014/main" id="{DE3D791A-0B13-451E-96DA-80ECEF2E9E80}"/>
               </a:ext>
             </a:extLst>
           </p:cNvPr>
@@ -33045,7 +33045,7 @@
           <p:cNvPr id="17" name="">
             <a:extLst xmlns:a="http://schemas.openxmlformats.org/drawingml/2006/main">
               <a:ext uri="{FF2B5EF4-FFF2-40B4-BE49-F238E27FC236}">
-                <a16:creationId xmlns:a16="http://schemas.microsoft.com/office/drawing/2014/main" id="{36EADAC2-A40B-4675-A10C-FD93CCE98F1A}"/>
+                <a16:creationId xmlns:a16="http://schemas.microsoft.com/office/drawing/2014/main" id="{75CBCB59-528A-4D71-B4D9-8394AA6BB8DD}"/>
               </a:ext>
             </a:extLst>
           </p:cNvPr>
@@ -33164,7 +33164,7 @@
     </p:spTree>
     <p:extLst>
       <p:ext uri="{BB962C8B-B14F-4D97-AF65-F5344CB8AC3E}">
-        <p14:creationId xmlns:p14="http://schemas.microsoft.com/office/powerpoint/2010/main" val="1568624300"/>
+        <p14:creationId xmlns:p14="http://schemas.microsoft.com/office/powerpoint/2010/main" val="1766442210"/>
       </p:ext>
     </p:extLst>
   </p:cSld>
@@ -33195,7 +33195,7 @@
           <p:cNvPr id="30" name="">
             <a:extLst xmlns:a="http://schemas.openxmlformats.org/drawingml/2006/main">
               <a:ext uri="{FF2B5EF4-FFF2-40B4-BE49-F238E27FC236}">
-                <a16:creationId xmlns:a16="http://schemas.microsoft.com/office/drawing/2014/main" id="{09C341FE-A2AF-4446-82C4-2829DF824F91}"/>
+                <a16:creationId xmlns:a16="http://schemas.microsoft.com/office/drawing/2014/main" id="{01581D9B-3426-4D22-9B6A-FB3D0D20E382}"/>
               </a:ext>
             </a:extLst>
           </p:cNvPr>
@@ -33226,7 +33226,7 @@
           <p:cNvPr id="2" name="">
             <a:extLst xmlns:a="http://schemas.openxmlformats.org/drawingml/2006/main">
               <a:ext uri="{FF2B5EF4-FFF2-40B4-BE49-F238E27FC236}">
-                <a16:creationId xmlns:a16="http://schemas.microsoft.com/office/drawing/2014/main" id="{663431B1-3538-4F92-A123-7BEC929AF137}"/>
+                <a16:creationId xmlns:a16="http://schemas.microsoft.com/office/drawing/2014/main" id="{2318EFD3-273F-48AD-A78B-CF6309FA3BB6}"/>
               </a:ext>
             </a:extLst>
           </p:cNvPr>
@@ -33347,7 +33347,7 @@
           <p:cNvPr id="3" name="">
             <a:extLst xmlns:a="http://schemas.openxmlformats.org/drawingml/2006/main">
               <a:ext uri="{FF2B5EF4-FFF2-40B4-BE49-F238E27FC236}">
-                <a16:creationId xmlns:a16="http://schemas.microsoft.com/office/drawing/2014/main" id="{FFA549BC-AC3E-4814-B1A1-92CA7B6ECCBA}"/>
+                <a16:creationId xmlns:a16="http://schemas.microsoft.com/office/drawing/2014/main" id="{FAF567BD-489E-4AFD-8EC8-D76F76F22A55}"/>
               </a:ext>
             </a:extLst>
           </p:cNvPr>
@@ -33468,7 +33468,7 @@
           <p:cNvPr id="4" name="">
             <a:extLst xmlns:a="http://schemas.openxmlformats.org/drawingml/2006/main">
               <a:ext uri="{FF2B5EF4-FFF2-40B4-BE49-F238E27FC236}">
-                <a16:creationId xmlns:a16="http://schemas.microsoft.com/office/drawing/2014/main" id="{5E408ADD-196C-4FDF-BB0A-F589A168C3EC}"/>
+                <a16:creationId xmlns:a16="http://schemas.microsoft.com/office/drawing/2014/main" id="{CCA02402-CFEF-4A82-921A-AEF96543C841}"/>
               </a:ext>
             </a:extLst>
           </p:cNvPr>
@@ -33499,7 +33499,7 @@
           <p:cNvPr id="5" name="">
             <a:extLst xmlns:a="http://schemas.openxmlformats.org/drawingml/2006/main">
               <a:ext uri="{FF2B5EF4-FFF2-40B4-BE49-F238E27FC236}">
-                <a16:creationId xmlns:a16="http://schemas.microsoft.com/office/drawing/2014/main" id="{0BC835C9-B7CC-438F-98CC-1D70D22DAA00}"/>
+                <a16:creationId xmlns:a16="http://schemas.microsoft.com/office/drawing/2014/main" id="{A5B507A9-29E2-4508-BAAF-8CF4859FCA6A}"/>
               </a:ext>
             </a:extLst>
           </p:cNvPr>
@@ -33620,7 +33620,7 @@
           <p:cNvPr id="6" name="">
             <a:extLst xmlns:a="http://schemas.openxmlformats.org/drawingml/2006/main">
               <a:ext uri="{FF2B5EF4-FFF2-40B4-BE49-F238E27FC236}">
-                <a16:creationId xmlns:a16="http://schemas.microsoft.com/office/drawing/2014/main" id="{71B84E5E-3FA5-42A9-8D8F-70128958DF88}"/>
+                <a16:creationId xmlns:a16="http://schemas.microsoft.com/office/drawing/2014/main" id="{325FF537-9AC3-4296-B01C-8A93A103EB73}"/>
               </a:ext>
             </a:extLst>
           </p:cNvPr>
@@ -33741,7 +33741,7 @@
           <p:cNvPr id="7" name="">
             <a:extLst xmlns:a="http://schemas.openxmlformats.org/drawingml/2006/main">
               <a:ext uri="{FF2B5EF4-FFF2-40B4-BE49-F238E27FC236}">
-                <a16:creationId xmlns:a16="http://schemas.microsoft.com/office/drawing/2014/main" id="{9D0E330F-382A-4B72-A43A-C1128E942833}"/>
+                <a16:creationId xmlns:a16="http://schemas.microsoft.com/office/drawing/2014/main" id="{0C35885D-C448-498A-B469-0CCDEBE65A8A}"/>
               </a:ext>
             </a:extLst>
           </p:cNvPr>
@@ -33862,7 +33862,7 @@
           <p:cNvPr id="8" name="">
             <a:extLst xmlns:a="http://schemas.openxmlformats.org/drawingml/2006/main">
               <a:ext uri="{FF2B5EF4-FFF2-40B4-BE49-F238E27FC236}">
-                <a16:creationId xmlns:a16="http://schemas.microsoft.com/office/drawing/2014/main" id="{9E5D19C3-37BE-41AA-8077-98D71CAECEB5}"/>
+                <a16:creationId xmlns:a16="http://schemas.microsoft.com/office/drawing/2014/main" id="{DBFC7017-5A1E-4BAC-ABF4-67DCE1F31AC5}"/>
               </a:ext>
             </a:extLst>
           </p:cNvPr>
@@ -33983,7 +33983,7 @@
           <p:cNvPr id="9" name="">
             <a:extLst xmlns:a="http://schemas.openxmlformats.org/drawingml/2006/main">
               <a:ext uri="{FF2B5EF4-FFF2-40B4-BE49-F238E27FC236}">
-                <a16:creationId xmlns:a16="http://schemas.microsoft.com/office/drawing/2014/main" id="{4376C21A-89C2-41F5-8688-69E3340F1FF3}"/>
+                <a16:creationId xmlns:a16="http://schemas.microsoft.com/office/drawing/2014/main" id="{33F1213B-1EE7-408B-A50A-7F7E82DDA2E1}"/>
               </a:ext>
             </a:extLst>
           </p:cNvPr>
@@ -34014,7 +34014,7 @@
           <p:cNvPr id="10" name="">
             <a:extLst xmlns:a="http://schemas.openxmlformats.org/drawingml/2006/main">
               <a:ext uri="{FF2B5EF4-FFF2-40B4-BE49-F238E27FC236}">
-                <a16:creationId xmlns:a16="http://schemas.microsoft.com/office/drawing/2014/main" id="{2FCAFBB9-4C2C-4E7C-946E-1F9E85A36034}"/>
+                <a16:creationId xmlns:a16="http://schemas.microsoft.com/office/drawing/2014/main" id="{49988C36-8E45-4527-B633-3BF9E09A2FA8}"/>
               </a:ext>
             </a:extLst>
           </p:cNvPr>
@@ -34135,7 +34135,7 @@
           <p:cNvPr id="11" name="">
             <a:extLst xmlns:a="http://schemas.openxmlformats.org/drawingml/2006/main">
               <a:ext uri="{FF2B5EF4-FFF2-40B4-BE49-F238E27FC236}">
-                <a16:creationId xmlns:a16="http://schemas.microsoft.com/office/drawing/2014/main" id="{70EEB581-F6B2-4AA3-A52B-85F36BB5F011}"/>
+                <a16:creationId xmlns:a16="http://schemas.microsoft.com/office/drawing/2014/main" id="{E9C74964-0B67-4808-A058-46B7200F2CBA}"/>
               </a:ext>
             </a:extLst>
           </p:cNvPr>
@@ -34256,7 +34256,7 @@
           <p:cNvPr id="12" name="">
             <a:extLst xmlns:a="http://schemas.openxmlformats.org/drawingml/2006/main">
               <a:ext uri="{FF2B5EF4-FFF2-40B4-BE49-F238E27FC236}">
-                <a16:creationId xmlns:a16="http://schemas.microsoft.com/office/drawing/2014/main" id="{9FB630FA-E3C7-49E7-B286-23D827EEE1FD}"/>
+                <a16:creationId xmlns:a16="http://schemas.microsoft.com/office/drawing/2014/main" id="{219D36FB-95AB-4E45-B175-DA6F472CB3D4}"/>
               </a:ext>
             </a:extLst>
           </p:cNvPr>
@@ -34377,7 +34377,7 @@
           <p:cNvPr id="13" name="">
             <a:extLst xmlns:a="http://schemas.openxmlformats.org/drawingml/2006/main">
               <a:ext uri="{FF2B5EF4-FFF2-40B4-BE49-F238E27FC236}">
-                <a16:creationId xmlns:a16="http://schemas.microsoft.com/office/drawing/2014/main" id="{5E693D61-86D8-43D5-ADE2-6B4BAF0E3260}"/>
+                <a16:creationId xmlns:a16="http://schemas.microsoft.com/office/drawing/2014/main" id="{3B4B416F-105D-43FD-A5A1-ED9BCAC6E5A7}"/>
               </a:ext>
             </a:extLst>
           </p:cNvPr>
@@ -34408,7 +34408,7 @@
           <p:cNvPr id="14" name="">
             <a:extLst xmlns:a="http://schemas.openxmlformats.org/drawingml/2006/main">
               <a:ext uri="{FF2B5EF4-FFF2-40B4-BE49-F238E27FC236}">
-                <a16:creationId xmlns:a16="http://schemas.microsoft.com/office/drawing/2014/main" id="{BC01352F-373E-4B1F-97D3-F0358D85380A}"/>
+                <a16:creationId xmlns:a16="http://schemas.microsoft.com/office/drawing/2014/main" id="{63B08BC2-18CF-4176-9E4B-146C1F054540}"/>
               </a:ext>
             </a:extLst>
           </p:cNvPr>
@@ -34529,7 +34529,7 @@
           <p:cNvPr id="15" name="">
             <a:extLst xmlns:a="http://schemas.openxmlformats.org/drawingml/2006/main">
               <a:ext uri="{FF2B5EF4-FFF2-40B4-BE49-F238E27FC236}">
-                <a16:creationId xmlns:a16="http://schemas.microsoft.com/office/drawing/2014/main" id="{A9D085B2-6FE7-4E32-8867-7563BFD0A91E}"/>
+                <a16:creationId xmlns:a16="http://schemas.microsoft.com/office/drawing/2014/main" id="{CA501366-0DD2-42F7-A782-6E51F5DC0EC1}"/>
               </a:ext>
             </a:extLst>
           </p:cNvPr>
@@ -34650,7 +34650,7 @@
           <p:cNvPr id="16" name="">
             <a:extLst xmlns:a="http://schemas.openxmlformats.org/drawingml/2006/main">
               <a:ext uri="{FF2B5EF4-FFF2-40B4-BE49-F238E27FC236}">
-                <a16:creationId xmlns:a16="http://schemas.microsoft.com/office/drawing/2014/main" id="{306CA518-F030-4FDF-9F63-1642CA6C4A8F}"/>
+                <a16:creationId xmlns:a16="http://schemas.microsoft.com/office/drawing/2014/main" id="{19776127-F025-43B4-B243-9E317C31F2EC}"/>
               </a:ext>
             </a:extLst>
           </p:cNvPr>
@@ -34771,7 +34771,7 @@
           <p:cNvPr id="17" name="">
             <a:extLst xmlns:a="http://schemas.openxmlformats.org/drawingml/2006/main">
               <a:ext uri="{FF2B5EF4-FFF2-40B4-BE49-F238E27FC236}">
-                <a16:creationId xmlns:a16="http://schemas.microsoft.com/office/drawing/2014/main" id="{E62978EC-8864-458D-B2E8-E20AF1EDB574}"/>
+                <a16:creationId xmlns:a16="http://schemas.microsoft.com/office/drawing/2014/main" id="{2B936714-D0CF-4802-8F5F-FFF7B32F4AEC}"/>
               </a:ext>
             </a:extLst>
           </p:cNvPr>
@@ -34802,7 +34802,7 @@
           <p:cNvPr id="18" name="">
             <a:extLst xmlns:a="http://schemas.openxmlformats.org/drawingml/2006/main">
               <a:ext uri="{FF2B5EF4-FFF2-40B4-BE49-F238E27FC236}">
-                <a16:creationId xmlns:a16="http://schemas.microsoft.com/office/drawing/2014/main" id="{676EF58C-19F6-4F46-B9DB-B3231278C102}"/>
+                <a16:creationId xmlns:a16="http://schemas.microsoft.com/office/drawing/2014/main" id="{84E7E7E9-0D12-4620-B7BD-64C328E00702}"/>
               </a:ext>
             </a:extLst>
           </p:cNvPr>
@@ -34923,7 +34923,7 @@
           <p:cNvPr id="19" name="">
             <a:extLst xmlns:a="http://schemas.openxmlformats.org/drawingml/2006/main">
               <a:ext uri="{FF2B5EF4-FFF2-40B4-BE49-F238E27FC236}">
-                <a16:creationId xmlns:a16="http://schemas.microsoft.com/office/drawing/2014/main" id="{6DEA43BB-0D56-4AC5-96E2-06DE37F1393F}"/>
+                <a16:creationId xmlns:a16="http://schemas.microsoft.com/office/drawing/2014/main" id="{A614DB11-08D6-4CEA-83FF-DEAB3CBAB5C9}"/>
               </a:ext>
             </a:extLst>
           </p:cNvPr>
@@ -35044,7 +35044,7 @@
           <p:cNvPr id="20" name="">
             <a:extLst xmlns:a="http://schemas.openxmlformats.org/drawingml/2006/main">
               <a:ext uri="{FF2B5EF4-FFF2-40B4-BE49-F238E27FC236}">
-                <a16:creationId xmlns:a16="http://schemas.microsoft.com/office/drawing/2014/main" id="{7FF0646C-9CD7-4C4D-BC7F-69FF610C4D14}"/>
+                <a16:creationId xmlns:a16="http://schemas.microsoft.com/office/drawing/2014/main" id="{8CF873FB-7616-4146-8B44-5F5680AB8270}"/>
               </a:ext>
             </a:extLst>
           </p:cNvPr>
@@ -35165,7 +35165,7 @@
           <p:cNvPr id="21" name="">
             <a:extLst xmlns:a="http://schemas.openxmlformats.org/drawingml/2006/main">
               <a:ext uri="{FF2B5EF4-FFF2-40B4-BE49-F238E27FC236}">
-                <a16:creationId xmlns:a16="http://schemas.microsoft.com/office/drawing/2014/main" id="{C7ED25E1-9CE0-44A5-877F-3C2280E0C46A}"/>
+                <a16:creationId xmlns:a16="http://schemas.microsoft.com/office/drawing/2014/main" id="{BBEA0BB1-CBD1-4F94-8CE5-4C167975FC02}"/>
               </a:ext>
             </a:extLst>
           </p:cNvPr>
@@ -35196,7 +35196,7 @@
           <p:cNvPr id="22" name="">
             <a:extLst xmlns:a="http://schemas.openxmlformats.org/drawingml/2006/main">
               <a:ext uri="{FF2B5EF4-FFF2-40B4-BE49-F238E27FC236}">
-                <a16:creationId xmlns:a16="http://schemas.microsoft.com/office/drawing/2014/main" id="{FFA9A565-0830-4067-A926-E10DB90D950C}"/>
+                <a16:creationId xmlns:a16="http://schemas.microsoft.com/office/drawing/2014/main" id="{86516538-9C98-4D56-A666-65151ED3B866}"/>
               </a:ext>
             </a:extLst>
           </p:cNvPr>
@@ -35317,7 +35317,7 @@
           <p:cNvPr id="23" name="">
             <a:extLst xmlns:a="http://schemas.openxmlformats.org/drawingml/2006/main">
               <a:ext uri="{FF2B5EF4-FFF2-40B4-BE49-F238E27FC236}">
-                <a16:creationId xmlns:a16="http://schemas.microsoft.com/office/drawing/2014/main" id="{C82DB48A-0DA2-4B5F-8F7B-EDC873154205}"/>
+                <a16:creationId xmlns:a16="http://schemas.microsoft.com/office/drawing/2014/main" id="{ADFD4FAF-682E-41B0-BBD7-C21F2F043647}"/>
               </a:ext>
             </a:extLst>
           </p:cNvPr>
@@ -35438,7 +35438,7 @@
           <p:cNvPr id="24" name="">
             <a:extLst xmlns:a="http://schemas.openxmlformats.org/drawingml/2006/main">
               <a:ext uri="{FF2B5EF4-FFF2-40B4-BE49-F238E27FC236}">
-                <a16:creationId xmlns:a16="http://schemas.microsoft.com/office/drawing/2014/main" id="{A9F3F1E2-3F4F-4124-ACD6-2A1C95DA9A11}"/>
+                <a16:creationId xmlns:a16="http://schemas.microsoft.com/office/drawing/2014/main" id="{2C36A58B-D960-4766-BF6B-D646A2BCDBA8}"/>
               </a:ext>
             </a:extLst>
           </p:cNvPr>
@@ -35559,7 +35559,7 @@
           <p:cNvPr id="25" name="">
             <a:extLst xmlns:a="http://schemas.openxmlformats.org/drawingml/2006/main">
               <a:ext uri="{FF2B5EF4-FFF2-40B4-BE49-F238E27FC236}">
-                <a16:creationId xmlns:a16="http://schemas.microsoft.com/office/drawing/2014/main" id="{F2E9C5F6-CC4E-4B16-9111-08DA2220A877}"/>
+                <a16:creationId xmlns:a16="http://schemas.microsoft.com/office/drawing/2014/main" id="{C1DB74E7-7B28-4C71-BB1E-1037891C845E}"/>
               </a:ext>
             </a:extLst>
           </p:cNvPr>
@@ -35590,7 +35590,7 @@
           <p:cNvPr id="26" name="">
             <a:extLst xmlns:a="http://schemas.openxmlformats.org/drawingml/2006/main">
               <a:ext uri="{FF2B5EF4-FFF2-40B4-BE49-F238E27FC236}">
-                <a16:creationId xmlns:a16="http://schemas.microsoft.com/office/drawing/2014/main" id="{9F5D5792-02C8-45AE-AF13-1A4DDA7F3451}"/>
+                <a16:creationId xmlns:a16="http://schemas.microsoft.com/office/drawing/2014/main" id="{723F1953-0BD5-4755-A000-568BEC278BD5}"/>
               </a:ext>
             </a:extLst>
           </p:cNvPr>
@@ -35711,7 +35711,7 @@
           <p:cNvPr id="27" name="">
             <a:extLst xmlns:a="http://schemas.openxmlformats.org/drawingml/2006/main">
               <a:ext uri="{FF2B5EF4-FFF2-40B4-BE49-F238E27FC236}">
-                <a16:creationId xmlns:a16="http://schemas.microsoft.com/office/drawing/2014/main" id="{70FC886C-19C6-4224-9936-CE731815718F}"/>
+                <a16:creationId xmlns:a16="http://schemas.microsoft.com/office/drawing/2014/main" id="{E7DA19CC-021D-4B61-AAB9-641322F48700}"/>
               </a:ext>
             </a:extLst>
           </p:cNvPr>
@@ -35832,7 +35832,7 @@
           <p:cNvPr id="28" name="">
             <a:extLst xmlns:a="http://schemas.openxmlformats.org/drawingml/2006/main">
               <a:ext uri="{FF2B5EF4-FFF2-40B4-BE49-F238E27FC236}">
-                <a16:creationId xmlns:a16="http://schemas.microsoft.com/office/drawing/2014/main" id="{F7F6F09F-CB4D-44C3-9E78-54633CE5841B}"/>
+                <a16:creationId xmlns:a16="http://schemas.microsoft.com/office/drawing/2014/main" id="{7833F7C3-424C-4162-9460-AB92F2606CC6}"/>
               </a:ext>
             </a:extLst>
           </p:cNvPr>
@@ -35953,7 +35953,7 @@
           <p:cNvPr id="29" name="">
             <a:extLst xmlns:a="http://schemas.openxmlformats.org/drawingml/2006/main">
               <a:ext uri="{FF2B5EF4-FFF2-40B4-BE49-F238E27FC236}">
-                <a16:creationId xmlns:a16="http://schemas.microsoft.com/office/drawing/2014/main" id="{8D8E0CCD-6DA3-42FF-B381-16F4C6D37F0C}"/>
+                <a16:creationId xmlns:a16="http://schemas.microsoft.com/office/drawing/2014/main" id="{0330C3F0-6BA6-424F-B3DE-EA2FACDA5998}"/>
               </a:ext>
             </a:extLst>
           </p:cNvPr>
@@ -35982,7 +35982,7 @@
     </p:spTree>
     <p:extLst>
       <p:ext uri="{BB962C8B-B14F-4D97-AF65-F5344CB8AC3E}">
-        <p14:creationId xmlns:p14="http://schemas.microsoft.com/office/powerpoint/2010/main" val="51547266"/>
+        <p14:creationId xmlns:p14="http://schemas.microsoft.com/office/powerpoint/2010/main" val="129237657"/>
       </p:ext>
     </p:extLst>
   </p:cSld>
@@ -36013,7 +36013,7 @@
           <p:cNvPr id="15" name="">
             <a:extLst xmlns:a="http://schemas.openxmlformats.org/drawingml/2006/main">
               <a:ext uri="{FF2B5EF4-FFF2-40B4-BE49-F238E27FC236}">
-                <a16:creationId xmlns:a16="http://schemas.microsoft.com/office/drawing/2014/main" id="{3F32CC89-6836-448A-BFB0-A5547784DC93}"/>
+                <a16:creationId xmlns:a16="http://schemas.microsoft.com/office/drawing/2014/main" id="{2575AACD-B8C6-4C33-A67F-A51460077C2B}"/>
               </a:ext>
             </a:extLst>
           </p:cNvPr>
@@ -36044,7 +36044,7 @@
           <p:cNvPr id="2" name="">
             <a:extLst xmlns:a="http://schemas.openxmlformats.org/drawingml/2006/main">
               <a:ext uri="{FF2B5EF4-FFF2-40B4-BE49-F238E27FC236}">
-                <a16:creationId xmlns:a16="http://schemas.microsoft.com/office/drawing/2014/main" id="{E083F5FD-A03F-42B9-AE46-7131295589F2}"/>
+                <a16:creationId xmlns:a16="http://schemas.microsoft.com/office/drawing/2014/main" id="{140272E6-4F27-4FBD-A4FC-350BC1D7BB2E}"/>
               </a:ext>
             </a:extLst>
           </p:cNvPr>
@@ -36165,7 +36165,7 @@
           <p:cNvPr id="3" name="">
             <a:extLst xmlns:a="http://schemas.openxmlformats.org/drawingml/2006/main">
               <a:ext uri="{FF2B5EF4-FFF2-40B4-BE49-F238E27FC236}">
-                <a16:creationId xmlns:a16="http://schemas.microsoft.com/office/drawing/2014/main" id="{3316A9FC-AC23-4D7A-B191-025CD9FB5C1C}"/>
+                <a16:creationId xmlns:a16="http://schemas.microsoft.com/office/drawing/2014/main" id="{BE9C4F76-9BB5-4CBA-B72D-AB544D71DF77}"/>
               </a:ext>
             </a:extLst>
           </p:cNvPr>
@@ -36286,7 +36286,7 @@
           <p:cNvPr id="4" name="">
             <a:extLst xmlns:a="http://schemas.openxmlformats.org/drawingml/2006/main">
               <a:ext uri="{FF2B5EF4-FFF2-40B4-BE49-F238E27FC236}">
-                <a16:creationId xmlns:a16="http://schemas.microsoft.com/office/drawing/2014/main" id="{7D975B99-A305-47A0-9D5B-885BD09A6C50}"/>
+                <a16:creationId xmlns:a16="http://schemas.microsoft.com/office/drawing/2014/main" id="{33BD2F14-FF75-4ED5-8091-7FEA056265EC}"/>
               </a:ext>
             </a:extLst>
           </p:cNvPr>
@@ -36317,7 +36317,7 @@
           <p:cNvPr id="5" name="">
             <a:extLst xmlns:a="http://schemas.openxmlformats.org/drawingml/2006/main">
               <a:ext uri="{FF2B5EF4-FFF2-40B4-BE49-F238E27FC236}">
-                <a16:creationId xmlns:a16="http://schemas.microsoft.com/office/drawing/2014/main" id="{5FBBC422-E46C-453B-A2A4-839501A61998}"/>
+                <a16:creationId xmlns:a16="http://schemas.microsoft.com/office/drawing/2014/main" id="{95A9C4C6-D1EB-4F5A-A238-AD57A55E3766}"/>
               </a:ext>
             </a:extLst>
           </p:cNvPr>
@@ -36438,7 +36438,7 @@
           <p:cNvPr id="6" name="">
             <a:extLst xmlns:a="http://schemas.openxmlformats.org/drawingml/2006/main">
               <a:ext uri="{FF2B5EF4-FFF2-40B4-BE49-F238E27FC236}">
-                <a16:creationId xmlns:a16="http://schemas.microsoft.com/office/drawing/2014/main" id="{C63C6301-07BE-48C7-A5CF-4508BA1E7984}"/>
+                <a16:creationId xmlns:a16="http://schemas.microsoft.com/office/drawing/2014/main" id="{CACAA8E0-5082-436D-A317-DF187C589B2D}"/>
               </a:ext>
             </a:extLst>
           </p:cNvPr>
@@ -36576,7 +36576,7 @@
           <p:cNvPr id="7" name="">
             <a:extLst xmlns:a="http://schemas.openxmlformats.org/drawingml/2006/main">
               <a:ext uri="{FF2B5EF4-FFF2-40B4-BE49-F238E27FC236}">
-                <a16:creationId xmlns:a16="http://schemas.microsoft.com/office/drawing/2014/main" id="{C7859B1E-0DA8-44B9-BA07-F3AACD1A1E50}"/>
+                <a16:creationId xmlns:a16="http://schemas.microsoft.com/office/drawing/2014/main" id="{4E52F2CB-B343-41EF-AE17-8F5A91F383D1}"/>
               </a:ext>
             </a:extLst>
           </p:cNvPr>
@@ -36697,7 +36697,7 @@
           <p:cNvPr id="8" name="">
             <a:extLst xmlns:a="http://schemas.openxmlformats.org/drawingml/2006/main">
               <a:ext uri="{FF2B5EF4-FFF2-40B4-BE49-F238E27FC236}">
-                <a16:creationId xmlns:a16="http://schemas.microsoft.com/office/drawing/2014/main" id="{F2A21E26-9B58-4DE1-9B7E-3085E72F5A0D}"/>
+                <a16:creationId xmlns:a16="http://schemas.microsoft.com/office/drawing/2014/main" id="{93B74352-105D-45EF-9708-355CB0BA74E1}"/>
               </a:ext>
             </a:extLst>
           </p:cNvPr>
@@ -36818,7 +36818,7 @@
           <p:cNvPr id="9" name="">
             <a:extLst xmlns:a="http://schemas.openxmlformats.org/drawingml/2006/main">
               <a:ext uri="{FF2B5EF4-FFF2-40B4-BE49-F238E27FC236}">
-                <a16:creationId xmlns:a16="http://schemas.microsoft.com/office/drawing/2014/main" id="{3EB2FA30-166D-4726-B12A-08DAE40913D8}"/>
+                <a16:creationId xmlns:a16="http://schemas.microsoft.com/office/drawing/2014/main" id="{41B11700-F5C8-4B3C-803C-CAA002C16A81}"/>
               </a:ext>
             </a:extLst>
           </p:cNvPr>
@@ -36939,7 +36939,7 @@
           <p:cNvPr id="10" name="">
             <a:extLst xmlns:a="http://schemas.openxmlformats.org/drawingml/2006/main">
               <a:ext uri="{FF2B5EF4-FFF2-40B4-BE49-F238E27FC236}">
-                <a16:creationId xmlns:a16="http://schemas.microsoft.com/office/drawing/2014/main" id="{FD66D76F-B47B-43B8-82F6-1A57CD03DE4D}"/>
+                <a16:creationId xmlns:a16="http://schemas.microsoft.com/office/drawing/2014/main" id="{C6B0C8C4-2A35-4F4F-AE6F-E1C27E4FB8A9}"/>
               </a:ext>
             </a:extLst>
           </p:cNvPr>
@@ -37060,7 +37060,7 @@
           <p:cNvPr id="11" name="">
             <a:extLst xmlns:a="http://schemas.openxmlformats.org/drawingml/2006/main">
               <a:ext uri="{FF2B5EF4-FFF2-40B4-BE49-F238E27FC236}">
-                <a16:creationId xmlns:a16="http://schemas.microsoft.com/office/drawing/2014/main" id="{AF1FE0FD-7D32-4A10-AC39-C4CCB9BEB019}"/>
+                <a16:creationId xmlns:a16="http://schemas.microsoft.com/office/drawing/2014/main" id="{37A42925-FC84-40BD-B98B-9A503F70DBD8}"/>
               </a:ext>
             </a:extLst>
           </p:cNvPr>
@@ -37181,7 +37181,7 @@
           <p:cNvPr id="12" name="">
             <a:extLst xmlns:a="http://schemas.openxmlformats.org/drawingml/2006/main">
               <a:ext uri="{FF2B5EF4-FFF2-40B4-BE49-F238E27FC236}">
-                <a16:creationId xmlns:a16="http://schemas.microsoft.com/office/drawing/2014/main" id="{87AF4FFF-6D4B-4B64-98E5-F25A07ABBF4C}"/>
+                <a16:creationId xmlns:a16="http://schemas.microsoft.com/office/drawing/2014/main" id="{0B4E4EEB-1D1D-4893-AE90-C023A4A3DEB1}"/>
               </a:ext>
             </a:extLst>
           </p:cNvPr>
@@ -37302,7 +37302,7 @@
           <p:cNvPr id="13" name="">
             <a:extLst xmlns:a="http://schemas.openxmlformats.org/drawingml/2006/main">
               <a:ext uri="{FF2B5EF4-FFF2-40B4-BE49-F238E27FC236}">
-                <a16:creationId xmlns:a16="http://schemas.microsoft.com/office/drawing/2014/main" id="{5845F69B-90B6-4637-A773-D80AB1ECFB0C}"/>
+                <a16:creationId xmlns:a16="http://schemas.microsoft.com/office/drawing/2014/main" id="{5D11FF69-88EE-426D-A494-ED8DCAB4CC92}"/>
               </a:ext>
             </a:extLst>
           </p:cNvPr>
@@ -37333,7 +37333,7 @@
           <p:cNvPr id="14" name="">
             <a:extLst xmlns:a="http://schemas.openxmlformats.org/drawingml/2006/main">
               <a:ext uri="{FF2B5EF4-FFF2-40B4-BE49-F238E27FC236}">
-                <a16:creationId xmlns:a16="http://schemas.microsoft.com/office/drawing/2014/main" id="{22BB98E0-6606-4D00-9D3A-C80B04661DBD}"/>
+                <a16:creationId xmlns:a16="http://schemas.microsoft.com/office/drawing/2014/main" id="{6B9C5F40-D2F8-4B3F-8437-8EA8B4F41C15}"/>
               </a:ext>
             </a:extLst>
           </p:cNvPr>
@@ -37452,7 +37452,7 @@
     </p:spTree>
     <p:extLst>
       <p:ext uri="{BB962C8B-B14F-4D97-AF65-F5344CB8AC3E}">
-        <p14:creationId xmlns:p14="http://schemas.microsoft.com/office/powerpoint/2010/main" val="1536762284"/>
+        <p14:creationId xmlns:p14="http://schemas.microsoft.com/office/powerpoint/2010/main" val="142294545"/>
       </p:ext>
     </p:extLst>
   </p:cSld>
@@ -37483,7 +37483,7 @@
           <p:cNvPr id="15" name="">
             <a:extLst xmlns:a="http://schemas.openxmlformats.org/drawingml/2006/main">
               <a:ext uri="{FF2B5EF4-FFF2-40B4-BE49-F238E27FC236}">
-                <a16:creationId xmlns:a16="http://schemas.microsoft.com/office/drawing/2014/main" id="{B172BC5E-CC81-458A-AD2E-BE0DA48F8CF4}"/>
+                <a16:creationId xmlns:a16="http://schemas.microsoft.com/office/drawing/2014/main" id="{B0F01271-C50B-48B6-83BB-552051F15546}"/>
               </a:ext>
             </a:extLst>
           </p:cNvPr>
@@ -37514,7 +37514,7 @@
           <p:cNvPr id="2" name="">
             <a:extLst xmlns:a="http://schemas.openxmlformats.org/drawingml/2006/main">
               <a:ext uri="{FF2B5EF4-FFF2-40B4-BE49-F238E27FC236}">
-                <a16:creationId xmlns:a16="http://schemas.microsoft.com/office/drawing/2014/main" id="{CD4A0B5B-4C80-4324-A9CA-D647C6DFA36A}"/>
+                <a16:creationId xmlns:a16="http://schemas.microsoft.com/office/drawing/2014/main" id="{87FBD8A8-5723-490B-8F4D-B2275B115CBD}"/>
               </a:ext>
             </a:extLst>
           </p:cNvPr>
@@ -37635,7 +37635,7 @@
           <p:cNvPr id="3" name="">
             <a:extLst xmlns:a="http://schemas.openxmlformats.org/drawingml/2006/main">
               <a:ext uri="{FF2B5EF4-FFF2-40B4-BE49-F238E27FC236}">
-                <a16:creationId xmlns:a16="http://schemas.microsoft.com/office/drawing/2014/main" id="{707665BC-1BC8-4431-A775-385ADCCB816F}"/>
+                <a16:creationId xmlns:a16="http://schemas.microsoft.com/office/drawing/2014/main" id="{BC4C7202-E92E-401E-9821-6FF1585BACA0}"/>
               </a:ext>
             </a:extLst>
           </p:cNvPr>
@@ -37756,7 +37756,7 @@
           <p:cNvPr id="4" name="">
             <a:extLst xmlns:a="http://schemas.openxmlformats.org/drawingml/2006/main">
               <a:ext uri="{FF2B5EF4-FFF2-40B4-BE49-F238E27FC236}">
-                <a16:creationId xmlns:a16="http://schemas.microsoft.com/office/drawing/2014/main" id="{A2FE78CE-5499-43DA-ABDE-217F81EDF618}"/>
+                <a16:creationId xmlns:a16="http://schemas.microsoft.com/office/drawing/2014/main" id="{5EE7D98B-867F-4555-98A5-49BEFFD04B92}"/>
               </a:ext>
             </a:extLst>
           </p:cNvPr>
@@ -37787,7 +37787,7 @@
           <p:cNvPr id="5" name="">
             <a:extLst xmlns:a="http://schemas.openxmlformats.org/drawingml/2006/main">
               <a:ext uri="{FF2B5EF4-FFF2-40B4-BE49-F238E27FC236}">
-                <a16:creationId xmlns:a16="http://schemas.microsoft.com/office/drawing/2014/main" id="{F3B10ECE-C8EF-48F1-937F-4DC1C8DDCDF5}"/>
+                <a16:creationId xmlns:a16="http://schemas.microsoft.com/office/drawing/2014/main" id="{1EF86F9B-B3DA-4283-8EFB-3050F6511467}"/>
               </a:ext>
             </a:extLst>
           </p:cNvPr>
@@ -37908,7 +37908,7 @@
           <p:cNvPr id="6" name="">
             <a:extLst xmlns:a="http://schemas.openxmlformats.org/drawingml/2006/main">
               <a:ext uri="{FF2B5EF4-FFF2-40B4-BE49-F238E27FC236}">
-                <a16:creationId xmlns:a16="http://schemas.microsoft.com/office/drawing/2014/main" id="{F5F47B48-463D-481A-950A-65CA49CDA320}"/>
+                <a16:creationId xmlns:a16="http://schemas.microsoft.com/office/drawing/2014/main" id="{ECB2ED23-C2E9-4490-9DAE-D7F7005F08AD}"/>
               </a:ext>
             </a:extLst>
           </p:cNvPr>
@@ -38029,7 +38029,7 @@
           <p:cNvPr id="7" name="">
             <a:extLst xmlns:a="http://schemas.openxmlformats.org/drawingml/2006/main">
               <a:ext uri="{FF2B5EF4-FFF2-40B4-BE49-F238E27FC236}">
-                <a16:creationId xmlns:a16="http://schemas.microsoft.com/office/drawing/2014/main" id="{8B0C4C42-F49B-468F-9D3C-746789337380}"/>
+                <a16:creationId xmlns:a16="http://schemas.microsoft.com/office/drawing/2014/main" id="{4437BB97-C11A-4E4B-8B77-1E78ED424078}"/>
               </a:ext>
             </a:extLst>
           </p:cNvPr>
@@ -38150,7 +38150,7 @@
           <p:cNvPr id="8" name="">
             <a:extLst xmlns:a="http://schemas.openxmlformats.org/drawingml/2006/main">
               <a:ext uri="{FF2B5EF4-FFF2-40B4-BE49-F238E27FC236}">
-                <a16:creationId xmlns:a16="http://schemas.microsoft.com/office/drawing/2014/main" id="{6C3E5BDA-CC0F-4386-8024-0A734D15E3DE}"/>
+                <a16:creationId xmlns:a16="http://schemas.microsoft.com/office/drawing/2014/main" id="{45E208B1-B8A0-4F2E-BD4F-069AB8B95D50}"/>
               </a:ext>
             </a:extLst>
           </p:cNvPr>
@@ -38271,7 +38271,7 @@
           <p:cNvPr id="9" name="">
             <a:extLst xmlns:a="http://schemas.openxmlformats.org/drawingml/2006/main">
               <a:ext uri="{FF2B5EF4-FFF2-40B4-BE49-F238E27FC236}">
-                <a16:creationId xmlns:a16="http://schemas.microsoft.com/office/drawing/2014/main" id="{DEC79068-292C-4967-91CC-53144B9D4A3B}"/>
+                <a16:creationId xmlns:a16="http://schemas.microsoft.com/office/drawing/2014/main" id="{FFE5F18B-7451-46BE-B47B-7CBE7254485F}"/>
               </a:ext>
             </a:extLst>
           </p:cNvPr>
@@ -38392,7 +38392,7 @@
           <p:cNvPr id="10" name="">
             <a:extLst xmlns:a="http://schemas.openxmlformats.org/drawingml/2006/main">
               <a:ext uri="{FF2B5EF4-FFF2-40B4-BE49-F238E27FC236}">
-                <a16:creationId xmlns:a16="http://schemas.microsoft.com/office/drawing/2014/main" id="{0807F29B-7F62-4CCD-95BD-DDC2C377B414}"/>
+                <a16:creationId xmlns:a16="http://schemas.microsoft.com/office/drawing/2014/main" id="{0E908C08-577E-4B43-96D9-5956B80B4FE2}"/>
               </a:ext>
             </a:extLst>
           </p:cNvPr>
@@ -38513,7 +38513,7 @@
           <p:cNvPr id="11" name="">
             <a:extLst xmlns:a="http://schemas.openxmlformats.org/drawingml/2006/main">
               <a:ext uri="{FF2B5EF4-FFF2-40B4-BE49-F238E27FC236}">
-                <a16:creationId xmlns:a16="http://schemas.microsoft.com/office/drawing/2014/main" id="{CE7DD5E5-95CE-4B44-9B56-940A3527C382}"/>
+                <a16:creationId xmlns:a16="http://schemas.microsoft.com/office/drawing/2014/main" id="{1F727E96-0DB1-47D7-80C0-D81135446CD2}"/>
               </a:ext>
             </a:extLst>
           </p:cNvPr>
@@ -38634,7 +38634,7 @@
           <p:cNvPr id="12" name="">
             <a:extLst xmlns:a="http://schemas.openxmlformats.org/drawingml/2006/main">
               <a:ext uri="{FF2B5EF4-FFF2-40B4-BE49-F238E27FC236}">
-                <a16:creationId xmlns:a16="http://schemas.microsoft.com/office/drawing/2014/main" id="{49E27DD6-11AD-45FF-B324-6F831C0D6E5B}"/>
+                <a16:creationId xmlns:a16="http://schemas.microsoft.com/office/drawing/2014/main" id="{D5766325-A57E-46DF-B09D-63F51D386213}"/>
               </a:ext>
             </a:extLst>
           </p:cNvPr>
@@ -38755,7 +38755,7 @@
           <p:cNvPr id="13" name="">
             <a:extLst xmlns:a="http://schemas.openxmlformats.org/drawingml/2006/main">
               <a:ext uri="{FF2B5EF4-FFF2-40B4-BE49-F238E27FC236}">
-                <a16:creationId xmlns:a16="http://schemas.microsoft.com/office/drawing/2014/main" id="{4BC03120-A559-4BC5-BE06-BD6ADCC9D120}"/>
+                <a16:creationId xmlns:a16="http://schemas.microsoft.com/office/drawing/2014/main" id="{AE79689D-7129-427A-9B10-CBFE1640B65B}"/>
               </a:ext>
             </a:extLst>
           </p:cNvPr>
@@ -38876,7 +38876,7 @@
           <p:cNvPr id="14" name="">
             <a:extLst xmlns:a="http://schemas.openxmlformats.org/drawingml/2006/main">
               <a:ext uri="{FF2B5EF4-FFF2-40B4-BE49-F238E27FC236}">
-                <a16:creationId xmlns:a16="http://schemas.microsoft.com/office/drawing/2014/main" id="{3FFA59A3-EDB0-4946-8FC2-5F8C199B22D8}"/>
+                <a16:creationId xmlns:a16="http://schemas.microsoft.com/office/drawing/2014/main" id="{4E75CC45-B26D-4D8C-A6FA-3E70FECD363A}"/>
               </a:ext>
             </a:extLst>
           </p:cNvPr>
@@ -38995,7 +38995,7 @@
     </p:spTree>
     <p:extLst>
       <p:ext uri="{BB962C8B-B14F-4D97-AF65-F5344CB8AC3E}">
-        <p14:creationId xmlns:p14="http://schemas.microsoft.com/office/powerpoint/2010/main" val="650829308"/>
+        <p14:creationId xmlns:p14="http://schemas.microsoft.com/office/powerpoint/2010/main" val="1356894397"/>
       </p:ext>
     </p:extLst>
   </p:cSld>
@@ -39026,7 +39026,7 @@
           <p:cNvPr id="31" name="">
             <a:extLst xmlns:a="http://schemas.openxmlformats.org/drawingml/2006/main">
               <a:ext uri="{FF2B5EF4-FFF2-40B4-BE49-F238E27FC236}">
-                <a16:creationId xmlns:a16="http://schemas.microsoft.com/office/drawing/2014/main" id="{1B49A48D-1A62-4DB0-9783-EF03EF367BC1}"/>
+                <a16:creationId xmlns:a16="http://schemas.microsoft.com/office/drawing/2014/main" id="{C1FF70B7-C070-4BA3-9AB1-1702229D30FD}"/>
               </a:ext>
             </a:extLst>
           </p:cNvPr>
@@ -39057,7 +39057,7 @@
           <p:cNvPr id="2" name="">
             <a:extLst xmlns:a="http://schemas.openxmlformats.org/drawingml/2006/main">
               <a:ext uri="{FF2B5EF4-FFF2-40B4-BE49-F238E27FC236}">
-                <a16:creationId xmlns:a16="http://schemas.microsoft.com/office/drawing/2014/main" id="{4B639AA5-707D-45F7-BE10-AE3B6A8C0124}"/>
+                <a16:creationId xmlns:a16="http://schemas.microsoft.com/office/drawing/2014/main" id="{088A7D73-AA27-47F6-874A-9C3967809DC4}"/>
               </a:ext>
             </a:extLst>
           </p:cNvPr>
@@ -39178,7 +39178,7 @@
           <p:cNvPr id="3" name="">
             <a:extLst xmlns:a="http://schemas.openxmlformats.org/drawingml/2006/main">
               <a:ext uri="{FF2B5EF4-FFF2-40B4-BE49-F238E27FC236}">
-                <a16:creationId xmlns:a16="http://schemas.microsoft.com/office/drawing/2014/main" id="{9E9EAFFE-2F98-4E4D-B23E-EB6B67508EA5}"/>
+                <a16:creationId xmlns:a16="http://schemas.microsoft.com/office/drawing/2014/main" id="{C7AC5C53-6470-4138-BA1C-773882AB8548}"/>
               </a:ext>
             </a:extLst>
           </p:cNvPr>
@@ -39299,7 +39299,7 @@
           <p:cNvPr id="4" name="">
             <a:extLst xmlns:a="http://schemas.openxmlformats.org/drawingml/2006/main">
               <a:ext uri="{FF2B5EF4-FFF2-40B4-BE49-F238E27FC236}">
-                <a16:creationId xmlns:a16="http://schemas.microsoft.com/office/drawing/2014/main" id="{F9C60B64-2790-405D-B8D8-6E6C2DEBDE99}"/>
+                <a16:creationId xmlns:a16="http://schemas.microsoft.com/office/drawing/2014/main" id="{0597F3A4-37E6-48DC-BD1E-497C54634FCF}"/>
               </a:ext>
             </a:extLst>
           </p:cNvPr>
@@ -39330,7 +39330,7 @@
           <p:cNvPr id="5" name="">
             <a:extLst xmlns:a="http://schemas.openxmlformats.org/drawingml/2006/main">
               <a:ext uri="{FF2B5EF4-FFF2-40B4-BE49-F238E27FC236}">
-                <a16:creationId xmlns:a16="http://schemas.microsoft.com/office/drawing/2014/main" id="{B7924BB8-D69B-47C1-A7D2-CAC62D7E8AC6}"/>
+                <a16:creationId xmlns:a16="http://schemas.microsoft.com/office/drawing/2014/main" id="{DC233532-3866-4A29-BA9F-C9CC6A5BCDA4}"/>
               </a:ext>
             </a:extLst>
           </p:cNvPr>
@@ -39451,7 +39451,7 @@
           <p:cNvPr id="6" name="">
             <a:extLst xmlns:a="http://schemas.openxmlformats.org/drawingml/2006/main">
               <a:ext uri="{FF2B5EF4-FFF2-40B4-BE49-F238E27FC236}">
-                <a16:creationId xmlns:a16="http://schemas.microsoft.com/office/drawing/2014/main" id="{EFAF4649-A3EC-4904-B494-C8EAC95A1509}"/>
+                <a16:creationId xmlns:a16="http://schemas.microsoft.com/office/drawing/2014/main" id="{682CF4FD-EB51-4CB9-A1C0-EAD8FCBCC638}"/>
               </a:ext>
             </a:extLst>
           </p:cNvPr>
@@ -39484,7 +39484,7 @@
           <p:cNvPr id="7" name="">
             <a:extLst xmlns:a="http://schemas.openxmlformats.org/drawingml/2006/main">
               <a:ext uri="{FF2B5EF4-FFF2-40B4-BE49-F238E27FC236}">
-                <a16:creationId xmlns:a16="http://schemas.microsoft.com/office/drawing/2014/main" id="{B9AB2F56-8C83-4536-B972-63DC5D8CAB02}"/>
+                <a16:creationId xmlns:a16="http://schemas.microsoft.com/office/drawing/2014/main" id="{1AE4A05D-A384-4353-A1E2-917F2C878E70}"/>
               </a:ext>
             </a:extLst>
           </p:cNvPr>
@@ -39605,7 +39605,7 @@
           <p:cNvPr id="8" name="">
             <a:extLst xmlns:a="http://schemas.openxmlformats.org/drawingml/2006/main">
               <a:ext uri="{FF2B5EF4-FFF2-40B4-BE49-F238E27FC236}">
-                <a16:creationId xmlns:a16="http://schemas.microsoft.com/office/drawing/2014/main" id="{7854D440-98F8-4696-A2AA-794A5C184872}"/>
+                <a16:creationId xmlns:a16="http://schemas.microsoft.com/office/drawing/2014/main" id="{240A6D61-8C1B-40AF-A5C0-3EA9BD8E4FEA}"/>
               </a:ext>
             </a:extLst>
           </p:cNvPr>
@@ -39726,7 +39726,7 @@
           <p:cNvPr id="9" name="">
             <a:extLst xmlns:a="http://schemas.openxmlformats.org/drawingml/2006/main">
               <a:ext uri="{FF2B5EF4-FFF2-40B4-BE49-F238E27FC236}">
-                <a16:creationId xmlns:a16="http://schemas.microsoft.com/office/drawing/2014/main" id="{F48A0F0A-8949-44A3-B2CA-AC2FE122BA8A}"/>
+                <a16:creationId xmlns:a16="http://schemas.microsoft.com/office/drawing/2014/main" id="{B904B030-88C3-4E77-A009-C25D70C7CBFB}"/>
               </a:ext>
             </a:extLst>
           </p:cNvPr>
@@ -39847,7 +39847,7 @@
           <p:cNvPr id="10" name="">
             <a:extLst xmlns:a="http://schemas.openxmlformats.org/drawingml/2006/main">
               <a:ext uri="{FF2B5EF4-FFF2-40B4-BE49-F238E27FC236}">
-                <a16:creationId xmlns:a16="http://schemas.microsoft.com/office/drawing/2014/main" id="{627E2037-033F-4436-A96D-D52F45C856F8}"/>
+                <a16:creationId xmlns:a16="http://schemas.microsoft.com/office/drawing/2014/main" id="{51CD4A88-2D44-42CB-B20F-738A616E9551}"/>
               </a:ext>
             </a:extLst>
           </p:cNvPr>
@@ -39880,7 +39880,7 @@
           <p:cNvPr id="11" name="">
             <a:extLst xmlns:a="http://schemas.openxmlformats.org/drawingml/2006/main">
               <a:ext uri="{FF2B5EF4-FFF2-40B4-BE49-F238E27FC236}">
-                <a16:creationId xmlns:a16="http://schemas.microsoft.com/office/drawing/2014/main" id="{597554F8-4889-4C2B-98F3-A0F54B007DB2}"/>
+                <a16:creationId xmlns:a16="http://schemas.microsoft.com/office/drawing/2014/main" id="{683DDAE2-A9D4-4D5D-A367-8C01D4AD311D}"/>
               </a:ext>
             </a:extLst>
           </p:cNvPr>
@@ -40001,7 +40001,7 @@
           <p:cNvPr id="12" name="">
             <a:extLst xmlns:a="http://schemas.openxmlformats.org/drawingml/2006/main">
               <a:ext uri="{FF2B5EF4-FFF2-40B4-BE49-F238E27FC236}">
-                <a16:creationId xmlns:a16="http://schemas.microsoft.com/office/drawing/2014/main" id="{7A1A2EF6-DD22-4D10-A6FE-193909E52630}"/>
+                <a16:creationId xmlns:a16="http://schemas.microsoft.com/office/drawing/2014/main" id="{B53F2C68-F146-4404-AB7C-F321F05C7BEB}"/>
               </a:ext>
             </a:extLst>
           </p:cNvPr>
@@ -40122,7 +40122,7 @@
           <p:cNvPr id="13" name="">
             <a:extLst xmlns:a="http://schemas.openxmlformats.org/drawingml/2006/main">
               <a:ext uri="{FF2B5EF4-FFF2-40B4-BE49-F238E27FC236}">
-                <a16:creationId xmlns:a16="http://schemas.microsoft.com/office/drawing/2014/main" id="{43DE793D-6399-437A-B32E-31079A6689EB}"/>
+                <a16:creationId xmlns:a16="http://schemas.microsoft.com/office/drawing/2014/main" id="{26A5F2DF-31A3-4316-93EB-89E1C5BAE1D4}"/>
               </a:ext>
             </a:extLst>
           </p:cNvPr>
@@ -40243,7 +40243,7 @@
           <p:cNvPr id="14" name="">
             <a:extLst xmlns:a="http://schemas.openxmlformats.org/drawingml/2006/main">
               <a:ext uri="{FF2B5EF4-FFF2-40B4-BE49-F238E27FC236}">
-                <a16:creationId xmlns:a16="http://schemas.microsoft.com/office/drawing/2014/main" id="{8C4DA885-1E36-4164-94A6-43E7A9BC9EB5}"/>
+                <a16:creationId xmlns:a16="http://schemas.microsoft.com/office/drawing/2014/main" id="{0624F3FD-81AF-44CC-A927-893470E58AE5}"/>
               </a:ext>
             </a:extLst>
           </p:cNvPr>
@@ -40276,7 +40276,7 @@
           <p:cNvPr id="15" name="">
             <a:extLst xmlns:a="http://schemas.openxmlformats.org/drawingml/2006/main">
               <a:ext uri="{FF2B5EF4-FFF2-40B4-BE49-F238E27FC236}">
-                <a16:creationId xmlns:a16="http://schemas.microsoft.com/office/drawing/2014/main" id="{5E5403D2-CA45-46C6-8199-C635A3E5F068}"/>
+                <a16:creationId xmlns:a16="http://schemas.microsoft.com/office/drawing/2014/main" id="{45A7B2F4-19A0-4017-ABDB-830D0436F42E}"/>
               </a:ext>
             </a:extLst>
           </p:cNvPr>
@@ -40397,7 +40397,7 @@
           <p:cNvPr id="16" name="">
             <a:extLst xmlns:a="http://schemas.openxmlformats.org/drawingml/2006/main">
               <a:ext uri="{FF2B5EF4-FFF2-40B4-BE49-F238E27FC236}">
-                <a16:creationId xmlns:a16="http://schemas.microsoft.com/office/drawing/2014/main" id="{7DDC104D-1E7A-467F-8915-3F79F44A9F33}"/>
+                <a16:creationId xmlns:a16="http://schemas.microsoft.com/office/drawing/2014/main" id="{926E7103-D8C2-4A4E-94EA-46A51C347D30}"/>
               </a:ext>
             </a:extLst>
           </p:cNvPr>
@@ -40518,7 +40518,7 @@
           <p:cNvPr id="17" name="">
             <a:extLst xmlns:a="http://schemas.openxmlformats.org/drawingml/2006/main">
               <a:ext uri="{FF2B5EF4-FFF2-40B4-BE49-F238E27FC236}">
-                <a16:creationId xmlns:a16="http://schemas.microsoft.com/office/drawing/2014/main" id="{E15FE1A4-223E-48E5-9917-DBEA36250822}"/>
+                <a16:creationId xmlns:a16="http://schemas.microsoft.com/office/drawing/2014/main" id="{C6A32961-C7E2-4497-8B72-6275D27AABB7}"/>
               </a:ext>
             </a:extLst>
           </p:cNvPr>
@@ -40639,7 +40639,7 @@
           <p:cNvPr id="18" name="">
             <a:extLst xmlns:a="http://schemas.openxmlformats.org/drawingml/2006/main">
               <a:ext uri="{FF2B5EF4-FFF2-40B4-BE49-F238E27FC236}">
-                <a16:creationId xmlns:a16="http://schemas.microsoft.com/office/drawing/2014/main" id="{4517A091-46C9-44E6-BC9D-B50142A0FA61}"/>
+                <a16:creationId xmlns:a16="http://schemas.microsoft.com/office/drawing/2014/main" id="{7B3BDCC9-D0B5-473B-966F-847B6D05231D}"/>
               </a:ext>
             </a:extLst>
           </p:cNvPr>
@@ -40672,7 +40672,7 @@
           <p:cNvPr id="19" name="">
             <a:extLst xmlns:a="http://schemas.openxmlformats.org/drawingml/2006/main">
               <a:ext uri="{FF2B5EF4-FFF2-40B4-BE49-F238E27FC236}">
-                <a16:creationId xmlns:a16="http://schemas.microsoft.com/office/drawing/2014/main" id="{E158F3C1-699C-4A18-B01F-1A3D53E55154}"/>
+                <a16:creationId xmlns:a16="http://schemas.microsoft.com/office/drawing/2014/main" id="{42D7AB25-E544-4E44-9ED7-8592FAE7EB32}"/>
               </a:ext>
             </a:extLst>
           </p:cNvPr>
@@ -40793,7 +40793,7 @@
           <p:cNvPr id="20" name="">
             <a:extLst xmlns:a="http://schemas.openxmlformats.org/drawingml/2006/main">
               <a:ext uri="{FF2B5EF4-FFF2-40B4-BE49-F238E27FC236}">
-                <a16:creationId xmlns:a16="http://schemas.microsoft.com/office/drawing/2014/main" id="{78919F71-A5AB-41FF-B0F8-EFAC8166CF16}"/>
+                <a16:creationId xmlns:a16="http://schemas.microsoft.com/office/drawing/2014/main" id="{EC73EDAD-5E86-45E2-BD5A-77B2966C7A26}"/>
               </a:ext>
             </a:extLst>
           </p:cNvPr>
@@ -40914,7 +40914,7 @@
           <p:cNvPr id="21" name="">
             <a:extLst xmlns:a="http://schemas.openxmlformats.org/drawingml/2006/main">
               <a:ext uri="{FF2B5EF4-FFF2-40B4-BE49-F238E27FC236}">
-                <a16:creationId xmlns:a16="http://schemas.microsoft.com/office/drawing/2014/main" id="{972C3838-2984-4760-931D-8344C79C9151}"/>
+                <a16:creationId xmlns:a16="http://schemas.microsoft.com/office/drawing/2014/main" id="{2AA2DDCE-4F45-4B65-A898-8F74738F3349}"/>
               </a:ext>
             </a:extLst>
           </p:cNvPr>
@@ -41035,7 +41035,7 @@
           <p:cNvPr id="22" name="">
             <a:extLst xmlns:a="http://schemas.openxmlformats.org/drawingml/2006/main">
               <a:ext uri="{FF2B5EF4-FFF2-40B4-BE49-F238E27FC236}">
-                <a16:creationId xmlns:a16="http://schemas.microsoft.com/office/drawing/2014/main" id="{7BDA3B59-8778-4B82-ABE4-B2BA8A43DD42}"/>
+                <a16:creationId xmlns:a16="http://schemas.microsoft.com/office/drawing/2014/main" id="{636FDD6E-3CA2-4C29-8844-062EA325C6C8}"/>
               </a:ext>
             </a:extLst>
           </p:cNvPr>
@@ -41068,7 +41068,7 @@
           <p:cNvPr id="23" name="">
             <a:extLst xmlns:a="http://schemas.openxmlformats.org/drawingml/2006/main">
               <a:ext uri="{FF2B5EF4-FFF2-40B4-BE49-F238E27FC236}">
-                <a16:creationId xmlns:a16="http://schemas.microsoft.com/office/drawing/2014/main" id="{0DD54A6C-202F-44BC-8F81-59DD252264E8}"/>
+                <a16:creationId xmlns:a16="http://schemas.microsoft.com/office/drawing/2014/main" id="{95106080-E019-4A46-A7FB-2CE0B15167FF}"/>
               </a:ext>
             </a:extLst>
           </p:cNvPr>
@@ -41189,7 +41189,7 @@
           <p:cNvPr id="24" name="">
             <a:extLst xmlns:a="http://schemas.openxmlformats.org/drawingml/2006/main">
               <a:ext uri="{FF2B5EF4-FFF2-40B4-BE49-F238E27FC236}">
-                <a16:creationId xmlns:a16="http://schemas.microsoft.com/office/drawing/2014/main" id="{5D7B8C51-E52D-42A5-AB36-157588095662}"/>
+                <a16:creationId xmlns:a16="http://schemas.microsoft.com/office/drawing/2014/main" id="{7A1E16D7-F50A-4BBD-BA1E-7AC4B3471B50}"/>
               </a:ext>
             </a:extLst>
           </p:cNvPr>
@@ -41310,7 +41310,7 @@
           <p:cNvPr id="25" name="">
             <a:extLst xmlns:a="http://schemas.openxmlformats.org/drawingml/2006/main">
               <a:ext uri="{FF2B5EF4-FFF2-40B4-BE49-F238E27FC236}">
-                <a16:creationId xmlns:a16="http://schemas.microsoft.com/office/drawing/2014/main" id="{0F6B523C-6A00-4EA7-914D-8DC62D5223AA}"/>
+                <a16:creationId xmlns:a16="http://schemas.microsoft.com/office/drawing/2014/main" id="{C3B88F85-E606-4FF7-AB71-83D957F0BED7}"/>
               </a:ext>
             </a:extLst>
           </p:cNvPr>
@@ -41431,7 +41431,7 @@
           <p:cNvPr id="26" name="">
             <a:extLst xmlns:a="http://schemas.openxmlformats.org/drawingml/2006/main">
               <a:ext uri="{FF2B5EF4-FFF2-40B4-BE49-F238E27FC236}">
-                <a16:creationId xmlns:a16="http://schemas.microsoft.com/office/drawing/2014/main" id="{28D1B37B-09C3-4CFE-BA11-C303E15EE797}"/>
+                <a16:creationId xmlns:a16="http://schemas.microsoft.com/office/drawing/2014/main" id="{EE7557BE-C3F3-4EA5-93DE-F383B77F18BB}"/>
               </a:ext>
             </a:extLst>
           </p:cNvPr>
@@ -41464,7 +41464,7 @@
           <p:cNvPr id="27" name="">
             <a:extLst xmlns:a="http://schemas.openxmlformats.org/drawingml/2006/main">
               <a:ext uri="{FF2B5EF4-FFF2-40B4-BE49-F238E27FC236}">
-                <a16:creationId xmlns:a16="http://schemas.microsoft.com/office/drawing/2014/main" id="{CC81DF3F-54E5-4356-9AC0-176557CD9CED}"/>
+                <a16:creationId xmlns:a16="http://schemas.microsoft.com/office/drawing/2014/main" id="{FE0C4B79-02E7-4AE6-AE82-3BF7DEF1065E}"/>
               </a:ext>
             </a:extLst>
           </p:cNvPr>
@@ -41585,7 +41585,7 @@
           <p:cNvPr id="28" name="">
             <a:extLst xmlns:a="http://schemas.openxmlformats.org/drawingml/2006/main">
               <a:ext uri="{FF2B5EF4-FFF2-40B4-BE49-F238E27FC236}">
-                <a16:creationId xmlns:a16="http://schemas.microsoft.com/office/drawing/2014/main" id="{4D70AC69-15E6-4AE4-B1DC-CB2A6DC725DA}"/>
+                <a16:creationId xmlns:a16="http://schemas.microsoft.com/office/drawing/2014/main" id="{AB67CF10-0F2A-4350-97EB-0B507CC68046}"/>
               </a:ext>
             </a:extLst>
           </p:cNvPr>
@@ -41706,7 +41706,7 @@
           <p:cNvPr id="29" name="">
             <a:extLst xmlns:a="http://schemas.openxmlformats.org/drawingml/2006/main">
               <a:ext uri="{FF2B5EF4-FFF2-40B4-BE49-F238E27FC236}">
-                <a16:creationId xmlns:a16="http://schemas.microsoft.com/office/drawing/2014/main" id="{03A23CAF-9AE9-4250-B5F6-8DE41B93C053}"/>
+                <a16:creationId xmlns:a16="http://schemas.microsoft.com/office/drawing/2014/main" id="{EF24240C-1861-4828-B880-469BFD510491}"/>
               </a:ext>
             </a:extLst>
           </p:cNvPr>
@@ -41827,7 +41827,7 @@
           <p:cNvPr id="30" name="">
             <a:extLst xmlns:a="http://schemas.openxmlformats.org/drawingml/2006/main">
               <a:ext uri="{FF2B5EF4-FFF2-40B4-BE49-F238E27FC236}">
-                <a16:creationId xmlns:a16="http://schemas.microsoft.com/office/drawing/2014/main" id="{32B0D889-4C33-4926-96CE-A1C38AE33F9E}"/>
+                <a16:creationId xmlns:a16="http://schemas.microsoft.com/office/drawing/2014/main" id="{24790068-20A1-47D6-A321-481EB39FFF1D}"/>
               </a:ext>
             </a:extLst>
           </p:cNvPr>
@@ -41946,7 +41946,7 @@
     </p:spTree>
     <p:extLst>
       <p:ext uri="{BB962C8B-B14F-4D97-AF65-F5344CB8AC3E}">
-        <p14:creationId xmlns:p14="http://schemas.microsoft.com/office/powerpoint/2010/main" val="1297849695"/>
+        <p14:creationId xmlns:p14="http://schemas.microsoft.com/office/powerpoint/2010/main" val="1134293301"/>
       </p:ext>
     </p:extLst>
   </p:cSld>
@@ -41977,7 +41977,7 @@
           <p:cNvPr id="17" name="">
             <a:extLst xmlns:a="http://schemas.openxmlformats.org/drawingml/2006/main">
               <a:ext uri="{FF2B5EF4-FFF2-40B4-BE49-F238E27FC236}">
-                <a16:creationId xmlns:a16="http://schemas.microsoft.com/office/drawing/2014/main" id="{96B6AB9B-3853-4F8A-A296-49DF54353EC5}"/>
+                <a16:creationId xmlns:a16="http://schemas.microsoft.com/office/drawing/2014/main" id="{9111F2F5-B605-4C8E-AEB8-E4E2B23D28A6}"/>
               </a:ext>
             </a:extLst>
           </p:cNvPr>
@@ -42008,7 +42008,7 @@
           <p:cNvPr id="2" name="">
             <a:extLst xmlns:a="http://schemas.openxmlformats.org/drawingml/2006/main">
               <a:ext uri="{FF2B5EF4-FFF2-40B4-BE49-F238E27FC236}">
-                <a16:creationId xmlns:a16="http://schemas.microsoft.com/office/drawing/2014/main" id="{BD2DB9DF-BA40-40D3-855D-F8D3E5C3EE7F}"/>
+                <a16:creationId xmlns:a16="http://schemas.microsoft.com/office/drawing/2014/main" id="{189D6730-3324-4F22-B9F1-FFA2CE150795}"/>
               </a:ext>
             </a:extLst>
           </p:cNvPr>
@@ -42129,7 +42129,7 @@
           <p:cNvPr id="3" name="">
             <a:extLst xmlns:a="http://schemas.openxmlformats.org/drawingml/2006/main">
               <a:ext uri="{FF2B5EF4-FFF2-40B4-BE49-F238E27FC236}">
-                <a16:creationId xmlns:a16="http://schemas.microsoft.com/office/drawing/2014/main" id="{5C53B493-7B3D-4A32-A274-25926660FE0E}"/>
+                <a16:creationId xmlns:a16="http://schemas.microsoft.com/office/drawing/2014/main" id="{0DA784E6-67D7-4915-ABE1-2335FFD5B1CE}"/>
               </a:ext>
             </a:extLst>
           </p:cNvPr>
@@ -42250,7 +42250,7 @@
           <p:cNvPr id="4" name="">
             <a:extLst xmlns:a="http://schemas.openxmlformats.org/drawingml/2006/main">
               <a:ext uri="{FF2B5EF4-FFF2-40B4-BE49-F238E27FC236}">
-                <a16:creationId xmlns:a16="http://schemas.microsoft.com/office/drawing/2014/main" id="{57586227-AA25-4D33-83CE-5441223667B9}"/>
+                <a16:creationId xmlns:a16="http://schemas.microsoft.com/office/drawing/2014/main" id="{7D259071-9E2F-44AE-8C2B-0276A51FBFBD}"/>
               </a:ext>
             </a:extLst>
           </p:cNvPr>
@@ -42281,7 +42281,7 @@
           <p:cNvPr id="5" name="">
             <a:extLst xmlns:a="http://schemas.openxmlformats.org/drawingml/2006/main">
               <a:ext uri="{FF2B5EF4-FFF2-40B4-BE49-F238E27FC236}">
-                <a16:creationId xmlns:a16="http://schemas.microsoft.com/office/drawing/2014/main" id="{88B405E1-151D-4BA0-9D4F-C41F524C2325}"/>
+                <a16:creationId xmlns:a16="http://schemas.microsoft.com/office/drawing/2014/main" id="{5322ADCF-C2CB-4572-9F8C-281920593E03}"/>
               </a:ext>
             </a:extLst>
           </p:cNvPr>
@@ -42402,7 +42402,7 @@
           <p:cNvPr id="6" name="">
             <a:extLst xmlns:a="http://schemas.openxmlformats.org/drawingml/2006/main">
               <a:ext uri="{FF2B5EF4-FFF2-40B4-BE49-F238E27FC236}">
-                <a16:creationId xmlns:a16="http://schemas.microsoft.com/office/drawing/2014/main" id="{5888F1D1-8EAD-464B-A0FA-7A3A44CB4034}"/>
+                <a16:creationId xmlns:a16="http://schemas.microsoft.com/office/drawing/2014/main" id="{6267C2A8-05B3-422A-BC6C-AEA5B4CCC32E}"/>
               </a:ext>
             </a:extLst>
           </p:cNvPr>
@@ -42523,7 +42523,7 @@
           <p:cNvPr id="7" name="">
             <a:extLst xmlns:a="http://schemas.openxmlformats.org/drawingml/2006/main">
               <a:ext uri="{FF2B5EF4-FFF2-40B4-BE49-F238E27FC236}">
-                <a16:creationId xmlns:a16="http://schemas.microsoft.com/office/drawing/2014/main" id="{8430CEB9-3A2B-4B4F-B32C-9DE368DCD799}"/>
+                <a16:creationId xmlns:a16="http://schemas.microsoft.com/office/drawing/2014/main" id="{A2791C58-28A0-45F7-96F1-14B712406EE1}"/>
               </a:ext>
             </a:extLst>
           </p:cNvPr>
@@ -42644,7 +42644,7 @@
           <p:cNvPr id="8" name="">
             <a:extLst xmlns:a="http://schemas.openxmlformats.org/drawingml/2006/main">
               <a:ext uri="{FF2B5EF4-FFF2-40B4-BE49-F238E27FC236}">
-                <a16:creationId xmlns:a16="http://schemas.microsoft.com/office/drawing/2014/main" id="{640FC6BA-BEEB-4971-AB2F-28F90AE16996}"/>
+                <a16:creationId xmlns:a16="http://schemas.microsoft.com/office/drawing/2014/main" id="{E4212384-0322-413F-B7E2-F8C54BCEE5A3}"/>
               </a:ext>
             </a:extLst>
           </p:cNvPr>
@@ -42799,7 +42799,7 @@
           <p:cNvPr id="9" name="">
             <a:extLst xmlns:a="http://schemas.openxmlformats.org/drawingml/2006/main">
               <a:ext uri="{FF2B5EF4-FFF2-40B4-BE49-F238E27FC236}">
-                <a16:creationId xmlns:a16="http://schemas.microsoft.com/office/drawing/2014/main" id="{DA397C65-32F2-4FCB-BC38-E6795AAA0671}"/>
+                <a16:creationId xmlns:a16="http://schemas.microsoft.com/office/drawing/2014/main" id="{40D3061C-FD54-40A4-898E-E2F36E6CE5FC}"/>
               </a:ext>
             </a:extLst>
           </p:cNvPr>
@@ -42920,7 +42920,7 @@
           <p:cNvPr id="10" name="">
             <a:extLst xmlns:a="http://schemas.openxmlformats.org/drawingml/2006/main">
               <a:ext uri="{FF2B5EF4-FFF2-40B4-BE49-F238E27FC236}">
-                <a16:creationId xmlns:a16="http://schemas.microsoft.com/office/drawing/2014/main" id="{CF7F0C88-1E44-428A-8E54-97054C37E4E3}"/>
+                <a16:creationId xmlns:a16="http://schemas.microsoft.com/office/drawing/2014/main" id="{45E5A869-3192-42B4-B056-84DAE8DBBD4D}"/>
               </a:ext>
             </a:extLst>
           </p:cNvPr>
@@ -42951,7 +42951,7 @@
           <p:cNvPr id="11" name="">
             <a:extLst xmlns:a="http://schemas.openxmlformats.org/drawingml/2006/main">
               <a:ext uri="{FF2B5EF4-FFF2-40B4-BE49-F238E27FC236}">
-                <a16:creationId xmlns:a16="http://schemas.microsoft.com/office/drawing/2014/main" id="{34DDB80B-FFF0-4047-B5F4-7609E90A2690}"/>
+                <a16:creationId xmlns:a16="http://schemas.microsoft.com/office/drawing/2014/main" id="{5619FD98-1B60-43ED-A35E-74E711C1DC36}"/>
               </a:ext>
             </a:extLst>
           </p:cNvPr>
@@ -43072,7 +43072,7 @@
           <p:cNvPr id="12" name="">
             <a:extLst xmlns:a="http://schemas.openxmlformats.org/drawingml/2006/main">
               <a:ext uri="{FF2B5EF4-FFF2-40B4-BE49-F238E27FC236}">
-                <a16:creationId xmlns:a16="http://schemas.microsoft.com/office/drawing/2014/main" id="{AD6A537D-3359-4D23-8F94-2C564832E79C}"/>
+                <a16:creationId xmlns:a16="http://schemas.microsoft.com/office/drawing/2014/main" id="{10F0C265-9783-467F-8C73-B21372E73B15}"/>
               </a:ext>
             </a:extLst>
           </p:cNvPr>
@@ -43193,7 +43193,7 @@
           <p:cNvPr id="13" name="">
             <a:extLst xmlns:a="http://schemas.openxmlformats.org/drawingml/2006/main">
               <a:ext uri="{FF2B5EF4-FFF2-40B4-BE49-F238E27FC236}">
-                <a16:creationId xmlns:a16="http://schemas.microsoft.com/office/drawing/2014/main" id="{01AB5FFC-2222-4816-A2BE-6948E2661110}"/>
+                <a16:creationId xmlns:a16="http://schemas.microsoft.com/office/drawing/2014/main" id="{A4F729E1-3F46-480D-B135-CC40E8BF263F}"/>
               </a:ext>
             </a:extLst>
           </p:cNvPr>
@@ -43348,7 +43348,7 @@
           <p:cNvPr id="14" name="">
             <a:extLst xmlns:a="http://schemas.openxmlformats.org/drawingml/2006/main">
               <a:ext uri="{FF2B5EF4-FFF2-40B4-BE49-F238E27FC236}">
-                <a16:creationId xmlns:a16="http://schemas.microsoft.com/office/drawing/2014/main" id="{1B083FC0-70BA-4A4A-A277-ABA94E77F8FB}"/>
+                <a16:creationId xmlns:a16="http://schemas.microsoft.com/office/drawing/2014/main" id="{947AC750-9930-43B6-AE94-439163427990}"/>
               </a:ext>
             </a:extLst>
           </p:cNvPr>
@@ -43469,7 +43469,7 @@
           <p:cNvPr id="15" name="">
             <a:extLst xmlns:a="http://schemas.openxmlformats.org/drawingml/2006/main">
               <a:ext uri="{FF2B5EF4-FFF2-40B4-BE49-F238E27FC236}">
-                <a16:creationId xmlns:a16="http://schemas.microsoft.com/office/drawing/2014/main" id="{1377AEC1-0590-4DB1-ACD1-A36CDECB222C}"/>
+                <a16:creationId xmlns:a16="http://schemas.microsoft.com/office/drawing/2014/main" id="{577AFFB7-1846-46CB-A430-493D8EA1FCCC}"/>
               </a:ext>
             </a:extLst>
           </p:cNvPr>
@@ -43502,7 +43502,7 @@
           <p:cNvPr id="16" name="">
             <a:extLst xmlns:a="http://schemas.openxmlformats.org/drawingml/2006/main">
               <a:ext uri="{FF2B5EF4-FFF2-40B4-BE49-F238E27FC236}">
-                <a16:creationId xmlns:a16="http://schemas.microsoft.com/office/drawing/2014/main" id="{7C4A8097-541F-4BC1-B230-9A63CDB50639}"/>
+                <a16:creationId xmlns:a16="http://schemas.microsoft.com/office/drawing/2014/main" id="{33F9038A-807A-42D8-9E6B-04587A39A2C3}"/>
               </a:ext>
             </a:extLst>
           </p:cNvPr>
@@ -43621,7 +43621,7 @@
     </p:spTree>
     <p:extLst>
       <p:ext uri="{BB962C8B-B14F-4D97-AF65-F5344CB8AC3E}">
-        <p14:creationId xmlns:p14="http://schemas.microsoft.com/office/powerpoint/2010/main" val="2036134948"/>
+        <p14:creationId xmlns:p14="http://schemas.microsoft.com/office/powerpoint/2010/main" val="986384210"/>
       </p:ext>
     </p:extLst>
   </p:cSld>
@@ -43652,7 +43652,7 @@
           <p:cNvPr id="23" name="">
             <a:extLst xmlns:a="http://schemas.openxmlformats.org/drawingml/2006/main">
               <a:ext uri="{FF2B5EF4-FFF2-40B4-BE49-F238E27FC236}">
-                <a16:creationId xmlns:a16="http://schemas.microsoft.com/office/drawing/2014/main" id="{24B733F7-04CE-4BDC-AAA0-F6BBCA6525F0}"/>
+                <a16:creationId xmlns:a16="http://schemas.microsoft.com/office/drawing/2014/main" id="{CEE99863-B360-4F16-B598-3EE241CFB735}"/>
               </a:ext>
             </a:extLst>
           </p:cNvPr>
@@ -43683,7 +43683,7 @@
           <p:cNvPr id="2" name="">
             <a:extLst xmlns:a="http://schemas.openxmlformats.org/drawingml/2006/main">
               <a:ext uri="{FF2B5EF4-FFF2-40B4-BE49-F238E27FC236}">
-                <a16:creationId xmlns:a16="http://schemas.microsoft.com/office/drawing/2014/main" id="{CFEEBE36-E855-425C-A936-753FF38E4AFC}"/>
+                <a16:creationId xmlns:a16="http://schemas.microsoft.com/office/drawing/2014/main" id="{9720A9DF-F46A-4AAE-A7D7-89025FE3D929}"/>
               </a:ext>
             </a:extLst>
           </p:cNvPr>
@@ -43804,7 +43804,7 @@
           <p:cNvPr id="3" name="">
             <a:extLst xmlns:a="http://schemas.openxmlformats.org/drawingml/2006/main">
               <a:ext uri="{FF2B5EF4-FFF2-40B4-BE49-F238E27FC236}">
-                <a16:creationId xmlns:a16="http://schemas.microsoft.com/office/drawing/2014/main" id="{CF9927EF-5B97-4494-A429-581FC4DFA229}"/>
+                <a16:creationId xmlns:a16="http://schemas.microsoft.com/office/drawing/2014/main" id="{55BD1E03-0CC8-4861-878E-68CA5AC747D7}"/>
               </a:ext>
             </a:extLst>
           </p:cNvPr>
@@ -43925,7 +43925,7 @@
           <p:cNvPr id="4" name="">
             <a:extLst xmlns:a="http://schemas.openxmlformats.org/drawingml/2006/main">
               <a:ext uri="{FF2B5EF4-FFF2-40B4-BE49-F238E27FC236}">
-                <a16:creationId xmlns:a16="http://schemas.microsoft.com/office/drawing/2014/main" id="{1F126645-C060-4F4E-A26D-2D08A4982991}"/>
+                <a16:creationId xmlns:a16="http://schemas.microsoft.com/office/drawing/2014/main" id="{9B29096E-1BB7-4619-B8C5-CF9E244C910C}"/>
               </a:ext>
             </a:extLst>
           </p:cNvPr>
@@ -43956,7 +43956,7 @@
           <p:cNvPr id="5" name="">
             <a:extLst xmlns:a="http://schemas.openxmlformats.org/drawingml/2006/main">
               <a:ext uri="{FF2B5EF4-FFF2-40B4-BE49-F238E27FC236}">
-                <a16:creationId xmlns:a16="http://schemas.microsoft.com/office/drawing/2014/main" id="{77876770-A2F0-4D5A-9900-8234F8697B00}"/>
+                <a16:creationId xmlns:a16="http://schemas.microsoft.com/office/drawing/2014/main" id="{3E27367B-C153-4379-92D7-F1BB201F4DFA}"/>
               </a:ext>
             </a:extLst>
           </p:cNvPr>
@@ -44077,7 +44077,7 @@
           <p:cNvPr id="6" name="">
             <a:extLst xmlns:a="http://schemas.openxmlformats.org/drawingml/2006/main">
               <a:ext uri="{FF2B5EF4-FFF2-40B4-BE49-F238E27FC236}">
-                <a16:creationId xmlns:a16="http://schemas.microsoft.com/office/drawing/2014/main" id="{2083C9F7-83EA-4657-AD76-759054608D57}"/>
+                <a16:creationId xmlns:a16="http://schemas.microsoft.com/office/drawing/2014/main" id="{1368E3A0-0E3D-4395-BB34-07FB351590DB}"/>
               </a:ext>
             </a:extLst>
           </p:cNvPr>
@@ -44198,7 +44198,7 @@
           <p:cNvPr id="7" name="">
             <a:extLst xmlns:a="http://schemas.openxmlformats.org/drawingml/2006/main">
               <a:ext uri="{FF2B5EF4-FFF2-40B4-BE49-F238E27FC236}">
-                <a16:creationId xmlns:a16="http://schemas.microsoft.com/office/drawing/2014/main" id="{A19338F2-A6E4-4B6D-BF8D-84AE2505720D}"/>
+                <a16:creationId xmlns:a16="http://schemas.microsoft.com/office/drawing/2014/main" id="{F12D19F7-ED36-4AAD-AF17-DA7199AA66C6}"/>
               </a:ext>
             </a:extLst>
           </p:cNvPr>
@@ -44319,7 +44319,7 @@
           <p:cNvPr id="8" name="">
             <a:extLst xmlns:a="http://schemas.openxmlformats.org/drawingml/2006/main">
               <a:ext uri="{FF2B5EF4-FFF2-40B4-BE49-F238E27FC236}">
-                <a16:creationId xmlns:a16="http://schemas.microsoft.com/office/drawing/2014/main" id="{68993503-3BD0-492F-823B-54B8FD888DE4}"/>
+                <a16:creationId xmlns:a16="http://schemas.microsoft.com/office/drawing/2014/main" id="{8DADB628-4797-4C24-BE45-C5A127A42BBB}"/>
               </a:ext>
             </a:extLst>
           </p:cNvPr>
@@ -44350,7 +44350,7 @@
           <p:cNvPr id="9" name="">
             <a:extLst xmlns:a="http://schemas.openxmlformats.org/drawingml/2006/main">
               <a:ext uri="{FF2B5EF4-FFF2-40B4-BE49-F238E27FC236}">
-                <a16:creationId xmlns:a16="http://schemas.microsoft.com/office/drawing/2014/main" id="{FCA447C3-614F-44AC-8F77-B53F5B2344F5}"/>
+                <a16:creationId xmlns:a16="http://schemas.microsoft.com/office/drawing/2014/main" id="{52F27778-55F6-4C29-9163-C191F2D6DC34}"/>
               </a:ext>
             </a:extLst>
           </p:cNvPr>
@@ -44471,7 +44471,7 @@
           <p:cNvPr id="10" name="">
             <a:extLst xmlns:a="http://schemas.openxmlformats.org/drawingml/2006/main">
               <a:ext uri="{FF2B5EF4-FFF2-40B4-BE49-F238E27FC236}">
-                <a16:creationId xmlns:a16="http://schemas.microsoft.com/office/drawing/2014/main" id="{A24F6E5B-CA5D-40F7-824A-AD1E2F771980}"/>
+                <a16:creationId xmlns:a16="http://schemas.microsoft.com/office/drawing/2014/main" id="{22DD2766-9FAB-429F-AEDE-EA943079CEF5}"/>
               </a:ext>
             </a:extLst>
           </p:cNvPr>
@@ -44592,7 +44592,7 @@
           <p:cNvPr id="11" name="">
             <a:extLst xmlns:a="http://schemas.openxmlformats.org/drawingml/2006/main">
               <a:ext uri="{FF2B5EF4-FFF2-40B4-BE49-F238E27FC236}">
-                <a16:creationId xmlns:a16="http://schemas.microsoft.com/office/drawing/2014/main" id="{6183F142-9504-447C-9078-A15A129E5383}"/>
+                <a16:creationId xmlns:a16="http://schemas.microsoft.com/office/drawing/2014/main" id="{BB154728-B375-4EF1-AF8F-5D505B285786}"/>
               </a:ext>
             </a:extLst>
           </p:cNvPr>
@@ -44623,7 +44623,7 @@
           <p:cNvPr id="12" name="">
             <a:extLst xmlns:a="http://schemas.openxmlformats.org/drawingml/2006/main">
               <a:ext uri="{FF2B5EF4-FFF2-40B4-BE49-F238E27FC236}">
-                <a16:creationId xmlns:a16="http://schemas.microsoft.com/office/drawing/2014/main" id="{3F455BC0-DD0B-49E9-987C-F79216004BF6}"/>
+                <a16:creationId xmlns:a16="http://schemas.microsoft.com/office/drawing/2014/main" id="{045C3B41-1529-4502-9DDB-64BCDB308ADC}"/>
               </a:ext>
             </a:extLst>
           </p:cNvPr>
@@ -44744,7 +44744,7 @@
           <p:cNvPr id="13" name="">
             <a:extLst xmlns:a="http://schemas.openxmlformats.org/drawingml/2006/main">
               <a:ext uri="{FF2B5EF4-FFF2-40B4-BE49-F238E27FC236}">
-                <a16:creationId xmlns:a16="http://schemas.microsoft.com/office/drawing/2014/main" id="{11F88A77-135E-4430-8041-5CA42F961C34}"/>
+                <a16:creationId xmlns:a16="http://schemas.microsoft.com/office/drawing/2014/main" id="{097B8EEE-7C31-46FC-8D25-BBF90EE40940}"/>
               </a:ext>
             </a:extLst>
           </p:cNvPr>
@@ -44865,7 +44865,7 @@
           <p:cNvPr id="14" name="">
             <a:extLst xmlns:a="http://schemas.openxmlformats.org/drawingml/2006/main">
               <a:ext uri="{FF2B5EF4-FFF2-40B4-BE49-F238E27FC236}">
-                <a16:creationId xmlns:a16="http://schemas.microsoft.com/office/drawing/2014/main" id="{2F07D648-A33D-4918-A8B9-94D2F1052B63}"/>
+                <a16:creationId xmlns:a16="http://schemas.microsoft.com/office/drawing/2014/main" id="{9951B283-7C2D-484E-BE8B-425248DBAF47}"/>
               </a:ext>
             </a:extLst>
           </p:cNvPr>
@@ -44896,7 +44896,7 @@
           <p:cNvPr id="15" name="">
             <a:extLst xmlns:a="http://schemas.openxmlformats.org/drawingml/2006/main">
               <a:ext uri="{FF2B5EF4-FFF2-40B4-BE49-F238E27FC236}">
-                <a16:creationId xmlns:a16="http://schemas.microsoft.com/office/drawing/2014/main" id="{4C900A72-9DB8-4A9F-A7C3-AD9B38ECE125}"/>
+                <a16:creationId xmlns:a16="http://schemas.microsoft.com/office/drawing/2014/main" id="{2400ECEF-CC91-449A-B7C4-21F2A50E30FE}"/>
               </a:ext>
             </a:extLst>
           </p:cNvPr>
@@ -45017,7 +45017,7 @@
           <p:cNvPr id="16" name="">
             <a:extLst xmlns:a="http://schemas.openxmlformats.org/drawingml/2006/main">
               <a:ext uri="{FF2B5EF4-FFF2-40B4-BE49-F238E27FC236}">
-                <a16:creationId xmlns:a16="http://schemas.microsoft.com/office/drawing/2014/main" id="{E25AD7B8-4FDD-4A19-916C-0D8D2CA44364}"/>
+                <a16:creationId xmlns:a16="http://schemas.microsoft.com/office/drawing/2014/main" id="{CCF5F5B5-5ABA-4CAE-A439-77714F568D51}"/>
               </a:ext>
             </a:extLst>
           </p:cNvPr>
@@ -45138,7 +45138,7 @@
           <p:cNvPr id="17" name="">
             <a:extLst xmlns:a="http://schemas.openxmlformats.org/drawingml/2006/main">
               <a:ext uri="{FF2B5EF4-FFF2-40B4-BE49-F238E27FC236}">
-                <a16:creationId xmlns:a16="http://schemas.microsoft.com/office/drawing/2014/main" id="{BA60DE3C-4362-4703-B909-5A6759290568}"/>
+                <a16:creationId xmlns:a16="http://schemas.microsoft.com/office/drawing/2014/main" id="{BC4D62EB-D60F-44B3-BA06-8FE8B757432F}"/>
               </a:ext>
             </a:extLst>
           </p:cNvPr>
@@ -45169,7 +45169,7 @@
           <p:cNvPr id="18" name="">
             <a:extLst xmlns:a="http://schemas.openxmlformats.org/drawingml/2006/main">
               <a:ext uri="{FF2B5EF4-FFF2-40B4-BE49-F238E27FC236}">
-                <a16:creationId xmlns:a16="http://schemas.microsoft.com/office/drawing/2014/main" id="{88BBA40B-4104-4B3F-96F0-FD9648CD17BA}"/>
+                <a16:creationId xmlns:a16="http://schemas.microsoft.com/office/drawing/2014/main" id="{3F1456DC-510D-4376-B5A5-F2948BB8159E}"/>
               </a:ext>
             </a:extLst>
           </p:cNvPr>
@@ -45290,7 +45290,7 @@
           <p:cNvPr id="19" name="">
             <a:extLst xmlns:a="http://schemas.openxmlformats.org/drawingml/2006/main">
               <a:ext uri="{FF2B5EF4-FFF2-40B4-BE49-F238E27FC236}">
-                <a16:creationId xmlns:a16="http://schemas.microsoft.com/office/drawing/2014/main" id="{A7453E7B-B1ED-4455-B262-EAAA49AC3D37}"/>
+                <a16:creationId xmlns:a16="http://schemas.microsoft.com/office/drawing/2014/main" id="{74F9DE43-6EF2-4188-AD81-81A1F239BC00}"/>
               </a:ext>
             </a:extLst>
           </p:cNvPr>
@@ -45411,7 +45411,7 @@
           <p:cNvPr id="20" name="">
             <a:extLst xmlns:a="http://schemas.openxmlformats.org/drawingml/2006/main">
               <a:ext uri="{FF2B5EF4-FFF2-40B4-BE49-F238E27FC236}">
-                <a16:creationId xmlns:a16="http://schemas.microsoft.com/office/drawing/2014/main" id="{39C331E5-1E76-455D-91F1-1CFFBE6486B9}"/>
+                <a16:creationId xmlns:a16="http://schemas.microsoft.com/office/drawing/2014/main" id="{251D8ACD-CB68-41BA-877F-CB738ABBDE68}"/>
               </a:ext>
             </a:extLst>
           </p:cNvPr>
@@ -45442,7 +45442,7 @@
           <p:cNvPr id="21" name="">
             <a:extLst xmlns:a="http://schemas.openxmlformats.org/drawingml/2006/main">
               <a:ext uri="{FF2B5EF4-FFF2-40B4-BE49-F238E27FC236}">
-                <a16:creationId xmlns:a16="http://schemas.microsoft.com/office/drawing/2014/main" id="{61363BAE-09D9-478A-A0E4-C492306A0708}"/>
+                <a16:creationId xmlns:a16="http://schemas.microsoft.com/office/drawing/2014/main" id="{D7C5D578-03B2-4607-9C69-2B7EAB3A06E4}"/>
               </a:ext>
             </a:extLst>
           </p:cNvPr>
@@ -45475,7 +45475,7 @@
           <p:cNvPr id="22" name="">
             <a:extLst xmlns:a="http://schemas.openxmlformats.org/drawingml/2006/main">
               <a:ext uri="{FF2B5EF4-FFF2-40B4-BE49-F238E27FC236}">
-                <a16:creationId xmlns:a16="http://schemas.microsoft.com/office/drawing/2014/main" id="{AA476693-68BA-4256-B7E3-AF0965D4F5D4}"/>
+                <a16:creationId xmlns:a16="http://schemas.microsoft.com/office/drawing/2014/main" id="{F590FEBD-0F3B-40AB-86ED-850EB2B09D80}"/>
               </a:ext>
             </a:extLst>
           </p:cNvPr>
@@ -45594,7 +45594,7 @@
     </p:spTree>
     <p:extLst>
       <p:ext uri="{BB962C8B-B14F-4D97-AF65-F5344CB8AC3E}">
-        <p14:creationId xmlns:p14="http://schemas.microsoft.com/office/powerpoint/2010/main" val="794461494"/>
+        <p14:creationId xmlns:p14="http://schemas.microsoft.com/office/powerpoint/2010/main" val="1078986353"/>
       </p:ext>
     </p:extLst>
   </p:cSld>
@@ -45625,7 +45625,7 @@
           <p:cNvPr id="27" name="">
             <a:extLst xmlns:a="http://schemas.openxmlformats.org/drawingml/2006/main">
               <a:ext uri="{FF2B5EF4-FFF2-40B4-BE49-F238E27FC236}">
-                <a16:creationId xmlns:a16="http://schemas.microsoft.com/office/drawing/2014/main" id="{EB1D7716-A9FE-439A-B7B4-914BEE1FEAFE}"/>
+                <a16:creationId xmlns:a16="http://schemas.microsoft.com/office/drawing/2014/main" id="{E9CFC20F-C1E5-4EE3-8E52-B96DABC8550E}"/>
               </a:ext>
             </a:extLst>
           </p:cNvPr>
@@ -45656,7 +45656,7 @@
           <p:cNvPr id="2" name="">
             <a:extLst xmlns:a="http://schemas.openxmlformats.org/drawingml/2006/main">
               <a:ext uri="{FF2B5EF4-FFF2-40B4-BE49-F238E27FC236}">
-                <a16:creationId xmlns:a16="http://schemas.microsoft.com/office/drawing/2014/main" id="{05DB0462-0CF4-498E-B6F0-3C06B633AA36}"/>
+                <a16:creationId xmlns:a16="http://schemas.microsoft.com/office/drawing/2014/main" id="{403A3103-162B-41A7-B67B-480F23C83F2C}"/>
               </a:ext>
             </a:extLst>
           </p:cNvPr>
@@ -45777,7 +45777,7 @@
           <p:cNvPr id="3" name="">
             <a:extLst xmlns:a="http://schemas.openxmlformats.org/drawingml/2006/main">
               <a:ext uri="{FF2B5EF4-FFF2-40B4-BE49-F238E27FC236}">
-                <a16:creationId xmlns:a16="http://schemas.microsoft.com/office/drawing/2014/main" id="{881B2B8F-1C60-46CF-8A90-8286E9C7ED69}"/>
+                <a16:creationId xmlns:a16="http://schemas.microsoft.com/office/drawing/2014/main" id="{E2E47F27-9E7A-458B-8CE7-007823E3E871}"/>
               </a:ext>
             </a:extLst>
           </p:cNvPr>
@@ -45898,7 +45898,7 @@
           <p:cNvPr id="4" name="">
             <a:extLst xmlns:a="http://schemas.openxmlformats.org/drawingml/2006/main">
               <a:ext uri="{FF2B5EF4-FFF2-40B4-BE49-F238E27FC236}">
-                <a16:creationId xmlns:a16="http://schemas.microsoft.com/office/drawing/2014/main" id="{4E4E96AD-5D0B-4CCC-BC74-DFCC5D20E1B5}"/>
+                <a16:creationId xmlns:a16="http://schemas.microsoft.com/office/drawing/2014/main" id="{5993F610-6893-4E9F-B3A3-F292C6AC579C}"/>
               </a:ext>
             </a:extLst>
           </p:cNvPr>
@@ -45929,7 +45929,7 @@
           <p:cNvPr id="5" name="">
             <a:extLst xmlns:a="http://schemas.openxmlformats.org/drawingml/2006/main">
               <a:ext uri="{FF2B5EF4-FFF2-40B4-BE49-F238E27FC236}">
-                <a16:creationId xmlns:a16="http://schemas.microsoft.com/office/drawing/2014/main" id="{7DBCC41D-6C41-49A2-A66A-529FEEF5BC2F}"/>
+                <a16:creationId xmlns:a16="http://schemas.microsoft.com/office/drawing/2014/main" id="{C11C1481-9E27-473B-8FC2-23B637D6A90A}"/>
               </a:ext>
             </a:extLst>
           </p:cNvPr>
@@ -46050,7 +46050,7 @@
           <p:cNvPr id="6" name="">
             <a:extLst xmlns:a="http://schemas.openxmlformats.org/drawingml/2006/main">
               <a:ext uri="{FF2B5EF4-FFF2-40B4-BE49-F238E27FC236}">
-                <a16:creationId xmlns:a16="http://schemas.microsoft.com/office/drawing/2014/main" id="{140603C3-DA11-4C65-A3EF-25CCA793F8B9}"/>
+                <a16:creationId xmlns:a16="http://schemas.microsoft.com/office/drawing/2014/main" id="{545E971F-2960-4D9E-B481-ED9D4DECE031}"/>
               </a:ext>
             </a:extLst>
           </p:cNvPr>
@@ -46171,7 +46171,7 @@
           <p:cNvPr id="7" name="">
             <a:extLst xmlns:a="http://schemas.openxmlformats.org/drawingml/2006/main">
               <a:ext uri="{FF2B5EF4-FFF2-40B4-BE49-F238E27FC236}">
-                <a16:creationId xmlns:a16="http://schemas.microsoft.com/office/drawing/2014/main" id="{7E20107F-A816-4700-BE04-4235C938FF57}"/>
+                <a16:creationId xmlns:a16="http://schemas.microsoft.com/office/drawing/2014/main" id="{FC54EF67-7F4B-4D11-B601-A6A8E6AF8256}"/>
               </a:ext>
             </a:extLst>
           </p:cNvPr>
@@ -46292,7 +46292,7 @@
           <p:cNvPr id="8" name="">
             <a:extLst xmlns:a="http://schemas.openxmlformats.org/drawingml/2006/main">
               <a:ext uri="{FF2B5EF4-FFF2-40B4-BE49-F238E27FC236}">
-                <a16:creationId xmlns:a16="http://schemas.microsoft.com/office/drawing/2014/main" id="{0311A550-7453-4CD9-9B9F-D28167F0C461}"/>
+                <a16:creationId xmlns:a16="http://schemas.microsoft.com/office/drawing/2014/main" id="{4DB55828-6046-464B-B941-4119DDD33D4B}"/>
               </a:ext>
             </a:extLst>
           </p:cNvPr>
@@ -46413,7 +46413,7 @@
           <p:cNvPr id="9" name="">
             <a:extLst xmlns:a="http://schemas.openxmlformats.org/drawingml/2006/main">
               <a:ext uri="{FF2B5EF4-FFF2-40B4-BE49-F238E27FC236}">
-                <a16:creationId xmlns:a16="http://schemas.microsoft.com/office/drawing/2014/main" id="{53E0AAD6-3121-44D2-82D2-B716BA3CD64E}"/>
+                <a16:creationId xmlns:a16="http://schemas.microsoft.com/office/drawing/2014/main" id="{1CFDA4D0-61CF-46A6-9A40-61B285AB35A0}"/>
               </a:ext>
             </a:extLst>
           </p:cNvPr>
@@ -46534,7 +46534,7 @@
           <p:cNvPr id="10" name="">
             <a:extLst xmlns:a="http://schemas.openxmlformats.org/drawingml/2006/main">
               <a:ext uri="{FF2B5EF4-FFF2-40B4-BE49-F238E27FC236}">
-                <a16:creationId xmlns:a16="http://schemas.microsoft.com/office/drawing/2014/main" id="{C169902E-85C6-4CB2-A4AC-ADB2C46242A8}"/>
+                <a16:creationId xmlns:a16="http://schemas.microsoft.com/office/drawing/2014/main" id="{7ED90710-1E2B-4B5C-833B-D6F5A1847F07}"/>
               </a:ext>
             </a:extLst>
           </p:cNvPr>
@@ -46565,7 +46565,7 @@
           <p:cNvPr id="11" name="">
             <a:extLst xmlns:a="http://schemas.openxmlformats.org/drawingml/2006/main">
               <a:ext uri="{FF2B5EF4-FFF2-40B4-BE49-F238E27FC236}">
-                <a16:creationId xmlns:a16="http://schemas.microsoft.com/office/drawing/2014/main" id="{29F28FE9-BDE0-44E8-ACB2-8C3BFB34D9D5}"/>
+                <a16:creationId xmlns:a16="http://schemas.microsoft.com/office/drawing/2014/main" id="{600CDD4D-9AB3-42AC-8036-05D3ADCE76B8}"/>
               </a:ext>
             </a:extLst>
           </p:cNvPr>
@@ -46686,7 +46686,7 @@
           <p:cNvPr id="12" name="">
             <a:extLst xmlns:a="http://schemas.openxmlformats.org/drawingml/2006/main">
               <a:ext uri="{FF2B5EF4-FFF2-40B4-BE49-F238E27FC236}">
-                <a16:creationId xmlns:a16="http://schemas.microsoft.com/office/drawing/2014/main" id="{FF27BB87-AAAE-4FDC-B30F-24A9A7091560}"/>
+                <a16:creationId xmlns:a16="http://schemas.microsoft.com/office/drawing/2014/main" id="{D6535AB1-E329-41DA-B591-CC45D6F64DD2}"/>
               </a:ext>
             </a:extLst>
           </p:cNvPr>
@@ -46807,7 +46807,7 @@
           <p:cNvPr id="13" name="">
             <a:extLst xmlns:a="http://schemas.openxmlformats.org/drawingml/2006/main">
               <a:ext uri="{FF2B5EF4-FFF2-40B4-BE49-F238E27FC236}">
-                <a16:creationId xmlns:a16="http://schemas.microsoft.com/office/drawing/2014/main" id="{AAD8D910-1323-4FAA-B2FA-B0EC3BF9712A}"/>
+                <a16:creationId xmlns:a16="http://schemas.microsoft.com/office/drawing/2014/main" id="{858459C8-B22D-43C5-A1F7-6DD54409167C}"/>
               </a:ext>
             </a:extLst>
           </p:cNvPr>
@@ -46838,7 +46838,7 @@
           <p:cNvPr id="14" name="">
             <a:extLst xmlns:a="http://schemas.openxmlformats.org/drawingml/2006/main">
               <a:ext uri="{FF2B5EF4-FFF2-40B4-BE49-F238E27FC236}">
-                <a16:creationId xmlns:a16="http://schemas.microsoft.com/office/drawing/2014/main" id="{94864A7F-EDAD-4432-9EA0-F253726EF780}"/>
+                <a16:creationId xmlns:a16="http://schemas.microsoft.com/office/drawing/2014/main" id="{DF384193-2EDE-4D8C-91FB-A4425FF349EA}"/>
               </a:ext>
             </a:extLst>
           </p:cNvPr>
@@ -46959,7 +46959,7 @@
           <p:cNvPr id="15" name="">
             <a:extLst xmlns:a="http://schemas.openxmlformats.org/drawingml/2006/main">
               <a:ext uri="{FF2B5EF4-FFF2-40B4-BE49-F238E27FC236}">
-                <a16:creationId xmlns:a16="http://schemas.microsoft.com/office/drawing/2014/main" id="{D59F98FC-CD59-4F08-A079-19974BF1DD97}"/>
+                <a16:creationId xmlns:a16="http://schemas.microsoft.com/office/drawing/2014/main" id="{A649B78F-BA6C-43F1-AF27-91070EC4BA7D}"/>
               </a:ext>
             </a:extLst>
           </p:cNvPr>
@@ -47080,7 +47080,7 @@
           <p:cNvPr id="16" name="">
             <a:extLst xmlns:a="http://schemas.openxmlformats.org/drawingml/2006/main">
               <a:ext uri="{FF2B5EF4-FFF2-40B4-BE49-F238E27FC236}">
-                <a16:creationId xmlns:a16="http://schemas.microsoft.com/office/drawing/2014/main" id="{492D2BB4-C585-4CD1-AE47-383656F484AC}"/>
+                <a16:creationId xmlns:a16="http://schemas.microsoft.com/office/drawing/2014/main" id="{252AF0B1-4B4A-4E64-A5B7-6ED78503C57A}"/>
               </a:ext>
             </a:extLst>
           </p:cNvPr>
@@ -47111,7 +47111,7 @@
           <p:cNvPr id="17" name="">
             <a:extLst xmlns:a="http://schemas.openxmlformats.org/drawingml/2006/main">
               <a:ext uri="{FF2B5EF4-FFF2-40B4-BE49-F238E27FC236}">
-                <a16:creationId xmlns:a16="http://schemas.microsoft.com/office/drawing/2014/main" id="{8B32066C-F97E-42ED-98ED-246A712CE08A}"/>
+                <a16:creationId xmlns:a16="http://schemas.microsoft.com/office/drawing/2014/main" id="{A7E32C87-90E7-4FC5-90A1-832EE14CE886}"/>
               </a:ext>
             </a:extLst>
           </p:cNvPr>
@@ -47232,7 +47232,7 @@
           <p:cNvPr id="18" name="">
             <a:extLst xmlns:a="http://schemas.openxmlformats.org/drawingml/2006/main">
               <a:ext uri="{FF2B5EF4-FFF2-40B4-BE49-F238E27FC236}">
-                <a16:creationId xmlns:a16="http://schemas.microsoft.com/office/drawing/2014/main" id="{8B3E57CB-D9D7-4768-A452-E348DFFEE142}"/>
+                <a16:creationId xmlns:a16="http://schemas.microsoft.com/office/drawing/2014/main" id="{FBF53D28-C85D-46D2-9C19-8B6C12867CDE}"/>
               </a:ext>
             </a:extLst>
           </p:cNvPr>
@@ -47353,7 +47353,7 @@
           <p:cNvPr id="19" name="">
             <a:extLst xmlns:a="http://schemas.openxmlformats.org/drawingml/2006/main">
               <a:ext uri="{FF2B5EF4-FFF2-40B4-BE49-F238E27FC236}">
-                <a16:creationId xmlns:a16="http://schemas.microsoft.com/office/drawing/2014/main" id="{05AA7C61-24A0-4462-A5C9-7B632FF32881}"/>
+                <a16:creationId xmlns:a16="http://schemas.microsoft.com/office/drawing/2014/main" id="{CD9786E3-ECA4-4526-A091-C8C1AC0E5398}"/>
               </a:ext>
             </a:extLst>
           </p:cNvPr>
@@ -47384,7 +47384,7 @@
           <p:cNvPr id="20" name="">
             <a:extLst xmlns:a="http://schemas.openxmlformats.org/drawingml/2006/main">
               <a:ext uri="{FF2B5EF4-FFF2-40B4-BE49-F238E27FC236}">
-                <a16:creationId xmlns:a16="http://schemas.microsoft.com/office/drawing/2014/main" id="{FE35861B-1562-4ABC-9EE2-A7DCDF28D6DB}"/>
+                <a16:creationId xmlns:a16="http://schemas.microsoft.com/office/drawing/2014/main" id="{C498072A-E070-4230-A40B-8BC2FCED6193}"/>
               </a:ext>
             </a:extLst>
           </p:cNvPr>
@@ -47505,7 +47505,7 @@
           <p:cNvPr id="21" name="">
             <a:extLst xmlns:a="http://schemas.openxmlformats.org/drawingml/2006/main">
               <a:ext uri="{FF2B5EF4-FFF2-40B4-BE49-F238E27FC236}">
-                <a16:creationId xmlns:a16="http://schemas.microsoft.com/office/drawing/2014/main" id="{2A7BC23F-4B67-44C1-91A6-E43C472C8525}"/>
+                <a16:creationId xmlns:a16="http://schemas.microsoft.com/office/drawing/2014/main" id="{3E871E51-5000-4FC6-8587-D4B1A77E1AA9}"/>
               </a:ext>
             </a:extLst>
           </p:cNvPr>
@@ -47626,7 +47626,7 @@
           <p:cNvPr id="22" name="">
             <a:extLst xmlns:a="http://schemas.openxmlformats.org/drawingml/2006/main">
               <a:ext uri="{FF2B5EF4-FFF2-40B4-BE49-F238E27FC236}">
-                <a16:creationId xmlns:a16="http://schemas.microsoft.com/office/drawing/2014/main" id="{ECCE3F3A-254D-4C6A-B4FC-D90155B36488}"/>
+                <a16:creationId xmlns:a16="http://schemas.microsoft.com/office/drawing/2014/main" id="{747D7266-7558-4D13-AC5B-CF19762E73A0}"/>
               </a:ext>
             </a:extLst>
           </p:cNvPr>
@@ -47657,7 +47657,7 @@
           <p:cNvPr id="23" name="">
             <a:extLst xmlns:a="http://schemas.openxmlformats.org/drawingml/2006/main">
               <a:ext uri="{FF2B5EF4-FFF2-40B4-BE49-F238E27FC236}">
-                <a16:creationId xmlns:a16="http://schemas.microsoft.com/office/drawing/2014/main" id="{961F094A-A943-44CF-A8BD-27ED8C7ADB6D}"/>
+                <a16:creationId xmlns:a16="http://schemas.microsoft.com/office/drawing/2014/main" id="{51808D86-EB1D-4379-948A-2FC26C35B580}"/>
               </a:ext>
             </a:extLst>
           </p:cNvPr>
@@ -47778,7 +47778,7 @@
           <p:cNvPr id="24" name="">
             <a:extLst xmlns:a="http://schemas.openxmlformats.org/drawingml/2006/main">
               <a:ext uri="{FF2B5EF4-FFF2-40B4-BE49-F238E27FC236}">
-                <a16:creationId xmlns:a16="http://schemas.microsoft.com/office/drawing/2014/main" id="{8AF8B78E-AB53-472C-86E1-97ADCE116DD4}"/>
+                <a16:creationId xmlns:a16="http://schemas.microsoft.com/office/drawing/2014/main" id="{F7218A80-3224-41EA-BEFB-EC3141BD7932}"/>
               </a:ext>
             </a:extLst>
           </p:cNvPr>
@@ -47899,7 +47899,7 @@
           <p:cNvPr id="25" name="">
             <a:extLst xmlns:a="http://schemas.openxmlformats.org/drawingml/2006/main">
               <a:ext uri="{FF2B5EF4-FFF2-40B4-BE49-F238E27FC236}">
-                <a16:creationId xmlns:a16="http://schemas.microsoft.com/office/drawing/2014/main" id="{CCF7CD83-99CA-492E-8EF2-3B5024BF5B7D}"/>
+                <a16:creationId xmlns:a16="http://schemas.microsoft.com/office/drawing/2014/main" id="{AA914BBF-3F87-4F46-95AF-344D4786BA6E}"/>
               </a:ext>
             </a:extLst>
           </p:cNvPr>
@@ -47930,7 +47930,7 @@
           <p:cNvPr id="26" name="">
             <a:extLst xmlns:a="http://schemas.openxmlformats.org/drawingml/2006/main">
               <a:ext uri="{FF2B5EF4-FFF2-40B4-BE49-F238E27FC236}">
-                <a16:creationId xmlns:a16="http://schemas.microsoft.com/office/drawing/2014/main" id="{840F1832-08C6-4D43-B70E-6494803B888E}"/>
+                <a16:creationId xmlns:a16="http://schemas.microsoft.com/office/drawing/2014/main" id="{DFFBF1FC-0CA5-41A7-99E2-7A16B11971B8}"/>
               </a:ext>
             </a:extLst>
           </p:cNvPr>
@@ -48041,7 +48041,7 @@
                   <a:srgbClr val="38D6C4"/>
                 </a:solidFill>
               </a:rPr>
-              <a:t>판정 = 관련 능력치 2~3개 + 장비 + 정보 + 현재 상태</a:t>
+              <a:t>판정 = 관련 능력치 2~3개 + 장비 + 정보 + 신체·정신 상태</a:t>
             </a:r>
           </a:p>
         </p:txBody>
@@ -48049,7 +48049,7 @@
     </p:spTree>
     <p:extLst>
       <p:ext uri="{BB962C8B-B14F-4D97-AF65-F5344CB8AC3E}">
-        <p14:creationId xmlns:p14="http://schemas.microsoft.com/office/powerpoint/2010/main" val="1979046726"/>
+        <p14:creationId xmlns:p14="http://schemas.microsoft.com/office/powerpoint/2010/main" val="1565278286"/>
       </p:ext>
     </p:extLst>
   </p:cSld>
@@ -48080,7 +48080,7 @@
           <p:cNvPr id="21" name="">
             <a:extLst xmlns:a="http://schemas.openxmlformats.org/drawingml/2006/main">
               <a:ext uri="{FF2B5EF4-FFF2-40B4-BE49-F238E27FC236}">
-                <a16:creationId xmlns:a16="http://schemas.microsoft.com/office/drawing/2014/main" id="{FBA288EC-1EAB-4BD2-9B2E-0C3D31188C8D}"/>
+                <a16:creationId xmlns:a16="http://schemas.microsoft.com/office/drawing/2014/main" id="{A43B2D14-4C83-4396-AD43-FA669E2E992A}"/>
               </a:ext>
             </a:extLst>
           </p:cNvPr>
@@ -48111,7 +48111,7 @@
           <p:cNvPr id="2" name="">
             <a:extLst xmlns:a="http://schemas.openxmlformats.org/drawingml/2006/main">
               <a:ext uri="{FF2B5EF4-FFF2-40B4-BE49-F238E27FC236}">
-                <a16:creationId xmlns:a16="http://schemas.microsoft.com/office/drawing/2014/main" id="{3B1FF23F-C180-4E23-B4FA-DB767083DE1D}"/>
+                <a16:creationId xmlns:a16="http://schemas.microsoft.com/office/drawing/2014/main" id="{C3130A0A-82A7-45C5-AE74-205C76E24CCE}"/>
               </a:ext>
             </a:extLst>
           </p:cNvPr>
@@ -48232,7 +48232,7 @@
           <p:cNvPr id="3" name="">
             <a:extLst xmlns:a="http://schemas.openxmlformats.org/drawingml/2006/main">
               <a:ext uri="{FF2B5EF4-FFF2-40B4-BE49-F238E27FC236}">
-                <a16:creationId xmlns:a16="http://schemas.microsoft.com/office/drawing/2014/main" id="{D5F6FBD0-9BEC-4499-8228-2EC6C0DDED42}"/>
+                <a16:creationId xmlns:a16="http://schemas.microsoft.com/office/drawing/2014/main" id="{649FEEA5-EEA4-45C3-86B1-16C161A6199F}"/>
               </a:ext>
             </a:extLst>
           </p:cNvPr>
@@ -48353,7 +48353,7 @@
           <p:cNvPr id="4" name="">
             <a:extLst xmlns:a="http://schemas.openxmlformats.org/drawingml/2006/main">
               <a:ext uri="{FF2B5EF4-FFF2-40B4-BE49-F238E27FC236}">
-                <a16:creationId xmlns:a16="http://schemas.microsoft.com/office/drawing/2014/main" id="{C25C8979-3C83-494E-858A-9BE893350997}"/>
+                <a16:creationId xmlns:a16="http://schemas.microsoft.com/office/drawing/2014/main" id="{7EE249D7-CD7A-4791-A27E-327576C5FCA5}"/>
               </a:ext>
             </a:extLst>
           </p:cNvPr>
@@ -48384,7 +48384,7 @@
           <p:cNvPr id="5" name="">
             <a:extLst xmlns:a="http://schemas.openxmlformats.org/drawingml/2006/main">
               <a:ext uri="{FF2B5EF4-FFF2-40B4-BE49-F238E27FC236}">
-                <a16:creationId xmlns:a16="http://schemas.microsoft.com/office/drawing/2014/main" id="{CEB5931A-7CAD-4362-9F8D-97E141EC018B}"/>
+                <a16:creationId xmlns:a16="http://schemas.microsoft.com/office/drawing/2014/main" id="{CD086B0B-0F4C-4D18-AA67-FED09F875C87}"/>
               </a:ext>
             </a:extLst>
           </p:cNvPr>
@@ -48505,7 +48505,7 @@
           <p:cNvPr id="6" name="">
             <a:extLst xmlns:a="http://schemas.openxmlformats.org/drawingml/2006/main">
               <a:ext uri="{FF2B5EF4-FFF2-40B4-BE49-F238E27FC236}">
-                <a16:creationId xmlns:a16="http://schemas.microsoft.com/office/drawing/2014/main" id="{43B50B6D-2F04-4922-94AB-E81BBA1D3A03}"/>
+                <a16:creationId xmlns:a16="http://schemas.microsoft.com/office/drawing/2014/main" id="{4EA1A515-C7A9-471C-94E7-369C6D6EA482}"/>
               </a:ext>
             </a:extLst>
           </p:cNvPr>
@@ -48626,7 +48626,7 @@
           <p:cNvPr id="7" name="">
             <a:extLst xmlns:a="http://schemas.openxmlformats.org/drawingml/2006/main">
               <a:ext uri="{FF2B5EF4-FFF2-40B4-BE49-F238E27FC236}">
-                <a16:creationId xmlns:a16="http://schemas.microsoft.com/office/drawing/2014/main" id="{B599BACC-6571-4333-B549-642218DE0732}"/>
+                <a16:creationId xmlns:a16="http://schemas.microsoft.com/office/drawing/2014/main" id="{225AA43A-1809-4348-975B-F6DDA247E433}"/>
               </a:ext>
             </a:extLst>
           </p:cNvPr>
@@ -48747,7 +48747,7 @@
           <p:cNvPr id="8" name="">
             <a:extLst xmlns:a="http://schemas.openxmlformats.org/drawingml/2006/main">
               <a:ext uri="{FF2B5EF4-FFF2-40B4-BE49-F238E27FC236}">
-                <a16:creationId xmlns:a16="http://schemas.microsoft.com/office/drawing/2014/main" id="{614A9BB7-3D08-4C62-AAB8-32E734DCFD3C}"/>
+                <a16:creationId xmlns:a16="http://schemas.microsoft.com/office/drawing/2014/main" id="{70326BAA-BBE9-4004-A132-FFA6E11D36FE}"/>
               </a:ext>
             </a:extLst>
           </p:cNvPr>
@@ -48868,7 +48868,7 @@
           <p:cNvPr id="9" name="">
             <a:extLst xmlns:a="http://schemas.openxmlformats.org/drawingml/2006/main">
               <a:ext uri="{FF2B5EF4-FFF2-40B4-BE49-F238E27FC236}">
-                <a16:creationId xmlns:a16="http://schemas.microsoft.com/office/drawing/2014/main" id="{7901B540-6BB9-45BF-A9E2-B08721B33DBC}"/>
+                <a16:creationId xmlns:a16="http://schemas.microsoft.com/office/drawing/2014/main" id="{660BD1B9-E185-4C07-872E-F304A9D514A5}"/>
               </a:ext>
             </a:extLst>
           </p:cNvPr>
@@ -48989,7 +48989,7 @@
           <p:cNvPr id="10" name="">
             <a:extLst xmlns:a="http://schemas.openxmlformats.org/drawingml/2006/main">
               <a:ext uri="{FF2B5EF4-FFF2-40B4-BE49-F238E27FC236}">
-                <a16:creationId xmlns:a16="http://schemas.microsoft.com/office/drawing/2014/main" id="{3CA055E2-D37D-4633-89E4-94CF7B82E19A}"/>
+                <a16:creationId xmlns:a16="http://schemas.microsoft.com/office/drawing/2014/main" id="{81A94C2E-F3B2-46D7-AB01-BD90FEC8420D}"/>
               </a:ext>
             </a:extLst>
           </p:cNvPr>
@@ -49020,7 +49020,7 @@
           <p:cNvPr id="11" name="">
             <a:extLst xmlns:a="http://schemas.openxmlformats.org/drawingml/2006/main">
               <a:ext uri="{FF2B5EF4-FFF2-40B4-BE49-F238E27FC236}">
-                <a16:creationId xmlns:a16="http://schemas.microsoft.com/office/drawing/2014/main" id="{0B2C724D-7720-415C-BDCA-2D6CA28A890E}"/>
+                <a16:creationId xmlns:a16="http://schemas.microsoft.com/office/drawing/2014/main" id="{9D22DF37-CA43-46DF-9876-E552E44E9679}"/>
               </a:ext>
             </a:extLst>
           </p:cNvPr>
@@ -49141,7 +49141,7 @@
           <p:cNvPr id="12" name="">
             <a:extLst xmlns:a="http://schemas.openxmlformats.org/drawingml/2006/main">
               <a:ext uri="{FF2B5EF4-FFF2-40B4-BE49-F238E27FC236}">
-                <a16:creationId xmlns:a16="http://schemas.microsoft.com/office/drawing/2014/main" id="{4D5FE194-CA63-40BD-940E-641DE8918C8B}"/>
+                <a16:creationId xmlns:a16="http://schemas.microsoft.com/office/drawing/2014/main" id="{44E195A7-3E48-4646-9F7A-97EF3DA423F1}"/>
               </a:ext>
             </a:extLst>
           </p:cNvPr>
@@ -49262,7 +49262,7 @@
           <p:cNvPr id="13" name="">
             <a:extLst xmlns:a="http://schemas.openxmlformats.org/drawingml/2006/main">
               <a:ext uri="{FF2B5EF4-FFF2-40B4-BE49-F238E27FC236}">
-                <a16:creationId xmlns:a16="http://schemas.microsoft.com/office/drawing/2014/main" id="{9229AB39-BBF1-4A26-83FA-F39B230A6764}"/>
+                <a16:creationId xmlns:a16="http://schemas.microsoft.com/office/drawing/2014/main" id="{9D4D3178-02A5-4C8A-9117-65BA556CCA07}"/>
               </a:ext>
             </a:extLst>
           </p:cNvPr>
@@ -49293,7 +49293,7 @@
           <p:cNvPr id="14" name="">
             <a:extLst xmlns:a="http://schemas.openxmlformats.org/drawingml/2006/main">
               <a:ext uri="{FF2B5EF4-FFF2-40B4-BE49-F238E27FC236}">
-                <a16:creationId xmlns:a16="http://schemas.microsoft.com/office/drawing/2014/main" id="{7F645FDC-D283-4374-AE2C-BAADD81C08B1}"/>
+                <a16:creationId xmlns:a16="http://schemas.microsoft.com/office/drawing/2014/main" id="{2A86F2F3-C9AD-4A09-9E7E-04FC2E3E2405}"/>
               </a:ext>
             </a:extLst>
           </p:cNvPr>
@@ -49414,7 +49414,7 @@
           <p:cNvPr id="15" name="">
             <a:extLst xmlns:a="http://schemas.openxmlformats.org/drawingml/2006/main">
               <a:ext uri="{FF2B5EF4-FFF2-40B4-BE49-F238E27FC236}">
-                <a16:creationId xmlns:a16="http://schemas.microsoft.com/office/drawing/2014/main" id="{CDF0474E-0492-4585-8DCC-C1A2F081F4DE}"/>
+                <a16:creationId xmlns:a16="http://schemas.microsoft.com/office/drawing/2014/main" id="{408E08B2-64EB-4D0C-98B2-4EFDEA0AFAE5}"/>
               </a:ext>
             </a:extLst>
           </p:cNvPr>
@@ -49535,7 +49535,7 @@
           <p:cNvPr id="16" name="">
             <a:extLst xmlns:a="http://schemas.openxmlformats.org/drawingml/2006/main">
               <a:ext uri="{FF2B5EF4-FFF2-40B4-BE49-F238E27FC236}">
-                <a16:creationId xmlns:a16="http://schemas.microsoft.com/office/drawing/2014/main" id="{6C52D754-3FBE-4665-BDC3-B38F6DEF68B1}"/>
+                <a16:creationId xmlns:a16="http://schemas.microsoft.com/office/drawing/2014/main" id="{A04CD556-6835-48E5-AFF0-F2F5FC11D197}"/>
               </a:ext>
             </a:extLst>
           </p:cNvPr>
@@ -49566,7 +49566,7 @@
           <p:cNvPr id="17" name="">
             <a:extLst xmlns:a="http://schemas.openxmlformats.org/drawingml/2006/main">
               <a:ext uri="{FF2B5EF4-FFF2-40B4-BE49-F238E27FC236}">
-                <a16:creationId xmlns:a16="http://schemas.microsoft.com/office/drawing/2014/main" id="{4863AC88-E769-4E7A-8F4F-BF5783CCB8DF}"/>
+                <a16:creationId xmlns:a16="http://schemas.microsoft.com/office/drawing/2014/main" id="{DDE3A004-44C2-425A-A13E-37BABA6A742B}"/>
               </a:ext>
             </a:extLst>
           </p:cNvPr>
@@ -49687,7 +49687,7 @@
           <p:cNvPr id="18" name="">
             <a:extLst xmlns:a="http://schemas.openxmlformats.org/drawingml/2006/main">
               <a:ext uri="{FF2B5EF4-FFF2-40B4-BE49-F238E27FC236}">
-                <a16:creationId xmlns:a16="http://schemas.microsoft.com/office/drawing/2014/main" id="{069ABF3E-715B-470F-9A79-56249BFD0F12}"/>
+                <a16:creationId xmlns:a16="http://schemas.microsoft.com/office/drawing/2014/main" id="{41504FF7-BBE1-446E-B031-26F812417895}"/>
               </a:ext>
             </a:extLst>
           </p:cNvPr>
@@ -49808,7 +49808,7 @@
           <p:cNvPr id="19" name="">
             <a:extLst xmlns:a="http://schemas.openxmlformats.org/drawingml/2006/main">
               <a:ext uri="{FF2B5EF4-FFF2-40B4-BE49-F238E27FC236}">
-                <a16:creationId xmlns:a16="http://schemas.microsoft.com/office/drawing/2014/main" id="{F54ACBA6-26E8-4FB3-885E-2F9EFE2D8B4C}"/>
+                <a16:creationId xmlns:a16="http://schemas.microsoft.com/office/drawing/2014/main" id="{F17A4B1C-E799-42D1-A9BA-0F1A4470C8F4}"/>
               </a:ext>
             </a:extLst>
           </p:cNvPr>
@@ -49839,7 +49839,7 @@
           <p:cNvPr id="20" name="">
             <a:extLst xmlns:a="http://schemas.openxmlformats.org/drawingml/2006/main">
               <a:ext uri="{FF2B5EF4-FFF2-40B4-BE49-F238E27FC236}">
-                <a16:creationId xmlns:a16="http://schemas.microsoft.com/office/drawing/2014/main" id="{D3725DAB-0400-4A82-8E44-2A8BA9D9F7F6}"/>
+                <a16:creationId xmlns:a16="http://schemas.microsoft.com/office/drawing/2014/main" id="{45249429-F555-432B-A5ED-FD3035A071C4}"/>
               </a:ext>
             </a:extLst>
           </p:cNvPr>
@@ -49958,7 +49958,7 @@
     </p:spTree>
     <p:extLst>
       <p:ext uri="{BB962C8B-B14F-4D97-AF65-F5344CB8AC3E}">
-        <p14:creationId xmlns:p14="http://schemas.microsoft.com/office/powerpoint/2010/main" val="426570119"/>
+        <p14:creationId xmlns:p14="http://schemas.microsoft.com/office/powerpoint/2010/main" val="301406489"/>
       </p:ext>
     </p:extLst>
   </p:cSld>

</xml_diff>